<commit_message>
Fix AMA citation placement, add DOIs and recent references, fill confirmed declarations, add separate AMA reference list
Co-Authored-By: Claude Opus 5.5 <noreply@anthropic.com>
Claude-Session: https://claude.ai/code/session_01N468nYR7vy45HpujgUezn5
</commit_message>
<xml_diff>
--- a/poster/MRKH_APHA2026_Poster.pptx
+++ b/poster/MRKH_APHA2026_Poster.pptx
@@ -7319,7 +7319,7 @@
                           </a:solidFill>
                           <a:latin typeface="Times New Roman"/>
                         </a:rPr>
-                        <a:t>Scoping review following Arksey &amp; O'Malley's five-stage framework;</a:t>
+                        <a:t>Scoping review following Arksey &amp; O'Malley's five-stage framework</a:t>
                       </a:r>
                       <a:r>
                         <a:rPr sz="2000" b="0" i="0" baseline="30000">
@@ -7337,7 +7337,7 @@
                           </a:solidFill>
                           <a:latin typeface="Times New Roman"/>
                         </a:rPr>
-                        <a:t> reported per PRISMA-ScR</a:t>
+                        <a:t>; reported per PRISMA-ScR</a:t>
                       </a:r>
                       <a:r>
                         <a:rPr sz="2000" b="0" i="0" baseline="30000">

</xml_diff>

<commit_message>
Report databases, search date, per-database counts and date-limit handling from search exports
Co-Authored-By: Claude Opus 5.5 <noreply@anthropic.com>
Claude-Session: https://claude.ai/code/session_01N468nYR7vy45HpujgUezn5
</commit_message>
<xml_diff>
--- a/poster/MRKH_APHA2026_Poster.pptx
+++ b/poster/MRKH_APHA2026_Poster.pptx
@@ -7392,7 +7392,7 @@
                           </a:solidFill>
                           <a:latin typeface="Times New Roman"/>
                         </a:rPr>
-                        <a:t>PubMed/MEDLINE, Scopus, PsycINFO, and CINAHL</a:t>
+                        <a:t>PubMed; Scopus; EBSCOhost (MEDLINE, CINAHL, APA PsycInfo, Women's Studies International)</a:t>
                       </a:r>
                     </a:p>
                   </a:txBody>
@@ -7416,7 +7416,7 @@
                           </a:solidFill>
                           <a:latin typeface="Times New Roman"/>
                         </a:rPr>
-                        <a:t>Years Searched</a:t>
+                        <a:t>Years Included</a:t>
                       </a:r>
                     </a:p>
                   </a:txBody>
@@ -7438,7 +7438,7 @@
                           </a:solidFill>
                           <a:latin typeface="Times New Roman"/>
                         </a:rPr>
-                        <a:t>January 2019 – March 2026</a:t>
+                        <a:t>January 2019 – March 2026 (earlier records removed at screening); searches run March 29, 2026</a:t>
                       </a:r>
                     </a:p>
                   </a:txBody>

</xml_diff>

<commit_message>
Rebuild results from re-screened records: provisional includes, abstract-level extraction, cited included studies
Co-Authored-By: Claude Opus 5.5 <noreply@anthropic.com>
Claude-Session: https://claude.ai/code/session_01N468nYR7vy45HpujgUezn5
</commit_message>
<xml_diff>
--- a/poster/MRKH_APHA2026_Poster.pptx
+++ b/poster/MRKH_APHA2026_Poster.pptx
@@ -6740,7 +6740,7 @@
         <p:spPr>
           <a:xfrm>
             <a:off x="502920" y="7223760"/>
-            <a:ext cx="10287000" cy="7635240"/>
+            <a:ext cx="10287000" cy="8321040"/>
           </a:xfrm>
           <a:prstGeom prst="rect">
             <a:avLst/>
@@ -6812,7 +6812,7 @@
                 </a:solidFill>
                 <a:latin typeface="Times New Roman"/>
               </a:rPr>
-              <a:t> Following Arksey and O'Malley's framework and PRISMA-ScR guidelines, we searched PubMed/MEDLINE, Scopus, PsycINFO, and CINAHL (January 2019–March 2026). Eligible studies included primary quantitative, qualitative, and mixed-methods research on psychological outcomes and/or coping mechanisms in MRKH populations.</a:t>
+              <a:t> Following Arksey and O'Malley's framework and PRISMA-ScR guidelines, we searched PubMed, Scopus, and EBSCOhost databases (January 2019–March 2026). Eligible studies included primary quantitative, qualitative, and mixed-methods research on psychological outcomes and/or coping mechanisms in MRKH populations.</a:t>
             </a:r>
           </a:p>
           <a:p>
@@ -6840,7 +6840,16 @@
                 </a:solidFill>
                 <a:latin typeface="Times New Roman"/>
               </a:rPr>
-              <a:t> 34 studies met inclusion criteria. Depression and anxiety were most frequently reported (n = 26), followed by reduced QoL and body image concerns (n = 22), psychosexual challenges (n = 19), and psychological distress (n = 17). Coping mechanisms were documented in 21 studies; healthcare gaps in 18.</a:t>
+              <a:t> 34 studies met inclusion criteria (provisional). Psychosexual and relational challenges were most frequently reported (n = 24), followed by reduced QoL, body image and self-esteem (n = 18), broader psychological distress (n = 18), and depression and anxiety (n = 10). Coping mechanisms were documented in 14 studies; healthcare gaps in 9. </a:t>
+            </a:r>
+            <a:r>
+              <a:rPr sz="2300" b="0" i="1">
+                <a:solidFill>
+                  <a:srgbClr val="000000"/>
+                </a:solidFill>
+                <a:latin typeface="Times New Roman"/>
+              </a:rPr>
+              <a:t>Results updated from the submitted abstract after final screening.</a:t>
             </a:r>
           </a:p>
           <a:p>
@@ -6909,7 +6918,7 @@
         </p:nvSpPr>
         <p:spPr>
           <a:xfrm>
-            <a:off x="502920" y="15087600"/>
+            <a:off x="502920" y="15773400"/>
             <a:ext cx="10287000" cy="868680"/>
           </a:xfrm>
           <a:prstGeom prst="rect">
@@ -6958,8 +6967,8 @@
         </p:nvSpPr>
         <p:spPr>
           <a:xfrm>
-            <a:off x="502920" y="15956280"/>
-            <a:ext cx="10287000" cy="8229600"/>
+            <a:off x="502920" y="16642080"/>
+            <a:ext cx="10287000" cy="7543800"/>
           </a:xfrm>
           <a:prstGeom prst="rect">
             <a:avLst/>
@@ -7576,7 +7585,7 @@
                           </a:solidFill>
                           <a:latin typeface="Times New Roman"/>
                         </a:rPr>
-                        <a:t>516 records identified; 155 duplicates removed; 361 screened; 327 excluded; 34 included</a:t>
+                        <a:t>516 identified; 192 duplicates removed; 324 screened; 278 excluded; 46 to full text (12 pending); 34 included (provisional). AI-assisted screening; human verification in progress</a:t>
                       </a:r>
                     </a:p>
                   </a:txBody>
@@ -7622,7 +7631,7 @@
                           </a:solidFill>
                           <a:latin typeface="Times New Roman"/>
                         </a:rPr>
-                        <a:t>Descriptive frequency counts by outcome domain and thematic grouping of coping mechanisms and healthcare gaps</a:t>
+                        <a:t>Abstract-level data charting; frequency counts by outcome domain and thematic grouping of coping mechanisms and healthcare gaps</a:t>
                       </a:r>
                     </a:p>
                   </a:txBody>
@@ -8502,7 +8511,7 @@
                 </a:solidFill>
                 <a:latin typeface="Times New Roman"/>
               </a:rPr>
-              <a:t>Coping Mechanisms Documented (n = 21 studies)</a:t>
+              <a:t>Coping Mechanisms Documented (n = 14 studies)</a:t>
             </a:r>
           </a:p>
         </p:txBody>
@@ -8592,7 +8601,7 @@
                 </a:solidFill>
                 <a:latin typeface="Times New Roman"/>
               </a:rPr>
-              <a:t>Peer &amp; community support</a:t>
+              <a:t>Peer &amp; social support (6)</a:t>
             </a:r>
           </a:p>
         </p:txBody>
@@ -8606,6 +8615,96 @@
         <p:spPr>
           <a:xfrm>
             <a:off x="25505664" y="16969083"/>
+            <a:ext cx="3761231" cy="713232"/>
+          </a:xfrm>
+          <a:prstGeom prst="roundRect">
+            <a:avLst>
+              <a:gd name="adj" fmla="val 12000"/>
+            </a:avLst>
+          </a:prstGeom>
+          <a:solidFill>
+            <a:srgbClr val="FDEEE7"/>
+          </a:solidFill>
+          <a:ln w="19050">
+            <a:solidFill>
+              <a:srgbClr val="C44E1B"/>
+            </a:solidFill>
+          </a:ln>
+          <a:effectLst/>
+        </p:spPr>
+        <p:style>
+          <a:lnRef idx="1">
+            <a:schemeClr val="accent1"/>
+          </a:lnRef>
+          <a:fillRef idx="3">
+            <a:schemeClr val="accent1"/>
+          </a:fillRef>
+          <a:effectRef idx="2">
+            <a:schemeClr val="accent1"/>
+          </a:effectRef>
+          <a:fontRef idx="minor">
+            <a:schemeClr val="lt1"/>
+          </a:fontRef>
+        </p:style>
+        <p:txBody>
+          <a:bodyPr rtlCol="0" anchor="ctr"/>
+          <a:lstStyle/>
+          <a:p>
+            <a:pPr algn="ctr"/>
+          </a:p>
+        </p:txBody>
+      </p:sp>
+      <p:sp>
+        <p:nvSpPr>
+          <p:cNvPr id="111" name="TextBox 110"/>
+          <p:cNvSpPr txBox="1"/>
+          <p:nvPr/>
+        </p:nvSpPr>
+        <p:spPr>
+          <a:xfrm>
+            <a:off x="25505664" y="16969083"/>
+            <a:ext cx="3761231" cy="713232"/>
+          </a:xfrm>
+          <a:prstGeom prst="rect">
+            <a:avLst/>
+          </a:prstGeom>
+          <a:noFill/>
+        </p:spPr>
+        <p:txBody>
+          <a:bodyPr wrap="square" anchor="ctr" lIns="45720" rIns="45720" tIns="73152" bIns="73152">
+            <a:noAutofit/>
+          </a:bodyPr>
+          <a:lstStyle/>
+          <a:p>
+            <a:pPr algn="ctr">
+              <a:lnSpc>
+                <a:spcPct val="100000"/>
+              </a:lnSpc>
+              <a:spcAft>
+                <a:spcPts val="0"/>
+              </a:spcAft>
+            </a:pPr>
+            <a:r>
+              <a:rPr sz="2100" b="0" i="0">
+                <a:solidFill>
+                  <a:srgbClr val="C44E1B"/>
+                </a:solidFill>
+                <a:latin typeface="Times New Roman"/>
+              </a:rPr>
+              <a:t>Avoidance / concealment (4)</a:t>
+            </a:r>
+          </a:p>
+        </p:txBody>
+      </p:sp>
+      <p:sp>
+        <p:nvSpPr>
+          <p:cNvPr id="112" name="Rounded Rectangle 111"/>
+          <p:cNvSpPr/>
+          <p:nvPr/>
+        </p:nvSpPr>
+        <p:spPr>
+          <a:xfrm>
+            <a:off x="29495496" y="16969083"/>
             <a:ext cx="3761231" cy="713232"/>
           </a:xfrm>
           <a:prstGeom prst="roundRect">
@@ -8647,13 +8746,13 @@
       </p:sp>
       <p:sp>
         <p:nvSpPr>
-          <p:cNvPr id="111" name="TextBox 110"/>
+          <p:cNvPr id="113" name="TextBox 112"/>
           <p:cNvSpPr txBox="1"/>
           <p:nvPr/>
         </p:nvSpPr>
         <p:spPr>
           <a:xfrm>
-            <a:off x="25505664" y="16969083"/>
+            <a:off x="29495496" y="16969083"/>
             <a:ext cx="3761231" cy="713232"/>
           </a:xfrm>
           <a:prstGeom prst="rect">
@@ -8682,20 +8781,20 @@
                 </a:solidFill>
                 <a:latin typeface="Times New Roman"/>
               </a:rPr>
-              <a:t>Psychological counseling</a:t>
-            </a:r>
-          </a:p>
-        </p:txBody>
-      </p:sp>
-      <p:sp>
-        <p:nvSpPr>
-          <p:cNvPr id="112" name="Rounded Rectangle 111"/>
+              <a:t>Counseling / intervention (3)</a:t>
+            </a:r>
+          </a:p>
+        </p:txBody>
+      </p:sp>
+      <p:sp>
+        <p:nvSpPr>
+          <p:cNvPr id="114" name="Rounded Rectangle 113"/>
           <p:cNvSpPr/>
           <p:nvPr/>
         </p:nvSpPr>
         <p:spPr>
           <a:xfrm>
-            <a:off x="29495496" y="16969083"/>
+            <a:off x="21515832" y="17837763"/>
             <a:ext cx="3761231" cy="713232"/>
           </a:xfrm>
           <a:prstGeom prst="roundRect">
@@ -8737,13 +8836,13 @@
       </p:sp>
       <p:sp>
         <p:nvSpPr>
-          <p:cNvPr id="113" name="TextBox 112"/>
+          <p:cNvPr id="115" name="TextBox 114"/>
           <p:cNvSpPr txBox="1"/>
           <p:nvPr/>
         </p:nvSpPr>
         <p:spPr>
           <a:xfrm>
-            <a:off x="29495496" y="16969083"/>
+            <a:off x="21515832" y="17837763"/>
             <a:ext cx="3761231" cy="713232"/>
           </a:xfrm>
           <a:prstGeom prst="rect">
@@ -8772,20 +8871,20 @@
                 </a:solidFill>
                 <a:latin typeface="Times New Roman"/>
               </a:rPr>
-              <a:t>Identity reconstruction</a:t>
-            </a:r>
-          </a:p>
-        </p:txBody>
-      </p:sp>
-      <p:sp>
-        <p:nvSpPr>
-          <p:cNvPr id="114" name="Rounded Rectangle 113"/>
+              <a:t>Identity reconstruction (3)</a:t>
+            </a:r>
+          </a:p>
+        </p:txBody>
+      </p:sp>
+      <p:sp>
+        <p:nvSpPr>
+          <p:cNvPr id="116" name="Rounded Rectangle 115"/>
           <p:cNvSpPr/>
           <p:nvPr/>
         </p:nvSpPr>
         <p:spPr>
           <a:xfrm>
-            <a:off x="21515832" y="17837763"/>
+            <a:off x="25505664" y="17837763"/>
             <a:ext cx="3761231" cy="713232"/>
           </a:xfrm>
           <a:prstGeom prst="roundRect">
@@ -8827,13 +8926,13 @@
       </p:sp>
       <p:sp>
         <p:nvSpPr>
-          <p:cNvPr id="115" name="TextBox 114"/>
+          <p:cNvPr id="117" name="TextBox 116"/>
           <p:cNvSpPr txBox="1"/>
           <p:nvPr/>
         </p:nvSpPr>
         <p:spPr>
           <a:xfrm>
-            <a:off x="21515832" y="17837763"/>
+            <a:off x="25505664" y="17837763"/>
             <a:ext cx="3761231" cy="713232"/>
           </a:xfrm>
           <a:prstGeom prst="rect">
@@ -8862,20 +8961,20 @@
                 </a:solidFill>
                 <a:latin typeface="Times New Roman"/>
               </a:rPr>
-              <a:t>Spiritual coping</a:t>
-            </a:r>
-          </a:p>
-        </p:txBody>
-      </p:sp>
-      <p:sp>
-        <p:nvSpPr>
-          <p:cNvPr id="116" name="Rounded Rectangle 115"/>
+              <a:t>Spiritual coping (2)</a:t>
+            </a:r>
+          </a:p>
+        </p:txBody>
+      </p:sp>
+      <p:sp>
+        <p:nvSpPr>
+          <p:cNvPr id="118" name="Rounded Rectangle 117"/>
           <p:cNvSpPr/>
           <p:nvPr/>
         </p:nvSpPr>
         <p:spPr>
           <a:xfrm>
-            <a:off x="25505664" y="17837763"/>
+            <a:off x="29495496" y="17837763"/>
             <a:ext cx="3761231" cy="713232"/>
           </a:xfrm>
           <a:prstGeom prst="roundRect">
@@ -8917,13 +9016,13 @@
       </p:sp>
       <p:sp>
         <p:nvSpPr>
-          <p:cNvPr id="117" name="TextBox 116"/>
+          <p:cNvPr id="119" name="TextBox 118"/>
           <p:cNvSpPr txBox="1"/>
           <p:nvPr/>
         </p:nvSpPr>
         <p:spPr>
           <a:xfrm>
-            <a:off x="25505664" y="17837763"/>
+            <a:off x="29495496" y="17837763"/>
             <a:ext cx="3761231" cy="713232"/>
           </a:xfrm>
           <a:prstGeom prst="rect">
@@ -8952,20 +9051,20 @@
                 </a:solidFill>
                 <a:latin typeface="Times New Roman"/>
               </a:rPr>
-              <a:t>Adaptive acceptance</a:t>
-            </a:r>
-          </a:p>
-        </p:txBody>
-      </p:sp>
-      <p:sp>
-        <p:nvSpPr>
-          <p:cNvPr id="118" name="Rounded Rectangle 117"/>
+              <a:t>Acceptance (2)</a:t>
+            </a:r>
+          </a:p>
+        </p:txBody>
+      </p:sp>
+      <p:sp>
+        <p:nvSpPr>
+          <p:cNvPr id="120" name="Rounded Rectangle 119"/>
           <p:cNvSpPr/>
           <p:nvPr/>
         </p:nvSpPr>
         <p:spPr>
           <a:xfrm>
-            <a:off x="29495496" y="17837763"/>
+            <a:off x="21515832" y="18706443"/>
             <a:ext cx="3761231" cy="713232"/>
           </a:xfrm>
           <a:prstGeom prst="roundRect">
@@ -8974,11 +9073,11 @@
             </a:avLst>
           </a:prstGeom>
           <a:solidFill>
-            <a:srgbClr val="FDEEE7"/>
+            <a:srgbClr val="EEF4FC"/>
           </a:solidFill>
           <a:ln w="19050">
             <a:solidFill>
-              <a:srgbClr val="C44E1B"/>
+              <a:srgbClr val="2A78D6"/>
             </a:solidFill>
           </a:ln>
           <a:effectLst/>
@@ -9007,13 +9106,13 @@
       </p:sp>
       <p:sp>
         <p:nvSpPr>
-          <p:cNvPr id="119" name="TextBox 118"/>
+          <p:cNvPr id="121" name="TextBox 120"/>
           <p:cNvSpPr txBox="1"/>
           <p:nvPr/>
         </p:nvSpPr>
         <p:spPr>
           <a:xfrm>
-            <a:off x="29495496" y="17837763"/>
+            <a:off x="21515832" y="18706443"/>
             <a:ext cx="3761231" cy="713232"/>
           </a:xfrm>
           <a:prstGeom prst="rect">
@@ -9038,18 +9137,18 @@
             <a:r>
               <a:rPr sz="2100" b="0" i="0">
                 <a:solidFill>
-                  <a:srgbClr val="C44E1B"/>
+                  <a:srgbClr val="0A254E"/>
                 </a:solidFill>
                 <a:latin typeface="Times New Roman"/>
               </a:rPr>
-              <a:t>Avoidance (maladaptive)</a:t>
+              <a:t>Self-advocacy (1)</a:t>
             </a:r>
           </a:p>
         </p:txBody>
       </p:sp>
       <p:pic>
         <p:nvPicPr>
-          <p:cNvPr id="120" name="Picture 119" descr="fig3_geographic_map.png"/>
+          <p:cNvPr id="122" name="Picture 121" descr="fig3_geographic_map.png"/>
           <p:cNvPicPr>
             <a:picLocks noChangeAspect="1"/>
           </p:cNvPicPr>
@@ -9063,7 +9162,7 @@
         </p:blipFill>
         <p:spPr>
           <a:xfrm>
-            <a:off x="11548872" y="20644679"/>
+            <a:off x="11548872" y="21038163"/>
             <a:ext cx="14264640" cy="7310627"/>
           </a:xfrm>
           <a:prstGeom prst="rect">
@@ -9073,13 +9172,13 @@
       </p:pic>
       <p:sp>
         <p:nvSpPr>
-          <p:cNvPr id="121" name="TextBox 120"/>
+          <p:cNvPr id="123" name="TextBox 122"/>
           <p:cNvSpPr txBox="1"/>
           <p:nvPr/>
         </p:nvSpPr>
         <p:spPr>
           <a:xfrm>
-            <a:off x="11548872" y="28046747"/>
+            <a:off x="11548872" y="28440231"/>
             <a:ext cx="14264640" cy="914400"/>
           </a:xfrm>
           <a:prstGeom prst="rect">
@@ -9127,14 +9226,14 @@
                 </a:solidFill>
                 <a:latin typeface="Times New Roman"/>
               </a:rPr>
-              <a:t>26 of 34 studies (76%) from Europe or North America; 3 from Africa or South America</a:t>
+              <a:t>Europe 14, Asia 14, North America 3, Africa 1, multinational 2; none from South America</a:t>
             </a:r>
           </a:p>
         </p:txBody>
       </p:sp>
       <p:pic>
         <p:nvPicPr>
-          <p:cNvPr id="122" name="Picture 121" descr="fig2_design_donut.png"/>
+          <p:cNvPr id="124" name="Picture 123" descr="fig2_design_donut.png"/>
           <p:cNvPicPr>
             <a:picLocks noChangeAspect="1"/>
           </p:cNvPicPr>
@@ -9148,8 +9247,8 @@
         </p:blipFill>
         <p:spPr>
           <a:xfrm>
-            <a:off x="26179272" y="21559079"/>
-            <a:ext cx="7077455" cy="4218467"/>
+            <a:off x="26179272" y="21952563"/>
+            <a:ext cx="7077455" cy="4289187"/>
           </a:xfrm>
           <a:prstGeom prst="rect">
             <a:avLst/>
@@ -9158,13 +9257,13 @@
       </p:pic>
       <p:sp>
         <p:nvSpPr>
-          <p:cNvPr id="123" name="TextBox 122"/>
+          <p:cNvPr id="125" name="TextBox 124"/>
           <p:cNvSpPr txBox="1"/>
           <p:nvPr/>
         </p:nvSpPr>
         <p:spPr>
           <a:xfrm>
-            <a:off x="26179272" y="25868986"/>
+            <a:off x="26179272" y="26333191"/>
             <a:ext cx="7077455" cy="914400"/>
           </a:xfrm>
           <a:prstGeom prst="rect">
@@ -9212,14 +9311,14 @@
                 </a:solidFill>
                 <a:latin typeface="Times New Roman"/>
               </a:rPr>
-              <a:t>Cross-sectional studies (n = 11) are a subset of quantitative designs</a:t>
-            </a:r>
-          </a:p>
-        </p:txBody>
-      </p:sp>
-      <p:sp>
-        <p:nvSpPr>
-          <p:cNvPr id="124" name="TextBox 123"/>
+              <a:t>Design of one study could not be determined from its abstract</a:t>
+            </a:r>
+          </a:p>
+        </p:txBody>
+      </p:sp>
+      <p:sp>
+        <p:nvSpPr>
+          <p:cNvPr id="126" name="TextBox 125"/>
           <p:cNvSpPr txBox="1"/>
           <p:nvPr/>
         </p:nvSpPr>
@@ -9268,7 +9367,7 @@
       </p:sp>
       <p:sp>
         <p:nvSpPr>
-          <p:cNvPr id="125" name="TextBox 124"/>
+          <p:cNvPr id="127" name="TextBox 126"/>
           <p:cNvSpPr txBox="1"/>
           <p:nvPr/>
         </p:nvSpPr>
@@ -9329,7 +9428,7 @@
                 </a:solidFill>
                 <a:latin typeface="Times New Roman"/>
               </a:rPr>
-              <a:t>Of 516 records identified, 361 remained after deduplication and 34 studies met inclusion criteria: 16 quantitative (11 cross-sectional), 11 qualitative, and 7 mixed-methods. Depression and anxiety were reported in 26 studies (76%), reduced QoL and body image in 22 (65%), psychosexual and relational challenges in 19 (56%), and broader distress in 17 (50%). Healthcare system gaps were identified in 18 studies (53%): delayed diagnosis without psychosocial support, limited multidisciplinary care, mental health insufficiently integrated into care models, and no standardized screening at diagnosis.</a:t>
+              <a:t>Of 516 records, 324 remained after deduplication and 34 studies were provisionally included: 18 quantitative, 12 qualitative, 3 mixed-methods, and 1 not reported. Psychosexual and relational challenges were most common (71%), followed by QoL, body image and self-esteem (53%), broader distress (53%), and depression and anxiety (29%). Healthcare gaps (9 studies) included providers' limited knowledge of MRKH, insensitive communication at diagnosis, and scarce information, psychological and fertility counseling.</a:t>
             </a:r>
           </a:p>
           <a:p>
@@ -9367,7 +9466,7 @@
                 </a:solidFill>
                 <a:latin typeface="Times New Roman"/>
               </a:rPr>
-              <a:t>These findings are consistent with earlier evidence of elevated distress, anxiety, and poorer mental health-related quality of life in MRKH</a:t>
+              <a:t>Findings on depression and anxiety were mixed: several studies reported elevated symptoms, while others found levels similar to controls. This aligns with earlier evidence</a:t>
             </a:r>
             <a:r>
               <a:rPr sz="2500" b="0" i="0" baseline="30000">
@@ -9385,7 +9484,7 @@
                 </a:solidFill>
                 <a:latin typeface="Times New Roman"/>
               </a:rPr>
-              <a:t> and with a prior systematic review.</a:t>
+              <a:t> and a prior systematic review highlighting sexual esteem and genital image.</a:t>
             </a:r>
             <a:r>
               <a:rPr sz="2500" b="0" i="0" baseline="30000">
@@ -9403,7 +9502,7 @@
                 </a:solidFill>
                 <a:latin typeface="Times New Roman"/>
               </a:rPr>
-              <a:t> Coping strategies were documented in most studies but remain unsupported by systematic clinical pathways, and 76% of studies came from Europe or North America, leaving low-resource settings underrepresented.</a:t>
+              <a:t> Coping relied largely on peer support and self-management rather than systematic clinical pathways.</a:t>
             </a:r>
           </a:p>
           <a:p>
@@ -9448,7 +9547,7 @@
       </p:sp>
       <p:sp>
         <p:nvSpPr>
-          <p:cNvPr id="126" name="TextBox 125"/>
+          <p:cNvPr id="128" name="TextBox 127"/>
           <p:cNvSpPr txBox="1"/>
           <p:nvPr/>
         </p:nvSpPr>
@@ -9497,7 +9596,7 @@
       </p:sp>
       <p:sp>
         <p:nvSpPr>
-          <p:cNvPr id="127" name="TextBox 126"/>
+          <p:cNvPr id="129" name="TextBox 128"/>
           <p:cNvSpPr txBox="1"/>
           <p:nvPr/>
         </p:nvSpPr>
@@ -9539,7 +9638,7 @@
                 </a:solidFill>
                 <a:latin typeface="Times New Roman"/>
               </a:rPr>
-              <a:t>•  Review limited to 2019–2026, potentially excluding earlier foundational research</a:t>
+              <a:t>•  Provisional: AI-assisted screening and abstract-level extraction pending full-text verification</a:t>
             </a:r>
           </a:p>
           <a:p>
@@ -9558,7 +9657,7 @@
                 </a:solidFill>
                 <a:latin typeface="Times New Roman"/>
               </a:rPr>
-              <a:t>•  Heterogeneous designs and outcome measures limit direct comparisons</a:t>
+              <a:t>•  Review limited to 2019–2026</a:t>
             </a:r>
           </a:p>
           <a:p>
@@ -9577,7 +9676,7 @@
                 </a:solidFill>
                 <a:latin typeface="Times New Roman"/>
               </a:rPr>
-              <a:t>•  Most studies from high-income countries, limiting global generalizability</a:t>
+              <a:t>•  Heterogeneous designs and measures limit comparison</a:t>
             </a:r>
           </a:p>
           <a:p>
@@ -9596,14 +9695,14 @@
                 </a:solidFill>
                 <a:latin typeface="Times New Roman"/>
               </a:rPr>
-              <a:t>•  Some studies relied on self-reported mental health outcomes</a:t>
-            </a:r>
-          </a:p>
-        </p:txBody>
-      </p:sp>
-      <p:sp>
-        <p:nvSpPr>
-          <p:cNvPr id="128" name="TextBox 127"/>
+              <a:t>•  Few studies from Africa; none from South America</a:t>
+            </a:r>
+          </a:p>
+        </p:txBody>
+      </p:sp>
+      <p:sp>
+        <p:nvSpPr>
+          <p:cNvPr id="130" name="TextBox 129"/>
           <p:cNvSpPr txBox="1"/>
           <p:nvPr/>
         </p:nvSpPr>
@@ -9652,7 +9751,7 @@
       </p:sp>
       <p:sp>
         <p:nvSpPr>
-          <p:cNvPr id="129" name="TextBox 128"/>
+          <p:cNvPr id="131" name="TextBox 130"/>
           <p:cNvSpPr txBox="1"/>
           <p:nvPr/>
         </p:nvSpPr>
@@ -9777,7 +9876,7 @@
       </p:sp>
       <p:sp>
         <p:nvSpPr>
-          <p:cNvPr id="130" name="TextBox 129"/>
+          <p:cNvPr id="132" name="TextBox 131"/>
           <p:cNvSpPr txBox="1"/>
           <p:nvPr/>
         </p:nvSpPr>
@@ -9826,7 +9925,7 @@
       </p:sp>
       <p:sp>
         <p:nvSpPr>
-          <p:cNvPr id="131" name="TextBox 130"/>
+          <p:cNvPr id="133" name="TextBox 132"/>
           <p:cNvSpPr txBox="1"/>
           <p:nvPr/>
         </p:nvSpPr>

</xml_diff>

<commit_message>
Reconcile with March 2026 screening tracker: English-only criterion, 36 studies
Co-Authored-By: Claude Opus 5.5 <noreply@anthropic.com>
Claude-Session: https://claude.ai/code/session_01N468nYR7vy45HpujgUezn5
</commit_message>
<xml_diff>
--- a/poster/MRKH_APHA2026_Poster.pptx
+++ b/poster/MRKH_APHA2026_Poster.pptx
@@ -6841,7 +6841,7 @@
                 </a:solidFill>
                 <a:latin typeface="Times New Roman"/>
               </a:rPr>
-              <a:t> 39 studies were provisionally included. Psychosexual and relational challenges were most frequent (n = 25), followed by psychological distress (n = 22), reduced QoL, body image and self-esteem (n = 20), and depression and anxiety (n = 12). Coping was documented in 14 studies; healthcare gaps in 10.</a:t>
+              <a:t> 36 studies were provisionally included. Psychosexual and relational challenges were most frequent (n = 23), followed by psychological distress (n = 20), reduced QoL, body image and self-esteem (n = 17), and depression and anxiety (n = 11). Coping was documented in 14 studies; healthcare gaps in 10.</a:t>
             </a:r>
           </a:p>
           <a:p>
@@ -7859,7 +7859,7 @@
                   </a:solidFill>
                   <a:latin typeface="Times New Roman"/>
                 </a:rPr>
-                <a:t>Of 516 records, 324 were screened and 39 studies included: 20 quantitative, 15 qualitative, 3 mixed-methods, 1 not reported. Studies came from Europe (17), Asia (14), North America (3), Africa (2), and Oceania (1); none from South America. Psychosexual and relational challenges were most common (64%); depression and anxiety were measured least (31%), with mixed findings.</a:t>
+                <a:t>Of 516 records, 324 were screened and 36 studies included: 18 quantitative, 15 qualitative, 2 mixed-methods, 1 not reported. Studies came from Europe (15), Asia (14), North America (3), Africa (1), and Oceania (1); none from South America. Psychosexual and relational challenges were most common (64%); depression and anxiety were measured least (31%), with mixed findings.</a:t>
               </a:r>
             </a:p>
             <a:p>
@@ -7933,7 +7933,7 @@
                   </a:solidFill>
                   <a:latin typeface="Times New Roman"/>
                 </a:rPr>
-                <a:t> Coping relied on peer support and self-management; only 3 studies tested interventions. Healthcare gaps included providers' limited knowledge of MRKH and insensitive communication at diagnosis.</a:t>
+                <a:t> Coping relied on peer support and self-management; only 2 studies tested interventions. Healthcare gaps included providers' limited knowledge of MRKH and insensitive communication at diagnosis.</a:t>
               </a:r>
             </a:p>
             <a:p>
@@ -8218,7 +8218,7 @@
                           </a:solidFill>
                           <a:latin typeface="Times New Roman"/>
                         </a:rPr>
-                        <a:t>Primary quantitative, qualitative, or mixed-methods studies reporting psychological outcomes or coping in MRKH; surgical/fertility-only studies excluded</a:t>
+                        <a:t>English-language primary quantitative, qualitative, or mixed-methods studies reporting psychological outcomes or coping in MRKH; surgical/fertility-only studies excluded</a:t>
                       </a:r>
                       <a:endParaRPr lang="en-US" sz="2400" dirty="0">
                         <a:latin typeface="Times New Roman" panose="02020603050405020304" pitchFamily="18" charset="0"/>
@@ -8265,7 +8265,7 @@
                           </a:solidFill>
                           <a:latin typeface="Times New Roman"/>
                         </a:rPr>
-                        <a:t>516 records; 324 screened; 46 assessed; 39 included. AI-assisted screening and abstract-level charting (verification in progress); frequency counts and thematic grouping</a:t>
+                        <a:t>516 records; 324 screened; 42 assessed; 36 included. AI-assisted screening and abstract-level charting (verification in progress); frequency counts and thematic grouping</a:t>
                       </a:r>
                       <a:endParaRPr lang="en-US" sz="2400" dirty="0">
                         <a:latin typeface="Times New Roman" panose="02020603050405020304" pitchFamily="18" charset="0"/>
@@ -8734,7 +8734,7 @@
                 </a:solidFill>
                 <a:latin typeface="Times New Roman"/>
               </a:rPr>
-              <a:t>Full list of the 39 included studies available on request.</a:t>
+              <a:t>Full list of the 36 included studies available on request.</a:t>
             </a:r>
           </a:p>
           <a:p>
@@ -8817,7 +8817,7 @@
                 </a:solidFill>
                 <a:latin typeface="Times New Roman"/>
               </a:rPr>
-              <a:t>Figure 1. Frequency of Outcome Domains Across Included Studies (N = 39); studies could report more than one domain</a:t>
+              <a:t>Figure 1. Frequency of Outcome Domains Across Included Studies (N = 36); studies could report more than one domain</a:t>
             </a:r>
           </a:p>
         </p:txBody>
@@ -8933,7 +8933,7 @@
                 </a:solidFill>
                 <a:latin typeface="Times New Roman"/>
               </a:rPr>
-              <a:t>Figure 3. Geographic Distribution of Included Studies (N = 39)</a:t>
+              <a:t>Figure 3. Geographic Distribution of Included Studies (N = 36)</a:t>
             </a:r>
           </a:p>
         </p:txBody>
@@ -8991,7 +8991,7 @@
                 </a:solidFill>
                 <a:latin typeface="Times New Roman"/>
               </a:rPr>
-              <a:t>Figure 4. Study Design Distribution (N = 39)</a:t>
+              <a:t>Figure 4. Study Design Distribution (N = 36)</a:t>
             </a:r>
           </a:p>
         </p:txBody>

</xml_diff>

<commit_message>
Full-text verification of 30 of 35 included studies
Checked extraction against the uploaded full texts; excluded Mediå 2022 at
eligibility (2 of 15 participants had MRKH, not analyzed separately), giving
35 included studies. Corrected domains, sample sizes and coping codes;
rebuilt data.json, figures, map, manuscript and poster. Added
rescreen/FULLTEXT_VERIFICATION.md.

Co-Authored-By: Claude Opus 5.5 <noreply@anthropic.com>
Claude-Session: https://claude.ai/code/session_01N468nYR7vy45HpujgUezn5
</commit_message>
<xml_diff>
--- a/poster/MRKH_APHA2026_Poster.pptx
+++ b/poster/MRKH_APHA2026_Poster.pptx
@@ -6841,7 +6841,7 @@
                 </a:solidFill>
                 <a:latin typeface="Times New Roman"/>
               </a:rPr>
-              <a:t> 36 studies were provisionally included. Psychosexual and relational challenges were most frequent (n = 23), followed by psychological distress (n = 20), reduced QoL, body image and self-esteem (n = 17), and depression and anxiety (n = 11). Coping was documented in 14 studies; healthcare gaps in 10.</a:t>
+              <a:t> 35 studies were included. Psychosexual and relational challenges were most frequent (n = 24), followed by psychological distress (n = 20), reduced QoL, body image and self-esteem (n = 19), and depression and anxiety (n = 14). Coping was documented in 15 studies; healthcare gaps in 10.</a:t>
             </a:r>
           </a:p>
           <a:p>
@@ -7859,7 +7859,7 @@
                   </a:solidFill>
                   <a:latin typeface="Times New Roman"/>
                 </a:rPr>
-                <a:t>Of 516 records, 324 were screened and 36 studies included: 18 quantitative, 15 qualitative, 2 mixed-methods, 1 not reported. Studies came from Europe (15), Asia (14), North America (3), Africa (1), and Oceania (1); none from South America. Psychosexual and relational challenges were most common (64%); depression and anxiety were measured least (31%), with mixed findings.</a:t>
+                <a:t>Of 516 records, 324 were screened and 35 studies included: 18 quantitative, 14 qualitative, 2 mixed-methods, 1 not reported. Studies came from Europe (14), Asia (14), North America (3), Africa (1), and Oceania (1); none from South America. Psychosexual and relational challenges were most common (69%); depression and anxiety were measured least (40%), with mixed findings.</a:t>
               </a:r>
             </a:p>
             <a:p>
@@ -8265,7 +8265,7 @@
                           </a:solidFill>
                           <a:latin typeface="Times New Roman"/>
                         </a:rPr>
-                        <a:t>516 records; 324 screened; 42 assessed; 36 included. AI-assisted screening and abstract-level charting (verification in progress); frequency counts and thematic grouping</a:t>
+                        <a:t>516 records; 324 screened; 42 assessed; 35 included. AI-assisted screening with full-text charting (30 of 35 studies); frequency counts and thematic grouping</a:t>
                       </a:r>
                       <a:endParaRPr lang="en-US" sz="2400" dirty="0">
                         <a:latin typeface="Times New Roman" panose="02020603050405020304" pitchFamily="18" charset="0"/>
@@ -8347,7 +8347,7 @@
                 </a:solidFill>
                 <a:latin typeface="Times New Roman"/>
               </a:rPr>
-              <a:t>• Provisional: AI-assisted screening and abstract-level charting pending full-text verification</a:t>
+              <a:t>• AI-assisted screening; 5 of 35 studies charted from abstracts only (full text unavailable)</a:t>
             </a:r>
           </a:p>
           <a:p>
@@ -8734,7 +8734,7 @@
                 </a:solidFill>
                 <a:latin typeface="Times New Roman"/>
               </a:rPr>
-              <a:t>Full list of the 36 included studies available on request.</a:t>
+              <a:t>Full list of the 35 included studies available on request.</a:t>
             </a:r>
           </a:p>
           <a:p>
@@ -8817,7 +8817,7 @@
                 </a:solidFill>
                 <a:latin typeface="Times New Roman"/>
               </a:rPr>
-              <a:t>Figure 1. Frequency of Outcome Domains Across Included Studies (N = 36); studies could report more than one domain</a:t>
+              <a:t>Figure 1. Frequency of Outcome Domains Across Included Studies (N = 35); studies could report more than one domain</a:t>
             </a:r>
           </a:p>
         </p:txBody>
@@ -8875,7 +8875,7 @@
                 </a:solidFill>
                 <a:latin typeface="Times New Roman"/>
               </a:rPr>
-              <a:t>Figure 2. PRISMA-ScR Flow Diagram of Study Selection (provisional)</a:t>
+              <a:t>Figure 2. PRISMA-ScR Flow Diagram of Study Selection</a:t>
             </a:r>
           </a:p>
         </p:txBody>
@@ -8933,7 +8933,7 @@
                 </a:solidFill>
                 <a:latin typeface="Times New Roman"/>
               </a:rPr>
-              <a:t>Figure 3. Geographic Distribution of Included Studies (N = 36)</a:t>
+              <a:t>Figure 3. Geographic Distribution of Included Studies (N = 35)</a:t>
             </a:r>
           </a:p>
         </p:txBody>
@@ -8991,7 +8991,7 @@
                 </a:solidFill>
                 <a:latin typeface="Times New Roman"/>
               </a:rPr>
-              <a:t>Figure 4. Study Design Distribution (N = 36)</a:t>
+              <a:t>Figure 4. Study Design Distribution (N = 35)</a:t>
             </a:r>
           </a:p>
         </p:txBody>
@@ -9049,7 +9049,7 @@
                 </a:solidFill>
                 <a:latin typeface="Times New Roman"/>
               </a:rPr>
-              <a:t>Figure 5. Coping Mechanisms Documented (14 studies)</a:t>
+              <a:t>Figure 5. Coping Mechanisms Documented (15 studies)</a:t>
             </a:r>
           </a:p>
         </p:txBody>

</xml_diff>

<commit_message>
Poster: fuller text with AMA in-text citations, QR code spot in the sample's References position, full reference list document; AMA fixes to reference formatting
Co-Authored-By: Claude Opus 5.5 <noreply@anthropic.com>
Claude-Session: https://claude.ai/code/session_01N468nYR7vy45HpujgUezn5
</commit_message>
<xml_diff>
--- a/poster/MRKH_APHA2026_Poster.pptx
+++ b/poster/MRKH_APHA2026_Poster.pptx
@@ -6756,7 +6756,7 @@
           </a:ln>
         </p:spPr>
         <p:txBody>
-          <a:bodyPr wrap="square" lIns="131445" tIns="65723" rIns="131445" bIns="65723" rtlCol="0">
+          <a:bodyPr wrap="square" lIns="131445" tIns="65723" rIns="131445" bIns="65723" rtlCol="0" anchor="t">
             <a:noAutofit/>
           </a:bodyPr>
           <a:lstStyle/>
@@ -6770,7 +6770,7 @@
               </a:spcAft>
             </a:pPr>
             <a:r>
-              <a:rPr sz="2400" b="1" i="0">
+              <a:rPr sz="2200" b="1" i="0">
                 <a:solidFill>
                   <a:srgbClr val="000000"/>
                 </a:solidFill>
@@ -6779,13 +6779,13 @@
               <a:t>Background:</a:t>
             </a:r>
             <a:r>
-              <a:rPr sz="2400" b="0" i="0">
+              <a:rPr sz="2200" b="0" i="0">
                 <a:solidFill>
                   <a:srgbClr val="000000"/>
                 </a:solidFill>
                 <a:latin typeface="Times New Roman"/>
               </a:rPr>
-              <a:t> Mayer-Rokitansky-Küster-Hauser (MRKH) syndrome is a rare congenital condition (1 in 4,500–5,000 female births) characterized by uterovaginal agenesis in individuals with a 46,XX karyotype. Diagnosed in adolescence, it carries substantial psychosocial burden that remains insufficiently synthesized.</a:t>
+              <a:t> Mayer-Rokitansky-Küster-Hauser (MRKH) syndrome is a rare congenital condition (1 in 4,500–5,000 female births) characterized by uterovaginal agenesis in individuals with a 46,XX karyotype. Usually diagnosed in adolescence, it affects fertility, sexuality, and identity, yet its mental health consequences remain insufficiently synthesized.</a:t>
             </a:r>
           </a:p>
           <a:p>
@@ -6798,7 +6798,7 @@
               </a:spcAft>
             </a:pPr>
             <a:r>
-              <a:rPr sz="2400" b="1" i="0">
+              <a:rPr sz="2200" b="1" i="0">
                 <a:solidFill>
                   <a:srgbClr val="000000"/>
                 </a:solidFill>
@@ -6807,13 +6807,13 @@
               <a:t>Methods:</a:t>
             </a:r>
             <a:r>
-              <a:rPr sz="2400" b="0" i="0">
+              <a:rPr sz="2200" b="0" i="0">
                 <a:solidFill>
                   <a:srgbClr val="000000"/>
                 </a:solidFill>
                 <a:latin typeface="Times New Roman"/>
               </a:rPr>
-              <a:t> Scoping review (Arksey &amp; O'Malley; PRISMA-ScR) of PubMed, Scopus, and EBSCOhost databases, January 2019–March 2026.</a:t>
+              <a:t> Scoping review (Arksey &amp; O'Malley; PRISMA-ScR) of PubMed, Scopus, and EBSCOhost databases (MEDLINE, CINAHL, APA PsycInfo, Women's Studies International), January 2019–March 2026.</a:t>
             </a:r>
           </a:p>
           <a:p>
@@ -6826,7 +6826,7 @@
               </a:spcAft>
             </a:pPr>
             <a:r>
-              <a:rPr sz="2400" b="1" i="0">
+              <a:rPr sz="2200" b="1" i="0">
                 <a:solidFill>
                   <a:srgbClr val="000000"/>
                 </a:solidFill>
@@ -6835,13 +6835,13 @@
               <a:t>Results:</a:t>
             </a:r>
             <a:r>
-              <a:rPr sz="2400" b="0" i="0">
+              <a:rPr sz="2200" b="0" i="0">
                 <a:solidFill>
                   <a:srgbClr val="000000"/>
                 </a:solidFill>
                 <a:latin typeface="Times New Roman"/>
               </a:rPr>
-              <a:t> 35 studies were included. Psychosexual and relational challenges were most frequent (n = 24), followed by psychological distress (n = 20), reduced QoL, body image and self-esteem (n = 19), and depression and anxiety (n = 14). Coping was documented in 15 studies; healthcare gaps in 10.</a:t>
+              <a:t> Of 516 records, 35 studies were included. Psychosexual and relational challenges were most frequent (n = 24), followed by psychological distress (n = 20), reduced QoL, body image, and self-esteem (n = 19), and depression and anxiety (n = 14). Coping was documented in 15 studies, mostly peer support; healthcare gaps in 10.</a:t>
             </a:r>
           </a:p>
           <a:p>
@@ -6854,7 +6854,7 @@
               </a:spcAft>
             </a:pPr>
             <a:r>
-              <a:rPr sz="2400" b="1" i="0">
+              <a:rPr sz="2200" b="1" i="0">
                 <a:solidFill>
                   <a:srgbClr val="000000"/>
                 </a:solidFill>
@@ -6863,22 +6863,13 @@
               <a:t>Conclusion:</a:t>
             </a:r>
             <a:r>
-              <a:rPr sz="2400" b="0" i="0">
+              <a:rPr sz="2200" b="0" i="0">
                 <a:solidFill>
                   <a:srgbClr val="000000"/>
                 </a:solidFill>
                 <a:latin typeface="Times New Roman"/>
               </a:rPr>
-              <a:t> MRKH-related psychosocial burden is substantial yet under-integrated into care. </a:t>
-            </a:r>
-            <a:r>
-              <a:rPr sz="2400" b="0" i="1">
-                <a:solidFill>
-                  <a:srgbClr val="000000"/>
-                </a:solidFill>
-                <a:latin typeface="Times New Roman"/>
-              </a:rPr>
-              <a:t>Results updated from the submitted abstract after final screening and full-text review.</a:t>
+              <a:t> MRKH-related psychosocial burden is substantial yet under-integrated into care. Psychosocial screening, psychosexual counseling, and peer support belong in MRKH care pathways.</a:t>
             </a:r>
           </a:p>
         </p:txBody>
@@ -6963,7 +6954,7 @@
           </a:ln>
         </p:spPr>
         <p:txBody>
-          <a:bodyPr wrap="square" lIns="131445" tIns="65723" rIns="131445" bIns="65723" rtlCol="0">
+          <a:bodyPr wrap="square" lIns="131445" tIns="65723" rIns="131445" bIns="65723" rtlCol="0" anchor="t">
             <a:noAutofit/>
           </a:bodyPr>
           <a:lstStyle/>
@@ -6977,7 +6968,7 @@
               </a:spcAft>
             </a:pPr>
             <a:r>
-              <a:rPr sz="2400" b="1" i="0">
+              <a:rPr sz="2200" b="1" i="0">
                 <a:solidFill>
                   <a:srgbClr val="000000"/>
                 </a:solidFill>
@@ -6996,16 +6987,16 @@
               </a:spcAft>
             </a:pPr>
             <a:r>
-              <a:rPr sz="2400" b="0" i="0">
+              <a:rPr sz="2200" b="0" i="0">
                 <a:solidFill>
                   <a:srgbClr val="000000"/>
                 </a:solidFill>
                 <a:latin typeface="Times New Roman"/>
               </a:rPr>
-              <a:t>MRKH syndrome is congenital absence of the uterus and upper vagina in individuals with a 46,XX karyotype and functional ovaries, affecting about 1 in 4,500–5,000 female births.</a:t>
-            </a:r>
-            <a:r>
-              <a:rPr sz="2400" b="0" i="0" baseline="30000">
+              <a:t>MRKH syndrome is the congenital absence of the uterus and upper vagina in individuals with a 46,XX karyotype and functioning ovaries, affecting about 1 in 4,500–5,000 female births.</a:t>
+            </a:r>
+            <a:r>
+              <a:rPr sz="2200" b="0" i="0" baseline="30000">
                 <a:solidFill>
                   <a:srgbClr val="000000"/>
                 </a:solidFill>
@@ -7014,16 +7005,16 @@
               <a:t>1,2</a:t>
             </a:r>
             <a:r>
-              <a:rPr sz="2400" b="0" i="0">
+              <a:rPr sz="2200" b="0" i="0">
                 <a:solidFill>
                   <a:srgbClr val="000000"/>
                 </a:solidFill>
                 <a:latin typeface="Times New Roman"/>
               </a:rPr>
-              <a:t> It is usually diagnosed in adolescence during evaluation for primary amenorrhea,</a:t>
-            </a:r>
-            <a:r>
-              <a:rPr sz="2400" b="0" i="0" baseline="30000">
+              <a:t> It is usually diagnosed in adolescence during evaluation of primary amenorrhea,</a:t>
+            </a:r>
+            <a:r>
+              <a:rPr sz="2200" b="0" i="0" baseline="30000">
                 <a:solidFill>
                   <a:srgbClr val="000000"/>
                 </a:solidFill>
@@ -7032,31 +7023,67 @@
               <a:t>1</a:t>
             </a:r>
             <a:r>
-              <a:rPr sz="2400" b="0" i="0">
+              <a:rPr sz="2200" b="0" i="0">
                 <a:solidFill>
                   <a:srgbClr val="000000"/>
                 </a:solidFill>
                 <a:latin typeface="Times New Roman"/>
               </a:rPr>
-              <a:t> a critical period for identity and social development. The diagnosis affects fertility, sexuality, and self-image, and psychosocial counseling is recommended as part of care,</a:t>
-            </a:r>
-            <a:r>
-              <a:rPr sz="2400" b="0" i="0" baseline="30000">
+              <a:t> a sensitive period for identity, sexuality, and relationships. Earlier studies linked MRKH with psychological distress, anxiety, and reduced quality of life,</a:t>
+            </a:r>
+            <a:r>
+              <a:rPr sz="2200" b="0" i="0" baseline="30000">
                 <a:solidFill>
                   <a:srgbClr val="000000"/>
                 </a:solidFill>
                 <a:latin typeface="Times New Roman"/>
               </a:rPr>
+              <a:t>3–5</a:t>
+            </a:r>
+            <a:r>
+              <a:rPr sz="2200" b="0" i="0">
+                <a:solidFill>
+                  <a:srgbClr val="000000"/>
+                </a:solidFill>
+                <a:latin typeface="Times New Roman"/>
+              </a:rPr>
+              <a:t> and guidelines recommend psychosocial counseling as part of care.</a:t>
+            </a:r>
+            <a:r>
+              <a:rPr sz="2200" b="0" i="0" baseline="30000">
+                <a:solidFill>
+                  <a:srgbClr val="000000"/>
+                </a:solidFill>
+                <a:latin typeface="Times New Roman"/>
+              </a:rPr>
               <a:t>1</a:t>
             </a:r>
             <a:r>
-              <a:rPr sz="2400" b="0" i="0">
+              <a:rPr sz="2200" b="0" i="0">
                 <a:solidFill>
                   <a:srgbClr val="000000"/>
                 </a:solidFill>
                 <a:latin typeface="Times New Roman"/>
               </a:rPr>
-              <a:t> yet mental health outcomes remain insufficiently integrated into practice.</a:t>
+              <a:t> Prior reviews focused on psychological and sexual outcomes;</a:t>
+            </a:r>
+            <a:r>
+              <a:rPr sz="2200" b="0" i="0" baseline="30000">
+                <a:solidFill>
+                  <a:srgbClr val="000000"/>
+                </a:solidFill>
+                <a:latin typeface="Times New Roman"/>
+              </a:rPr>
+              <a:t>6,7</a:t>
+            </a:r>
+            <a:r>
+              <a:rPr sz="2200" b="0" i="0">
+                <a:solidFill>
+                  <a:srgbClr val="000000"/>
+                </a:solidFill>
+                <a:latin typeface="Times New Roman"/>
+              </a:rPr>
+              <a:t> coping and healthcare system gaps have not been mapped across the growing recent literature. Mapping this evidence can guide psychosocial care, provider training, and research priorities.</a:t>
             </a:r>
           </a:p>
           <a:p>
@@ -7069,7 +7096,7 @@
               </a:spcAft>
             </a:pPr>
             <a:r>
-              <a:rPr sz="2400" b="1" i="0">
+              <a:rPr sz="2200" b="1" i="0">
                 <a:solidFill>
                   <a:srgbClr val="000000"/>
                 </a:solidFill>
@@ -7088,13 +7115,13 @@
               </a:spcAft>
             </a:pPr>
             <a:r>
-              <a:rPr sz="2400" b="0" i="0">
+              <a:rPr sz="2200" b="0" i="0">
                 <a:solidFill>
                   <a:srgbClr val="000000"/>
                 </a:solidFill>
                 <a:latin typeface="Times New Roman"/>
               </a:rPr>
-              <a:t>To map mental health outcomes, coping mechanisms, and healthcare system gaps reported in studies of individuals with MRKH published 2019–2026.</a:t>
+              <a:t>To map mental health and psychosocial outcomes, coping mechanisms, and healthcare system gaps reported in studies of individuals with MRKH published 2019–2026.</a:t>
             </a:r>
           </a:p>
           <a:p>
@@ -7107,7 +7134,7 @@
               </a:spcAft>
             </a:pPr>
             <a:r>
-              <a:rPr sz="2400" b="1" i="0">
+              <a:rPr sz="2200" b="1" i="0">
                 <a:solidFill>
                   <a:srgbClr val="000000"/>
                 </a:solidFill>
@@ -7126,7 +7153,7 @@
               </a:spcAft>
             </a:pPr>
             <a:r>
-              <a:rPr sz="2400" b="0" i="0">
+              <a:rPr sz="2200" b="0" i="0">
                 <a:solidFill>
                   <a:srgbClr val="000000"/>
                 </a:solidFill>
@@ -7187,398 +7214,441 @@
           </a:p>
         </p:txBody>
       </p:sp>
-      <p:grpSp>
-        <p:nvGrpSpPr>
-          <p:cNvPr id="314" name="Group 313">
+      <p:sp>
+        <p:nvSpPr>
+          <p:cNvPr id="315" name="TextBox 314">
             <a:extLst>
               <a:ext uri="{FF2B5EF4-FFF2-40B4-BE49-F238E27FC236}">
-                <a16:creationId xmlns:a16="http://schemas.microsoft.com/office/drawing/2014/main" id="{BC6EF120-E0D1-21D9-0B16-C9D342E5CDB5}"/>
+                <a16:creationId xmlns:a16="http://schemas.microsoft.com/office/drawing/2014/main" id="{1A04ABA2-9C79-F910-AB39-429544CFAA06}"/>
               </a:ext>
             </a:extLst>
           </p:cNvPr>
-          <p:cNvGrpSpPr/>
+          <p:cNvSpPr txBox="1"/>
           <p:nvPr/>
-        </p:nvGrpSpPr>
-        <p:grpSpPr>
+        </p:nvSpPr>
+        <p:spPr>
           <a:xfrm>
-            <a:off x="641891" y="20411383"/>
-            <a:ext cx="9565778" cy="11946867"/>
-            <a:chOff x="783601" y="26482178"/>
-            <a:chExt cx="9359887" cy="5029212"/>
+            <a:off x="694314" y="21631677"/>
+            <a:ext cx="9513355" cy="10726573"/>
           </a:xfrm>
-        </p:grpSpPr>
-        <p:sp>
-          <p:nvSpPr>
-            <p:cNvPr id="315" name="TextBox 314">
-              <a:extLst>
-                <a:ext uri="{FF2B5EF4-FFF2-40B4-BE49-F238E27FC236}">
-                  <a16:creationId xmlns:a16="http://schemas.microsoft.com/office/drawing/2014/main" id="{1A04ABA2-9C79-F910-AB39-429544CFAA06}"/>
-                </a:ext>
-              </a:extLst>
-            </p:cNvPr>
-            <p:cNvSpPr txBox="1"/>
-            <p:nvPr/>
-          </p:nvSpPr>
-          <p:spPr>
-            <a:xfrm>
-              <a:off x="834896" y="26995879"/>
-              <a:ext cx="9308592" cy="4515511"/>
-            </a:xfrm>
-            <a:prstGeom prst="rect">
-              <a:avLst/>
-            </a:prstGeom>
+          <a:prstGeom prst="rect">
+            <a:avLst/>
+          </a:prstGeom>
+          <a:solidFill>
+            <a:schemeClr val="tx1"/>
+          </a:solidFill>
+          <a:ln cap="rnd">
             <a:solidFill>
-              <a:schemeClr val="tx1"/>
+              <a:schemeClr val="bg1"/>
             </a:solidFill>
-            <a:ln cap="rnd">
-              <a:solidFill>
-                <a:schemeClr val="bg1"/>
-              </a:solidFill>
-            </a:ln>
-          </p:spPr>
-          <p:txBody>
-            <a:bodyPr wrap="square" lIns="182880" rIns="182880" rtlCol="0">
-              <a:noAutofit/>
-            </a:bodyPr>
-            <a:lstStyle/>
-            <a:p>
-              <a:pPr algn="just"/>
-              <a:endParaRPr lang="en-US" sz="1800" dirty="0">
-                <a:latin typeface="Times New Roman"/>
-                <a:cs typeface="Times New Roman"/>
-              </a:endParaRPr>
-            </a:p>
-          </p:txBody>
-        </p:sp>
-        <p:sp>
-          <p:nvSpPr>
-            <p:cNvPr id="316" name="TextBox 315">
-              <a:extLst>
-                <a:ext uri="{FF2B5EF4-FFF2-40B4-BE49-F238E27FC236}">
-                  <a16:creationId xmlns:a16="http://schemas.microsoft.com/office/drawing/2014/main" id="{BC19B682-B6AF-9A71-5C4D-B2D1BE476405}"/>
-                </a:ext>
-              </a:extLst>
-            </p:cNvPr>
-            <p:cNvSpPr txBox="1"/>
-            <p:nvPr/>
-          </p:nvSpPr>
-          <p:spPr>
-            <a:xfrm>
-              <a:off x="783601" y="26482178"/>
-              <a:ext cx="9308592" cy="400902"/>
-            </a:xfrm>
-            <a:prstGeom prst="rect">
-              <a:avLst/>
-            </a:prstGeom>
-            <a:solidFill>
-              <a:srgbClr val="0A254E"/>
-            </a:solidFill>
-            <a:ln>
-              <a:solidFill>
-                <a:schemeClr val="bg1"/>
-              </a:solidFill>
-            </a:ln>
-          </p:spPr>
-          <p:txBody>
-            <a:bodyPr wrap="square" lIns="131445" tIns="65723" rIns="131445" bIns="65723" rtlCol="0">
-              <a:spAutoFit/>
-            </a:bodyPr>
-            <a:lstStyle/>
-            <a:p>
-              <a:pPr algn="ctr"/>
-              <a:r>
-                <a:rPr lang="en-US" sz="4800" dirty="0">
-                  <a:latin typeface="Times New Roman"/>
-                  <a:cs typeface="Times New Roman"/>
-                </a:rPr>
-                <a:t>Methods</a:t>
-              </a:r>
-              <a:endParaRPr lang="en-US" sz="6000" dirty="0">
-                <a:latin typeface="Times New Roman"/>
-                <a:cs typeface="Times New Roman"/>
-              </a:endParaRPr>
-            </a:p>
-          </p:txBody>
-        </p:sp>
-      </p:grpSp>
-      <p:grpSp>
-        <p:nvGrpSpPr>
-          <p:cNvPr id="320" name="Group 319">
+          </a:ln>
+        </p:spPr>
+        <p:txBody>
+          <a:bodyPr wrap="square" lIns="182880" rIns="182880" rtlCol="0">
+            <a:noAutofit/>
+          </a:bodyPr>
+          <a:lstStyle/>
+          <a:p>
+            <a:pPr algn="just"/>
+            <a:endParaRPr lang="en-US" sz="1800" dirty="0">
+              <a:latin typeface="Times New Roman"/>
+              <a:cs typeface="Times New Roman"/>
+            </a:endParaRPr>
+          </a:p>
+        </p:txBody>
+      </p:sp>
+      <p:sp>
+        <p:nvSpPr>
+          <p:cNvPr id="316" name="TextBox 315">
             <a:extLst>
               <a:ext uri="{FF2B5EF4-FFF2-40B4-BE49-F238E27FC236}">
-                <a16:creationId xmlns:a16="http://schemas.microsoft.com/office/drawing/2014/main" id="{53AEC50B-E878-4565-180E-A62D5A2144C4}"/>
+                <a16:creationId xmlns:a16="http://schemas.microsoft.com/office/drawing/2014/main" id="{BC19B682-B6AF-9A71-5C4D-B2D1BE476405}"/>
               </a:ext>
             </a:extLst>
           </p:cNvPr>
-          <p:cNvGrpSpPr/>
+          <p:cNvSpPr txBox="1"/>
           <p:nvPr/>
-        </p:nvGrpSpPr>
-        <p:grpSpPr>
+        </p:nvSpPr>
+        <p:spPr>
           <a:xfrm>
-            <a:off x="34006809" y="17775704"/>
-            <a:ext cx="9256360" cy="8790347"/>
-            <a:chOff x="34080553" y="17757963"/>
-            <a:chExt cx="9295886" cy="7458416"/>
+            <a:off x="641891" y="20411383"/>
+            <a:ext cx="9513355" cy="952341"/>
           </a:xfrm>
-        </p:grpSpPr>
-        <p:sp>
-          <p:nvSpPr>
-            <p:cNvPr id="321" name="TextBox 320">
-              <a:extLst>
-                <a:ext uri="{FF2B5EF4-FFF2-40B4-BE49-F238E27FC236}">
-                  <a16:creationId xmlns:a16="http://schemas.microsoft.com/office/drawing/2014/main" id="{CB19DFF1-BA24-B68B-4652-0F80775C03FA}"/>
-                </a:ext>
-              </a:extLst>
-            </p:cNvPr>
-            <p:cNvSpPr txBox="1"/>
-            <p:nvPr/>
-          </p:nvSpPr>
-          <p:spPr>
-            <a:xfrm>
-              <a:off x="34080554" y="19026404"/>
-              <a:ext cx="9263014" cy="6189975"/>
-            </a:xfrm>
-            <a:prstGeom prst="rect">
-              <a:avLst/>
-            </a:prstGeom>
+          <a:prstGeom prst="rect">
+            <a:avLst/>
+          </a:prstGeom>
+          <a:solidFill>
+            <a:srgbClr val="0A254E"/>
+          </a:solidFill>
+          <a:ln>
             <a:solidFill>
-              <a:srgbClr val="FFFFFF"/>
+              <a:schemeClr val="bg1"/>
             </a:solidFill>
-            <a:ln cap="rnd">
-              <a:solidFill>
-                <a:schemeClr val="bg1"/>
-              </a:solidFill>
-            </a:ln>
-          </p:spPr>
-          <p:txBody>
-            <a:bodyPr wrap="square" lIns="182880" rIns="182880" rtlCol="0">
-              <a:noAutofit/>
-            </a:bodyPr>
-            <a:lstStyle/>
-            <a:p>
-              <a:pPr algn="just">
-                <a:lnSpc>
-                  <a:spcPct val="100000"/>
-                </a:lnSpc>
-                <a:spcAft>
-                  <a:spcPts val="300"/>
-                </a:spcAft>
-              </a:pPr>
-              <a:r>
-                <a:rPr sz="2400" b="1" i="0">
-                  <a:solidFill>
-                    <a:srgbClr val="000000"/>
-                  </a:solidFill>
-                  <a:latin typeface="Times New Roman"/>
-                </a:rPr>
-                <a:t>Public Health Implications</a:t>
-              </a:r>
-            </a:p>
-            <a:p>
-              <a:pPr algn="l">
-                <a:lnSpc>
-                  <a:spcPct val="100000"/>
-                </a:lnSpc>
-                <a:spcAft>
-                  <a:spcPts val="300"/>
-                </a:spcAft>
-              </a:pPr>
-              <a:r>
-                <a:rPr sz="2400" b="0" i="0">
-                  <a:solidFill>
-                    <a:srgbClr val="000000"/>
-                  </a:solidFill>
-                  <a:latin typeface="Times New Roman"/>
-                </a:rPr>
-                <a:t>• Integrate psychosocial support and mental health screening at diagnosis</a:t>
-              </a:r>
-            </a:p>
-            <a:p>
-              <a:pPr algn="l">
-                <a:lnSpc>
-                  <a:spcPct val="100000"/>
-                </a:lnSpc>
-                <a:spcAft>
-                  <a:spcPts val="300"/>
-                </a:spcAft>
-              </a:pPr>
-              <a:r>
-                <a:rPr sz="2400" b="0" i="0">
-                  <a:solidFill>
-                    <a:srgbClr val="000000"/>
-                  </a:solidFill>
-                  <a:latin typeface="Times New Roman"/>
-                </a:rPr>
-                <a:t>• Build multidisciplinary teams with psychology and social work</a:t>
-              </a:r>
-            </a:p>
-            <a:p>
-              <a:pPr algn="l">
-                <a:lnSpc>
-                  <a:spcPct val="100000"/>
-                </a:lnSpc>
-                <a:spcAft>
-                  <a:spcPts val="300"/>
-                </a:spcAft>
-              </a:pPr>
-              <a:r>
-                <a:rPr sz="2400" b="0" i="0">
-                  <a:solidFill>
-                    <a:srgbClr val="000000"/>
-                  </a:solidFill>
-                  <a:latin typeface="Times New Roman"/>
-                </a:rPr>
-                <a:t>• Pair vaginal lengthening treatment with psychosexual counseling</a:t>
-              </a:r>
-            </a:p>
-            <a:p>
-              <a:pPr algn="l">
-                <a:lnSpc>
-                  <a:spcPct val="100000"/>
-                </a:lnSpc>
-                <a:spcAft>
-                  <a:spcPts val="300"/>
-                </a:spcAft>
-              </a:pPr>
-              <a:r>
-                <a:rPr sz="2400" b="0" i="0">
-                  <a:solidFill>
-                    <a:srgbClr val="000000"/>
-                  </a:solidFill>
-                  <a:latin typeface="Times New Roman"/>
-                </a:rPr>
-                <a:t>• Train providers in sensitive, non-stigmatizing communication</a:t>
-              </a:r>
-            </a:p>
-            <a:p>
-              <a:pPr algn="just">
-                <a:lnSpc>
-                  <a:spcPct val="100000"/>
-                </a:lnSpc>
-                <a:spcAft>
-                  <a:spcPts val="300"/>
-                </a:spcAft>
-              </a:pPr>
-              <a:r>
-                <a:rPr sz="2400" b="1" i="0">
-                  <a:solidFill>
-                    <a:srgbClr val="000000"/>
-                  </a:solidFill>
-                  <a:latin typeface="Times New Roman"/>
-                </a:rPr>
-                <a:t>Future Work</a:t>
-              </a:r>
-            </a:p>
-            <a:p>
-              <a:pPr algn="l">
-                <a:lnSpc>
-                  <a:spcPct val="100000"/>
-                </a:lnSpc>
-                <a:spcAft>
-                  <a:spcPts val="300"/>
-                </a:spcAft>
-              </a:pPr>
-              <a:r>
-                <a:rPr sz="2400" b="0" i="0">
-                  <a:solidFill>
-                    <a:srgbClr val="000000"/>
-                  </a:solidFill>
-                  <a:latin typeface="Times New Roman"/>
-                </a:rPr>
-                <a:t>• Longitudinal studies with validated measures</a:t>
-              </a:r>
-            </a:p>
-            <a:p>
-              <a:pPr algn="l">
-                <a:lnSpc>
-                  <a:spcPct val="100000"/>
-                </a:lnSpc>
-                <a:spcAft>
-                  <a:spcPts val="300"/>
-                </a:spcAft>
-              </a:pPr>
-              <a:r>
-                <a:rPr sz="2400" b="0" i="0">
-                  <a:solidFill>
-                    <a:srgbClr val="000000"/>
-                  </a:solidFill>
-                  <a:latin typeface="Times New Roman"/>
-                </a:rPr>
-                <a:t>• Trials of psychosocial interventions in routine care</a:t>
-              </a:r>
-            </a:p>
-            <a:p>
-              <a:pPr algn="l">
-                <a:lnSpc>
-                  <a:spcPct val="100000"/>
-                </a:lnSpc>
-                <a:spcAft>
-                  <a:spcPts val="300"/>
-                </a:spcAft>
-              </a:pPr>
-              <a:r>
-                <a:rPr sz="2400" b="0" i="0">
-                  <a:solidFill>
-                    <a:srgbClr val="000000"/>
-                  </a:solidFill>
-                  <a:latin typeface="Times New Roman"/>
-                </a:rPr>
-                <a:t>• Research in underrepresented and low-resource settings</a:t>
-              </a:r>
-            </a:p>
-          </p:txBody>
-        </p:sp>
-        <p:sp>
-          <p:nvSpPr>
-            <p:cNvPr id="322" name="TextBox 321">
-              <a:extLst>
-                <a:ext uri="{FF2B5EF4-FFF2-40B4-BE49-F238E27FC236}">
-                  <a16:creationId xmlns:a16="http://schemas.microsoft.com/office/drawing/2014/main" id="{FF9BD680-0755-89B6-9224-48721A47729A}"/>
-                </a:ext>
-              </a:extLst>
-            </p:cNvPr>
-            <p:cNvSpPr txBox="1"/>
-            <p:nvPr/>
-          </p:nvSpPr>
-          <p:spPr>
-            <a:xfrm>
-              <a:off x="34080553" y="17757963"/>
-              <a:ext cx="9295886" cy="1268441"/>
-            </a:xfrm>
-            <a:prstGeom prst="rect">
-              <a:avLst/>
-            </a:prstGeom>
+          </a:ln>
+        </p:spPr>
+        <p:txBody>
+          <a:bodyPr wrap="square" lIns="131445" tIns="65723" rIns="131445" bIns="65723" rtlCol="0">
+            <a:spAutoFit/>
+          </a:bodyPr>
+          <a:lstStyle/>
+          <a:p>
+            <a:pPr algn="ctr"/>
+            <a:r>
+              <a:rPr lang="en-US" sz="4800" dirty="0">
+                <a:latin typeface="Times New Roman"/>
+                <a:cs typeface="Times New Roman"/>
+              </a:rPr>
+              <a:t>Methods</a:t>
+            </a:r>
+            <a:endParaRPr lang="en-US" sz="6000" dirty="0">
+              <a:latin typeface="Times New Roman"/>
+              <a:cs typeface="Times New Roman"/>
+            </a:endParaRPr>
+          </a:p>
+        </p:txBody>
+      </p:sp>
+      <p:sp>
+        <p:nvSpPr>
+          <p:cNvPr id="321" name="TextBox 320">
+            <a:extLst>
+              <a:ext uri="{FF2B5EF4-FFF2-40B4-BE49-F238E27FC236}">
+                <a16:creationId xmlns:a16="http://schemas.microsoft.com/office/drawing/2014/main" id="{CB19DFF1-BA24-B68B-4652-0F80775C03FA}"/>
+              </a:ext>
+            </a:extLst>
+          </p:cNvPr>
+          <p:cNvSpPr txBox="1"/>
+          <p:nvPr/>
+        </p:nvSpPr>
+        <p:spPr>
+          <a:xfrm>
+            <a:off x="34006536" y="19156680"/>
+            <a:ext cx="9253728" cy="7406640"/>
+          </a:xfrm>
+          <a:prstGeom prst="rect">
+            <a:avLst/>
+          </a:prstGeom>
+          <a:solidFill>
+            <a:srgbClr val="FFFFFF"/>
+          </a:solidFill>
+          <a:ln cap="rnd">
             <a:solidFill>
-              <a:srgbClr val="0A254E"/>
+              <a:schemeClr val="bg1"/>
             </a:solidFill>
-            <a:ln>
-              <a:solidFill>
-                <a:schemeClr val="bg1"/>
-              </a:solidFill>
-            </a:ln>
-          </p:spPr>
-          <p:txBody>
-            <a:bodyPr wrap="square" lIns="131445" tIns="65723" rIns="131445" bIns="65723" rtlCol="0">
-              <a:spAutoFit/>
-            </a:bodyPr>
-            <a:lstStyle/>
-            <a:p>
-              <a:pPr algn="ctr"/>
-              <a:r>
-                <a:rPr lang="en-US" sz="4800" dirty="0">
-                  <a:latin typeface="Garamond"/>
-                  <a:cs typeface="Garamond"/>
-                </a:rPr>
-                <a:t>Public Health Implications and Future Work</a:t>
-              </a:r>
-              <a:endParaRPr lang="en-US" sz="6000" dirty="0">
-                <a:latin typeface="Garamond"/>
+          </a:ln>
+        </p:spPr>
+        <p:txBody>
+          <a:bodyPr wrap="square" lIns="182880" rIns="182880" rtlCol="0" anchor="t">
+            <a:noAutofit/>
+          </a:bodyPr>
+          <a:lstStyle/>
+          <a:p>
+            <a:pPr algn="just">
+              <a:lnSpc>
+                <a:spcPct val="100000"/>
+              </a:lnSpc>
+              <a:spcAft>
+                <a:spcPts val="300"/>
+              </a:spcAft>
+            </a:pPr>
+            <a:r>
+              <a:rPr sz="2200" b="1" i="0">
+                <a:solidFill>
+                  <a:srgbClr val="000000"/>
+                </a:solidFill>
+                <a:latin typeface="Times New Roman"/>
+              </a:rPr>
+              <a:t>Public Health Implications</a:t>
+            </a:r>
+          </a:p>
+          <a:p>
+            <a:pPr algn="l" marL="274320" indent="-274320">
+              <a:lnSpc>
+                <a:spcPct val="100000"/>
+              </a:lnSpc>
+              <a:spcAft>
+                <a:spcPts val="300"/>
+              </a:spcAft>
+            </a:pPr>
+            <a:r>
+              <a:rPr sz="2200" b="0" i="0">
+                <a:solidFill>
+                  <a:srgbClr val="000000"/>
+                </a:solidFill>
+                <a:latin typeface="Times New Roman"/>
+              </a:rPr>
+              <a:t>• Integrate psychosocial screening and support into MRKH diagnostic pathways</a:t>
+            </a:r>
+            <a:r>
+              <a:rPr sz="2200" b="0" i="0" baseline="30000">
+                <a:solidFill>
+                  <a:srgbClr val="000000"/>
+                </a:solidFill>
+                <a:latin typeface="Times New Roman"/>
+              </a:rPr>
+              <a:t>1</a:t>
+            </a:r>
+          </a:p>
+          <a:p>
+            <a:pPr algn="l" marL="274320" indent="-274320">
+              <a:lnSpc>
+                <a:spcPct val="100000"/>
+              </a:lnSpc>
+              <a:spcAft>
+                <a:spcPts val="300"/>
+              </a:spcAft>
+            </a:pPr>
+            <a:r>
+              <a:rPr sz="2200" b="0" i="0">
+                <a:solidFill>
+                  <a:srgbClr val="000000"/>
+                </a:solidFill>
+                <a:latin typeface="Times New Roman"/>
+              </a:rPr>
+              <a:t>• Build multidisciplinary teams that include psychology and social work</a:t>
+            </a:r>
+          </a:p>
+          <a:p>
+            <a:pPr algn="l" marL="274320" indent="-274320">
+              <a:lnSpc>
+                <a:spcPct val="100000"/>
+              </a:lnSpc>
+              <a:spcAft>
+                <a:spcPts val="300"/>
+              </a:spcAft>
+            </a:pPr>
+            <a:r>
+              <a:rPr sz="2200" b="0" i="0">
+                <a:solidFill>
+                  <a:srgbClr val="000000"/>
+                </a:solidFill>
+                <a:latin typeface="Times New Roman"/>
+              </a:rPr>
+              <a:t>• Pair vaginal lengthening treatment with psychosexual counseling</a:t>
+            </a:r>
+          </a:p>
+          <a:p>
+            <a:pPr algn="l" marL="274320" indent="-274320">
+              <a:lnSpc>
+                <a:spcPct val="100000"/>
+              </a:lnSpc>
+              <a:spcAft>
+                <a:spcPts val="300"/>
+              </a:spcAft>
+            </a:pPr>
+            <a:r>
+              <a:rPr sz="2200" b="0" i="0">
+                <a:solidFill>
+                  <a:srgbClr val="000000"/>
+                </a:solidFill>
+                <a:latin typeface="Times New Roman"/>
+              </a:rPr>
+              <a:t>• Train providers in sensitive, non-stigmatizing communication</a:t>
+            </a:r>
+          </a:p>
+          <a:p>
+            <a:pPr algn="l" marL="274320" indent="-274320">
+              <a:lnSpc>
+                <a:spcPct val="100000"/>
+              </a:lnSpc>
+              <a:spcAft>
+                <a:spcPts val="300"/>
+              </a:spcAft>
+            </a:pPr>
+            <a:r>
+              <a:rPr sz="2200" b="0" i="0">
+                <a:solidFill>
+                  <a:srgbClr val="000000"/>
+                </a:solidFill>
+                <a:latin typeface="Times New Roman"/>
+              </a:rPr>
+              <a:t>• Expand peer support networks, including online communities</a:t>
+            </a:r>
+          </a:p>
+          <a:p>
+            <a:pPr algn="just">
+              <a:lnSpc>
+                <a:spcPct val="100000"/>
+              </a:lnSpc>
+              <a:spcAft>
+                <a:spcPts val="300"/>
+              </a:spcAft>
+            </a:pPr>
+            <a:r>
+              <a:rPr sz="2200" b="1" i="0">
+                <a:solidFill>
+                  <a:srgbClr val="000000"/>
+                </a:solidFill>
+                <a:latin typeface="Times New Roman"/>
+              </a:rPr>
+              <a:t>Future Research</a:t>
+            </a:r>
+          </a:p>
+          <a:p>
+            <a:pPr algn="l" marL="274320" indent="-274320">
+              <a:lnSpc>
+                <a:spcPct val="100000"/>
+              </a:lnSpc>
+              <a:spcAft>
+                <a:spcPts val="300"/>
+              </a:spcAft>
+            </a:pPr>
+            <a:r>
+              <a:rPr sz="2200" b="0" i="0">
+                <a:solidFill>
+                  <a:srgbClr val="000000"/>
+                </a:solidFill>
+                <a:latin typeface="Times New Roman"/>
+              </a:rPr>
+              <a:t>• Longitudinal studies using validated mental health measures</a:t>
+            </a:r>
+          </a:p>
+          <a:p>
+            <a:pPr algn="l" marL="274320" indent="-274320">
+              <a:lnSpc>
+                <a:spcPct val="100000"/>
+              </a:lnSpc>
+              <a:spcAft>
+                <a:spcPts val="300"/>
+              </a:spcAft>
+            </a:pPr>
+            <a:r>
+              <a:rPr sz="2200" b="0" i="0">
+                <a:solidFill>
+                  <a:srgbClr val="000000"/>
+                </a:solidFill>
+                <a:latin typeface="Times New Roman"/>
+              </a:rPr>
+              <a:t>• Trials of psychosocial interventions delivered in routine care</a:t>
+            </a:r>
+          </a:p>
+          <a:p>
+            <a:pPr algn="l" marL="274320" indent="-274320">
+              <a:lnSpc>
+                <a:spcPct val="100000"/>
+              </a:lnSpc>
+              <a:spcAft>
+                <a:spcPts val="300"/>
+              </a:spcAft>
+            </a:pPr>
+            <a:r>
+              <a:rPr sz="2200" b="0" i="0">
+                <a:solidFill>
+                  <a:srgbClr val="000000"/>
+                </a:solidFill>
+                <a:latin typeface="Times New Roman"/>
+              </a:rPr>
+              <a:t>• Studies in Africa, South America, and other low-resource settings</a:t>
+            </a:r>
+          </a:p>
+          <a:p>
+            <a:pPr algn="just">
+              <a:lnSpc>
+                <a:spcPct val="100000"/>
+              </a:lnSpc>
+              <a:spcAft>
+                <a:spcPts val="300"/>
+              </a:spcAft>
+            </a:pPr>
+            <a:r>
+              <a:rPr sz="2200" b="1" i="0">
+                <a:solidFill>
+                  <a:srgbClr val="000000"/>
+                </a:solidFill>
+                <a:latin typeface="Times New Roman"/>
+              </a:rPr>
+              <a:t>Conclusion</a:t>
+            </a:r>
+          </a:p>
+          <a:p>
+            <a:pPr algn="just">
+              <a:lnSpc>
+                <a:spcPct val="100000"/>
+              </a:lnSpc>
+              <a:spcAft>
+                <a:spcPts val="300"/>
+              </a:spcAft>
+            </a:pPr>
+            <a:r>
+              <a:rPr sz="2200" b="0" i="0">
+                <a:solidFill>
+                  <a:srgbClr val="000000"/>
+                </a:solidFill>
+                <a:latin typeface="Times New Roman"/>
+              </a:rPr>
+              <a:t>MRKH carries a substantial psychosocial burden that remains under-integrated into care. Mental health–inclusive, multidisciplinary care is needed to close this gap.</a:t>
+            </a:r>
+          </a:p>
+          <a:p>
+            <a:pPr algn="just">
+              <a:lnSpc>
+                <a:spcPct val="100000"/>
+              </a:lnSpc>
+              <a:spcAft>
+                <a:spcPts val="300"/>
+              </a:spcAft>
+            </a:pPr>
+            <a:r>
+              <a:rPr sz="2200" b="0" i="1">
+                <a:solidFill>
+                  <a:srgbClr val="000000"/>
+                </a:solidFill>
+                <a:latin typeface="Times New Roman"/>
+              </a:rPr>
+              <a:t>Acknowledgements: mentorship by Dr. Paul Okojie and Dr. Robyn Anderson; no external funding.</a:t>
+            </a:r>
+          </a:p>
+        </p:txBody>
+      </p:sp>
+      <p:sp>
+        <p:nvSpPr>
+          <p:cNvPr id="322" name="TextBox 321">
+            <a:extLst>
+              <a:ext uri="{FF2B5EF4-FFF2-40B4-BE49-F238E27FC236}">
+                <a16:creationId xmlns:a16="http://schemas.microsoft.com/office/drawing/2014/main" id="{FF9BD680-0755-89B6-9224-48721A47729A}"/>
+              </a:ext>
+            </a:extLst>
+          </p:cNvPr>
+          <p:cNvSpPr txBox="1"/>
+          <p:nvPr/>
+        </p:nvSpPr>
+        <p:spPr>
+          <a:xfrm>
+            <a:off x="34006536" y="18288000"/>
+            <a:ext cx="9253728" cy="868680"/>
+          </a:xfrm>
+          <a:prstGeom prst="rect">
+            <a:avLst/>
+          </a:prstGeom>
+          <a:solidFill>
+            <a:srgbClr val="0A254E"/>
+          </a:solidFill>
+          <a:ln>
+            <a:solidFill>
+              <a:schemeClr val="bg1"/>
+            </a:solidFill>
+          </a:ln>
+        </p:spPr>
+        <p:txBody>
+          <a:bodyPr wrap="square" lIns="131445" tIns="65723" rIns="131445" bIns="65723" rtlCol="0">
+            <a:spAutoFit/>
+          </a:bodyPr>
+          <a:lstStyle/>
+          <a:p>
+            <a:pPr algn="ctr"/>
+            <a:r>
+              <a:rPr lang="en-US" sz="4800" dirty="0">
+                <a:latin typeface="Times New Roman"/>
                 <a:cs typeface="Garamond"/>
-              </a:endParaRPr>
-            </a:p>
-          </p:txBody>
-        </p:sp>
-      </p:grpSp>
+              </a:rPr>
+              <a:t>Implications and Conclusion</a:t>
+            </a:r>
+            <a:endParaRPr lang="en-US" sz="6000" dirty="0">
+              <a:latin typeface="Garamond"/>
+              <a:cs typeface="Garamond"/>
+            </a:endParaRPr>
+          </a:p>
+        </p:txBody>
+      </p:sp>
       <p:sp>
         <p:nvSpPr>
           <p:cNvPr id="323" name="TextBox 322">
@@ -7629,354 +7699,671 @@
           </a:p>
         </p:txBody>
       </p:sp>
-      <p:grpSp>
-        <p:nvGrpSpPr>
-          <p:cNvPr id="324" name="Group 323">
+      <p:sp>
+        <p:nvSpPr>
+          <p:cNvPr id="325" name="TextBox 324">
             <a:extLst>
               <a:ext uri="{FF2B5EF4-FFF2-40B4-BE49-F238E27FC236}">
-                <a16:creationId xmlns:a16="http://schemas.microsoft.com/office/drawing/2014/main" id="{C378E3EE-14D9-F365-6D63-2860BE15E8A3}"/>
+                <a16:creationId xmlns:a16="http://schemas.microsoft.com/office/drawing/2014/main" id="{C035F57E-62DB-372A-C78A-9EAA827DE73E}"/>
               </a:ext>
             </a:extLst>
           </p:cNvPr>
-          <p:cNvGrpSpPr/>
+          <p:cNvSpPr txBox="1"/>
           <p:nvPr/>
-        </p:nvGrpSpPr>
-        <p:grpSpPr>
+        </p:nvSpPr>
+        <p:spPr>
           <a:xfrm>
-            <a:off x="34006807" y="4220388"/>
-            <a:ext cx="9256360" cy="13555315"/>
-            <a:chOff x="34040395" y="3962579"/>
-            <a:chExt cx="9212446" cy="11915692"/>
+            <a:off x="34006536" y="5093208"/>
+            <a:ext cx="9253728" cy="13103352"/>
           </a:xfrm>
-        </p:grpSpPr>
-        <p:sp>
-          <p:nvSpPr>
-            <p:cNvPr id="325" name="TextBox 324">
-              <a:extLst>
-                <a:ext uri="{FF2B5EF4-FFF2-40B4-BE49-F238E27FC236}">
-                  <a16:creationId xmlns:a16="http://schemas.microsoft.com/office/drawing/2014/main" id="{C035F57E-62DB-372A-C78A-9EAA827DE73E}"/>
-                </a:ext>
-              </a:extLst>
-            </p:cNvPr>
-            <p:cNvSpPr txBox="1"/>
-            <p:nvPr/>
-          </p:nvSpPr>
-          <p:spPr>
-            <a:xfrm>
-              <a:off x="34040395" y="5147429"/>
-              <a:ext cx="9212446" cy="10730842"/>
-            </a:xfrm>
-            <a:prstGeom prst="rect">
-              <a:avLst/>
-            </a:prstGeom>
+          <a:prstGeom prst="rect">
+            <a:avLst/>
+          </a:prstGeom>
+          <a:solidFill>
+            <a:srgbClr val="FFFFFF"/>
+          </a:solidFill>
+          <a:ln cap="rnd">
             <a:solidFill>
-              <a:srgbClr val="FFFFFF"/>
+              <a:schemeClr val="bg1"/>
             </a:solidFill>
-            <a:ln cap="rnd">
-              <a:solidFill>
-                <a:schemeClr val="bg1"/>
-              </a:solidFill>
-            </a:ln>
-          </p:spPr>
-          <p:txBody>
-            <a:bodyPr wrap="square" lIns="182880" rIns="182880" rtlCol="0">
-              <a:noAutofit/>
-            </a:bodyPr>
-            <a:lstStyle/>
-            <a:p>
-              <a:pPr algn="just"/>
-              <a:endParaRPr lang="en-US" sz="1800" dirty="0">
-                <a:latin typeface="Garamond"/>
-                <a:cs typeface="Garamond"/>
-              </a:endParaRPr>
-            </a:p>
-            <a:p>
-              <a:pPr algn="just"/>
-              <a:endParaRPr lang="en-US" sz="1800" dirty="0">
-                <a:latin typeface="Garamond"/>
-                <a:cs typeface="Garamond"/>
-              </a:endParaRPr>
-            </a:p>
-            <a:p>
-              <a:pPr algn="just"/>
-              <a:endParaRPr lang="en-US" sz="1800" dirty="0">
-                <a:latin typeface="Garamond"/>
-                <a:cs typeface="Garamond"/>
-              </a:endParaRPr>
-            </a:p>
-            <a:p>
-              <a:pPr algn="just"/>
-              <a:endParaRPr lang="en-US" sz="1800" dirty="0">
-                <a:latin typeface="Garamond"/>
-                <a:cs typeface="Garamond"/>
-              </a:endParaRPr>
-            </a:p>
-            <a:p>
-              <a:pPr algn="just"/>
-              <a:endParaRPr lang="en-US" sz="1800" dirty="0">
-                <a:latin typeface="Garamond"/>
-                <a:cs typeface="Garamond"/>
-              </a:endParaRPr>
-            </a:p>
-            <a:p>
-              <a:pPr algn="just"/>
-              <a:endParaRPr lang="en-US" sz="1800" dirty="0">
-                <a:latin typeface="Garamond"/>
-                <a:cs typeface="Garamond"/>
-              </a:endParaRPr>
-            </a:p>
-            <a:p>
-              <a:pPr algn="just"/>
-              <a:endParaRPr lang="en-US" sz="1800" dirty="0">
-                <a:latin typeface="Garamond"/>
-                <a:cs typeface="Garamond"/>
-              </a:endParaRPr>
-            </a:p>
-            <a:p>
-              <a:pPr algn="just"/>
-              <a:endParaRPr lang="en-US" sz="1800" dirty="0">
-                <a:latin typeface="Garamond"/>
-                <a:cs typeface="Garamond"/>
-              </a:endParaRPr>
-            </a:p>
-            <a:p>
-              <a:pPr algn="just"/>
-              <a:endParaRPr lang="en-US" sz="1800" dirty="0">
-                <a:latin typeface="Garamond"/>
-                <a:cs typeface="Garamond"/>
-              </a:endParaRPr>
-            </a:p>
-          </p:txBody>
-        </p:sp>
-        <p:sp>
-          <p:nvSpPr>
-            <p:cNvPr id="326" name="TextBox 325">
-              <a:extLst>
-                <a:ext uri="{FF2B5EF4-FFF2-40B4-BE49-F238E27FC236}">
-                  <a16:creationId xmlns:a16="http://schemas.microsoft.com/office/drawing/2014/main" id="{2270543F-2128-4E8D-CCFD-F12E4C7A64FC}"/>
-                </a:ext>
-              </a:extLst>
-            </p:cNvPr>
-            <p:cNvSpPr txBox="1"/>
-            <p:nvPr/>
-          </p:nvSpPr>
-          <p:spPr>
-            <a:xfrm>
-              <a:off x="34040395" y="3962579"/>
-              <a:ext cx="9212446" cy="1437942"/>
-            </a:xfrm>
-            <a:prstGeom prst="rect">
-              <a:avLst/>
-            </a:prstGeom>
+          </a:ln>
+        </p:spPr>
+        <p:txBody>
+          <a:bodyPr wrap="square" lIns="182880" rIns="182880" rtlCol="0">
+            <a:noAutofit/>
+          </a:bodyPr>
+          <a:lstStyle/>
+          <a:p>
+            <a:pPr algn="just"/>
+            <a:endParaRPr lang="en-US" sz="1800" dirty="0">
+              <a:latin typeface="Garamond"/>
+              <a:cs typeface="Garamond"/>
+            </a:endParaRPr>
+          </a:p>
+          <a:p>
+            <a:pPr algn="just"/>
+            <a:endParaRPr lang="en-US" sz="1800" dirty="0">
+              <a:latin typeface="Garamond"/>
+              <a:cs typeface="Garamond"/>
+            </a:endParaRPr>
+          </a:p>
+          <a:p>
+            <a:pPr algn="just"/>
+            <a:endParaRPr lang="en-US" sz="1800" dirty="0">
+              <a:latin typeface="Garamond"/>
+              <a:cs typeface="Garamond"/>
+            </a:endParaRPr>
+          </a:p>
+          <a:p>
+            <a:pPr algn="just"/>
+            <a:endParaRPr lang="en-US" sz="1800" dirty="0">
+              <a:latin typeface="Garamond"/>
+              <a:cs typeface="Garamond"/>
+            </a:endParaRPr>
+          </a:p>
+          <a:p>
+            <a:pPr algn="just"/>
+            <a:endParaRPr lang="en-US" sz="1800" dirty="0">
+              <a:latin typeface="Garamond"/>
+              <a:cs typeface="Garamond"/>
+            </a:endParaRPr>
+          </a:p>
+          <a:p>
+            <a:pPr algn="just"/>
+            <a:endParaRPr lang="en-US" sz="1800" dirty="0">
+              <a:latin typeface="Garamond"/>
+              <a:cs typeface="Garamond"/>
+            </a:endParaRPr>
+          </a:p>
+          <a:p>
+            <a:pPr algn="just"/>
+            <a:endParaRPr lang="en-US" sz="1800" dirty="0">
+              <a:latin typeface="Garamond"/>
+              <a:cs typeface="Garamond"/>
+            </a:endParaRPr>
+          </a:p>
+          <a:p>
+            <a:pPr algn="just"/>
+            <a:endParaRPr lang="en-US" sz="1800" dirty="0">
+              <a:latin typeface="Garamond"/>
+              <a:cs typeface="Garamond"/>
+            </a:endParaRPr>
+          </a:p>
+          <a:p>
+            <a:pPr algn="just"/>
+            <a:endParaRPr lang="en-US" sz="1800" dirty="0">
+              <a:latin typeface="Garamond"/>
+              <a:cs typeface="Garamond"/>
+            </a:endParaRPr>
+          </a:p>
+        </p:txBody>
+      </p:sp>
+      <p:sp>
+        <p:nvSpPr>
+          <p:cNvPr id="326" name="TextBox 325">
+            <a:extLst>
+              <a:ext uri="{FF2B5EF4-FFF2-40B4-BE49-F238E27FC236}">
+                <a16:creationId xmlns:a16="http://schemas.microsoft.com/office/drawing/2014/main" id="{2270543F-2128-4E8D-CCFD-F12E4C7A64FC}"/>
+              </a:ext>
+            </a:extLst>
+          </p:cNvPr>
+          <p:cNvSpPr txBox="1"/>
+          <p:nvPr/>
+        </p:nvSpPr>
+        <p:spPr>
+          <a:xfrm>
+            <a:off x="34006536" y="4224528"/>
+            <a:ext cx="9253728" cy="868680"/>
+          </a:xfrm>
+          <a:prstGeom prst="rect">
+            <a:avLst/>
+          </a:prstGeom>
+          <a:solidFill>
+            <a:srgbClr val="0A254E"/>
+          </a:solidFill>
+          <a:ln>
             <a:solidFill>
-              <a:srgbClr val="0A254E"/>
+              <a:schemeClr val="bg1"/>
             </a:solidFill>
-            <a:ln>
-              <a:solidFill>
-                <a:schemeClr val="bg1"/>
-              </a:solidFill>
-            </a:ln>
-          </p:spPr>
-          <p:txBody>
-            <a:bodyPr wrap="square" lIns="131445" tIns="65723" rIns="131445" bIns="65723" rtlCol="0">
-              <a:spAutoFit/>
-            </a:bodyPr>
-            <a:lstStyle/>
-            <a:p>
-              <a:pPr algn="ctr"/>
-              <a:r>
-                <a:rPr lang="en-US" sz="4800" dirty="0">
-                  <a:latin typeface="Times New Roman"/>
-                  <a:cs typeface="Times New Roman"/>
-                </a:rPr>
-                <a:t>Results, Discussion, Conclusion, and Limitations</a:t>
-              </a:r>
-              <a:endParaRPr lang="en-US" sz="6000" dirty="0">
+          </a:ln>
+        </p:spPr>
+        <p:txBody>
+          <a:bodyPr wrap="square" lIns="131445" tIns="65723" rIns="131445" bIns="65723" rtlCol="0">
+            <a:spAutoFit/>
+          </a:bodyPr>
+          <a:lstStyle/>
+          <a:p>
+            <a:pPr algn="ctr"/>
+            <a:r>
+              <a:rPr lang="en-US" sz="4800" dirty="0">
                 <a:latin typeface="Times New Roman"/>
                 <a:cs typeface="Times New Roman"/>
-              </a:endParaRPr>
-            </a:p>
-          </p:txBody>
-        </p:sp>
-        <p:sp>
-          <p:nvSpPr>
-            <p:cNvPr id="327" name="Rectangle 326">
-              <a:extLst>
-                <a:ext uri="{FF2B5EF4-FFF2-40B4-BE49-F238E27FC236}">
-                  <a16:creationId xmlns:a16="http://schemas.microsoft.com/office/drawing/2014/main" id="{3A97DB32-0FF1-1C0F-BA0A-FB20D75949A1}"/>
-                </a:ext>
-              </a:extLst>
-            </p:cNvPr>
-            <p:cNvSpPr/>
-            <p:nvPr/>
-          </p:nvSpPr>
-          <p:spPr>
-            <a:xfrm>
-              <a:off x="34309049" y="5632989"/>
-              <a:ext cx="8943792" cy="7201734"/>
-            </a:xfrm>
-            <a:prstGeom prst="rect">
-              <a:avLst/>
-            </a:prstGeom>
-          </p:spPr>
-          <p:txBody>
-            <a:bodyPr wrap="square">
-              <a:noAutofit/>
-            </a:bodyPr>
-            <a:lstStyle/>
-            <a:p>
-              <a:pPr algn="just">
-                <a:lnSpc>
-                  <a:spcPct val="100000"/>
-                </a:lnSpc>
-                <a:spcAft>
-                  <a:spcPts val="400"/>
-                </a:spcAft>
-              </a:pPr>
-              <a:r>
-                <a:rPr sz="2400" b="1" i="0">
-                  <a:solidFill>
-                    <a:srgbClr val="000000"/>
-                  </a:solidFill>
-                  <a:latin typeface="Times New Roman"/>
-                </a:rPr>
-                <a:t>Results</a:t>
-              </a:r>
-            </a:p>
-            <a:p>
-              <a:pPr algn="just">
-                <a:lnSpc>
-                  <a:spcPct val="100000"/>
-                </a:lnSpc>
-                <a:spcAft>
-                  <a:spcPts val="400"/>
-                </a:spcAft>
-              </a:pPr>
-              <a:r>
-                <a:rPr sz="2400" b="0" i="0">
-                  <a:solidFill>
-                    <a:srgbClr val="000000"/>
-                  </a:solidFill>
-                  <a:latin typeface="Times New Roman"/>
-                </a:rPr>
-                <a:t>Of 516 records, 324 were screened and 35 studies included: 18 quantitative, 14 qualitative, 2 mixed-methods, 1 not reported. Studies came from Europe (14), Asia (14), North America (3), Africa (1), and Oceania (1); none from South America. Psychosexual and relational challenges were most common (69%); depression and anxiety were measured least (40%), with mixed findings.</a:t>
-              </a:r>
-            </a:p>
-            <a:p>
-              <a:pPr algn="just">
-                <a:lnSpc>
-                  <a:spcPct val="100000"/>
-                </a:lnSpc>
-                <a:spcAft>
-                  <a:spcPts val="400"/>
-                </a:spcAft>
-              </a:pPr>
-              <a:r>
-                <a:rPr sz="2400" b="1" i="0">
-                  <a:solidFill>
-                    <a:srgbClr val="000000"/>
-                  </a:solidFill>
-                  <a:latin typeface="Times New Roman"/>
-                </a:rPr>
-                <a:t>Discussion</a:t>
-              </a:r>
-            </a:p>
-            <a:p>
-              <a:pPr algn="just">
-                <a:lnSpc>
-                  <a:spcPct val="100000"/>
-                </a:lnSpc>
-                <a:spcAft>
-                  <a:spcPts val="400"/>
-                </a:spcAft>
-              </a:pPr>
-              <a:r>
-                <a:rPr sz="2400" b="0" i="0">
-                  <a:solidFill>
-                    <a:srgbClr val="000000"/>
-                  </a:solidFill>
-                  <a:latin typeface="Times New Roman"/>
-                </a:rPr>
-                <a:t>Findings align with earlier evidence</a:t>
-              </a:r>
-              <a:r>
-                <a:rPr sz="2400" b="0" i="0" baseline="30000">
-                  <a:solidFill>
-                    <a:srgbClr val="000000"/>
-                  </a:solidFill>
-                  <a:latin typeface="Times New Roman"/>
-                </a:rPr>
-                <a:t>5–7</a:t>
-              </a:r>
-              <a:r>
-                <a:rPr sz="2400" b="0" i="0">
-                  <a:solidFill>
-                    <a:srgbClr val="000000"/>
-                  </a:solidFill>
-                  <a:latin typeface="Times New Roman"/>
-                </a:rPr>
-                <a:t> and a prior review highlighting sexual esteem and genital image.</a:t>
-              </a:r>
-              <a:r>
-                <a:rPr sz="2400" b="0" i="0" baseline="30000">
-                  <a:solidFill>
-                    <a:srgbClr val="000000"/>
-                  </a:solidFill>
-                  <a:latin typeface="Times New Roman"/>
-                </a:rPr>
-                <a:t>8</a:t>
-              </a:r>
-              <a:r>
-                <a:rPr sz="2400" b="0" i="0">
-                  <a:solidFill>
-                    <a:srgbClr val="000000"/>
-                  </a:solidFill>
-                  <a:latin typeface="Times New Roman"/>
-                </a:rPr>
-                <a:t> Coping relied on peer support and self-management; only 2 studies tested interventions. Healthcare gaps included providers' limited knowledge of MRKH and insensitive communication at diagnosis.</a:t>
-              </a:r>
-            </a:p>
-            <a:p>
-              <a:pPr algn="just">
-                <a:lnSpc>
-                  <a:spcPct val="100000"/>
-                </a:lnSpc>
-                <a:spcAft>
-                  <a:spcPts val="400"/>
-                </a:spcAft>
-              </a:pPr>
-              <a:r>
-                <a:rPr sz="2400" b="1" i="0">
-                  <a:solidFill>
-                    <a:srgbClr val="000000"/>
-                  </a:solidFill>
-                  <a:latin typeface="Times New Roman"/>
-                </a:rPr>
-                <a:t>Conclusion</a:t>
-              </a:r>
-            </a:p>
-            <a:p>
-              <a:pPr algn="just">
-                <a:lnSpc>
-                  <a:spcPct val="100000"/>
-                </a:lnSpc>
-                <a:spcAft>
-                  <a:spcPts val="400"/>
-                </a:spcAft>
-              </a:pPr>
-              <a:r>
-                <a:rPr sz="2400" b="0" i="0">
-                  <a:solidFill>
-                    <a:srgbClr val="000000"/>
-                  </a:solidFill>
-                  <a:latin typeface="Times New Roman"/>
-                </a:rPr>
-                <a:t>Psychosocial burden in MRKH is substantial yet under-integrated into care; multidisciplinary, mental health–inclusive care is needed.</a:t>
-              </a:r>
-            </a:p>
-          </p:txBody>
-        </p:sp>
-      </p:grpSp>
+              </a:rPr>
+              <a:t>Results and Discussion</a:t>
+            </a:r>
+            <a:endParaRPr lang="en-US" sz="6000" dirty="0">
+              <a:latin typeface="Times New Roman"/>
+              <a:cs typeface="Times New Roman"/>
+            </a:endParaRPr>
+          </a:p>
+        </p:txBody>
+      </p:sp>
+      <p:sp>
+        <p:nvSpPr>
+          <p:cNvPr id="327" name="Rectangle 326">
+            <a:extLst>
+              <a:ext uri="{FF2B5EF4-FFF2-40B4-BE49-F238E27FC236}">
+                <a16:creationId xmlns:a16="http://schemas.microsoft.com/office/drawing/2014/main" id="{3A97DB32-0FF1-1C0F-BA0A-FB20D75949A1}"/>
+              </a:ext>
+            </a:extLst>
+          </p:cNvPr>
+          <p:cNvSpPr/>
+          <p:nvPr/>
+        </p:nvSpPr>
+        <p:spPr>
+          <a:xfrm>
+            <a:off x="34116263" y="5138928"/>
+            <a:ext cx="9034272" cy="13011912"/>
+          </a:xfrm>
+          <a:prstGeom prst="rect">
+            <a:avLst/>
+          </a:prstGeom>
+        </p:spPr>
+        <p:txBody>
+          <a:bodyPr wrap="square" anchor="t">
+            <a:noAutofit/>
+          </a:bodyPr>
+          <a:lstStyle/>
+          <a:p>
+            <a:pPr algn="just">
+              <a:lnSpc>
+                <a:spcPct val="100000"/>
+              </a:lnSpc>
+              <a:spcAft>
+                <a:spcPts val="400"/>
+              </a:spcAft>
+            </a:pPr>
+            <a:r>
+              <a:rPr sz="2200" b="1" i="0">
+                <a:solidFill>
+                  <a:srgbClr val="000000"/>
+                </a:solidFill>
+                <a:latin typeface="Times New Roman"/>
+              </a:rPr>
+              <a:t>Key Findings</a:t>
+            </a:r>
+          </a:p>
+          <a:p>
+            <a:pPr algn="just">
+              <a:lnSpc>
+                <a:spcPct val="100000"/>
+              </a:lnSpc>
+              <a:spcAft>
+                <a:spcPts val="400"/>
+              </a:spcAft>
+            </a:pPr>
+            <a:r>
+              <a:rPr sz="2200" b="0" i="0">
+                <a:solidFill>
+                  <a:srgbClr val="000000"/>
+                </a:solidFill>
+                <a:latin typeface="Times New Roman"/>
+              </a:rPr>
+              <a:t>35 studies from 2019–2026 were included (18 quantitative, 14 qualitative, 2 mixed-methods), with samples of 5 to 616 participants (Figures 1–5).</a:t>
+            </a:r>
+          </a:p>
+          <a:p>
+            <a:pPr algn="l" marL="274320" indent="-274320">
+              <a:lnSpc>
+                <a:spcPct val="100000"/>
+              </a:lnSpc>
+              <a:spcAft>
+                <a:spcPts val="400"/>
+              </a:spcAft>
+            </a:pPr>
+            <a:r>
+              <a:rPr sz="2200" b="0" i="0">
+                <a:solidFill>
+                  <a:srgbClr val="000000"/>
+                </a:solidFill>
+                <a:latin typeface="Times New Roman"/>
+              </a:rPr>
+              <a:t>• </a:t>
+            </a:r>
+            <a:r>
+              <a:rPr sz="2200" b="1" i="0">
+                <a:solidFill>
+                  <a:srgbClr val="000000"/>
+                </a:solidFill>
+                <a:latin typeface="Times New Roman"/>
+              </a:rPr>
+              <a:t>Psychosexual and relational (69%):</a:t>
+            </a:r>
+            <a:r>
+              <a:rPr sz="2200" b="0" i="0">
+                <a:solidFill>
+                  <a:srgbClr val="000000"/>
+                </a:solidFill>
+                <a:latin typeface="Times New Roman"/>
+              </a:rPr>
+              <a:t> lower sexual esteem and more negative genital self-image than controls, even after neovagina creation.</a:t>
+            </a:r>
+            <a:r>
+              <a:rPr sz="2200" b="0" i="0" baseline="30000">
+                <a:solidFill>
+                  <a:srgbClr val="000000"/>
+                </a:solidFill>
+                <a:latin typeface="Times New Roman"/>
+              </a:rPr>
+              <a:t>10,11</a:t>
+            </a:r>
+          </a:p>
+          <a:p>
+            <a:pPr algn="l" marL="274320" indent="-274320">
+              <a:lnSpc>
+                <a:spcPct val="100000"/>
+              </a:lnSpc>
+              <a:spcAft>
+                <a:spcPts val="400"/>
+              </a:spcAft>
+            </a:pPr>
+            <a:r>
+              <a:rPr sz="2200" b="0" i="0">
+                <a:solidFill>
+                  <a:srgbClr val="000000"/>
+                </a:solidFill>
+                <a:latin typeface="Times New Roman"/>
+              </a:rPr>
+              <a:t>• </a:t>
+            </a:r>
+            <a:r>
+              <a:rPr sz="2200" b="1" i="0">
+                <a:solidFill>
+                  <a:srgbClr val="000000"/>
+                </a:solidFill>
+                <a:latin typeface="Times New Roman"/>
+              </a:rPr>
+              <a:t>Psychological distress (57%):</a:t>
+            </a:r>
+            <a:r>
+              <a:rPr sz="2200" b="0" i="0">
+                <a:solidFill>
+                  <a:srgbClr val="000000"/>
+                </a:solidFill>
+                <a:latin typeface="Times New Roman"/>
+              </a:rPr>
+              <a:t> shock, grief, shame, and secrecy at diagnosis; the diagnostic process itself was described as upsetting and potentially traumatizing.</a:t>
+            </a:r>
+            <a:r>
+              <a:rPr sz="2200" b="0" i="0" baseline="30000">
+                <a:solidFill>
+                  <a:srgbClr val="000000"/>
+                </a:solidFill>
+                <a:latin typeface="Times New Roman"/>
+              </a:rPr>
+              <a:t>12,13</a:t>
+            </a:r>
+          </a:p>
+          <a:p>
+            <a:pPr algn="l" marL="274320" indent="-274320">
+              <a:lnSpc>
+                <a:spcPct val="100000"/>
+              </a:lnSpc>
+              <a:spcAft>
+                <a:spcPts val="400"/>
+              </a:spcAft>
+            </a:pPr>
+            <a:r>
+              <a:rPr sz="2200" b="0" i="0">
+                <a:solidFill>
+                  <a:srgbClr val="000000"/>
+                </a:solidFill>
+                <a:latin typeface="Times New Roman"/>
+              </a:rPr>
+              <a:t>• </a:t>
+            </a:r>
+            <a:r>
+              <a:rPr sz="2200" b="1" i="0">
+                <a:solidFill>
+                  <a:srgbClr val="000000"/>
+                </a:solidFill>
+                <a:latin typeface="Times New Roman"/>
+              </a:rPr>
+              <a:t>QoL, body image, and self-esteem (54%):</a:t>
+            </a:r>
+            <a:r>
+              <a:rPr sz="2200" b="0" i="0">
+                <a:solidFill>
+                  <a:srgbClr val="000000"/>
+                </a:solidFill>
+                <a:latin typeface="Times New Roman"/>
+              </a:rPr>
+              <a:t> impaired mental health–related quality of life,</a:t>
+            </a:r>
+            <a:r>
+              <a:rPr sz="2200" b="0" i="0" baseline="30000">
+                <a:solidFill>
+                  <a:srgbClr val="000000"/>
+                </a:solidFill>
+                <a:latin typeface="Times New Roman"/>
+              </a:rPr>
+              <a:t>14</a:t>
+            </a:r>
+            <a:r>
+              <a:rPr sz="2200" b="0" i="0">
+                <a:solidFill>
+                  <a:srgbClr val="000000"/>
+                </a:solidFill>
+                <a:latin typeface="Times New Roman"/>
+              </a:rPr>
+              <a:t> and higher distress with lower self-esteem than population norms.</a:t>
+            </a:r>
+            <a:r>
+              <a:rPr sz="2200" b="0" i="0" baseline="30000">
+                <a:solidFill>
+                  <a:srgbClr val="000000"/>
+                </a:solidFill>
+                <a:latin typeface="Times New Roman"/>
+              </a:rPr>
+              <a:t>15</a:t>
+            </a:r>
+          </a:p>
+          <a:p>
+            <a:pPr algn="l" marL="274320" indent="-274320">
+              <a:lnSpc>
+                <a:spcPct val="100000"/>
+              </a:lnSpc>
+              <a:spcAft>
+                <a:spcPts val="400"/>
+              </a:spcAft>
+            </a:pPr>
+            <a:r>
+              <a:rPr sz="2200" b="0" i="0">
+                <a:solidFill>
+                  <a:srgbClr val="000000"/>
+                </a:solidFill>
+                <a:latin typeface="Times New Roman"/>
+              </a:rPr>
+              <a:t>• </a:t>
+            </a:r>
+            <a:r>
+              <a:rPr sz="2200" b="1" i="0">
+                <a:solidFill>
+                  <a:srgbClr val="000000"/>
+                </a:solidFill>
+                <a:latin typeface="Times New Roman"/>
+              </a:rPr>
+              <a:t>Depression and anxiety (40%):</a:t>
+            </a:r>
+            <a:r>
+              <a:rPr sz="2200" b="0" i="0">
+                <a:solidFill>
+                  <a:srgbClr val="000000"/>
+                </a:solidFill>
+                <a:latin typeface="Times New Roman"/>
+              </a:rPr>
+              <a:t> depressive symptoms in 75.2% of 141 Chinese patients;</a:t>
+            </a:r>
+            <a:r>
+              <a:rPr sz="2200" b="0" i="0" baseline="30000">
+                <a:solidFill>
+                  <a:srgbClr val="000000"/>
+                </a:solidFill>
+                <a:latin typeface="Times New Roman"/>
+              </a:rPr>
+              <a:t>16</a:t>
+            </a:r>
+            <a:r>
+              <a:rPr sz="2200" b="0" i="0">
+                <a:solidFill>
+                  <a:srgbClr val="000000"/>
+                </a:solidFill>
+                <a:latin typeface="Times New Roman"/>
+              </a:rPr>
+              <a:t> anxiety in 37.7% and depression in 32.5% of 77 Malaysian women.</a:t>
+            </a:r>
+            <a:r>
+              <a:rPr sz="2200" b="0" i="0" baseline="30000">
+                <a:solidFill>
+                  <a:srgbClr val="000000"/>
+                </a:solidFill>
+                <a:latin typeface="Times New Roman"/>
+              </a:rPr>
+              <a:t>17</a:t>
+            </a:r>
+            <a:r>
+              <a:rPr sz="2200" b="0" i="0">
+                <a:solidFill>
+                  <a:srgbClr val="000000"/>
+                </a:solidFill>
+                <a:latin typeface="Times New Roman"/>
+              </a:rPr>
+              <a:t> Findings were mixed: uterus transplant candidates in France showed few symptoms.</a:t>
+            </a:r>
+            <a:r>
+              <a:rPr sz="2200" b="0" i="0" baseline="30000">
+                <a:solidFill>
+                  <a:srgbClr val="000000"/>
+                </a:solidFill>
+                <a:latin typeface="Times New Roman"/>
+              </a:rPr>
+              <a:t>18</a:t>
+            </a:r>
+          </a:p>
+          <a:p>
+            <a:pPr algn="l" marL="274320" indent="-274320">
+              <a:lnSpc>
+                <a:spcPct val="100000"/>
+              </a:lnSpc>
+              <a:spcAft>
+                <a:spcPts val="400"/>
+              </a:spcAft>
+            </a:pPr>
+            <a:r>
+              <a:rPr sz="2200" b="0" i="0">
+                <a:solidFill>
+                  <a:srgbClr val="000000"/>
+                </a:solidFill>
+                <a:latin typeface="Times New Roman"/>
+              </a:rPr>
+              <a:t>• </a:t>
+            </a:r>
+            <a:r>
+              <a:rPr sz="2200" b="1" i="0">
+                <a:solidFill>
+                  <a:srgbClr val="000000"/>
+                </a:solidFill>
+                <a:latin typeface="Times New Roman"/>
+              </a:rPr>
+              <a:t>Coping (43%):</a:t>
+            </a:r>
+            <a:r>
+              <a:rPr sz="2200" b="0" i="0">
+                <a:solidFill>
+                  <a:srgbClr val="000000"/>
+                </a:solidFill>
+                <a:latin typeface="Times New Roman"/>
+              </a:rPr>
+              <a:t> peer and online support most common; avoidance and concealment also frequent, and one study traced a shift from avoidance to empowerment.</a:t>
+            </a:r>
+            <a:r>
+              <a:rPr sz="2200" b="0" i="0" baseline="30000">
+                <a:solidFill>
+                  <a:srgbClr val="000000"/>
+                </a:solidFill>
+                <a:latin typeface="Times New Roman"/>
+              </a:rPr>
+              <a:t>19</a:t>
+            </a:r>
+            <a:r>
+              <a:rPr sz="2200" b="0" i="0">
+                <a:solidFill>
+                  <a:srgbClr val="000000"/>
+                </a:solidFill>
+                <a:latin typeface="Times New Roman"/>
+              </a:rPr>
+              <a:t> Only 2 intervention studies were found, both reporting benefit.</a:t>
+            </a:r>
+            <a:r>
+              <a:rPr sz="2200" b="0" i="0" baseline="30000">
+                <a:solidFill>
+                  <a:srgbClr val="000000"/>
+                </a:solidFill>
+                <a:latin typeface="Times New Roman"/>
+              </a:rPr>
+              <a:t>20,21</a:t>
+            </a:r>
+          </a:p>
+          <a:p>
+            <a:pPr algn="l" marL="274320" indent="-274320">
+              <a:lnSpc>
+                <a:spcPct val="100000"/>
+              </a:lnSpc>
+              <a:spcAft>
+                <a:spcPts val="400"/>
+              </a:spcAft>
+            </a:pPr>
+            <a:r>
+              <a:rPr sz="2200" b="0" i="0">
+                <a:solidFill>
+                  <a:srgbClr val="000000"/>
+                </a:solidFill>
+                <a:latin typeface="Times New Roman"/>
+              </a:rPr>
+              <a:t>• </a:t>
+            </a:r>
+            <a:r>
+              <a:rPr sz="2200" b="1" i="0">
+                <a:solidFill>
+                  <a:srgbClr val="000000"/>
+                </a:solidFill>
+                <a:latin typeface="Times New Roman"/>
+              </a:rPr>
+              <a:t>Healthcare gaps (29%):</a:t>
+            </a:r>
+            <a:r>
+              <a:rPr sz="2200" b="0" i="0">
+                <a:solidFill>
+                  <a:srgbClr val="000000"/>
+                </a:solidFill>
+                <a:latin typeface="Times New Roman"/>
+              </a:rPr>
+              <a:t> delayed diagnosis, providers unfamiliar with MRKH, and patients forced to self-advocate.</a:t>
+            </a:r>
+            <a:r>
+              <a:rPr sz="2200" b="0" i="0" baseline="30000">
+                <a:solidFill>
+                  <a:srgbClr val="000000"/>
+                </a:solidFill>
+                <a:latin typeface="Times New Roman"/>
+              </a:rPr>
+              <a:t>22,23</a:t>
+            </a:r>
+          </a:p>
+          <a:p>
+            <a:pPr algn="just">
+              <a:lnSpc>
+                <a:spcPct val="100000"/>
+              </a:lnSpc>
+              <a:spcAft>
+                <a:spcPts val="400"/>
+              </a:spcAft>
+            </a:pPr>
+            <a:r>
+              <a:rPr sz="2200" b="1" i="0">
+                <a:solidFill>
+                  <a:srgbClr val="000000"/>
+                </a:solidFill>
+                <a:latin typeface="Times New Roman"/>
+              </a:rPr>
+              <a:t>Discussion</a:t>
+            </a:r>
+          </a:p>
+          <a:p>
+            <a:pPr algn="just">
+              <a:lnSpc>
+                <a:spcPct val="100000"/>
+              </a:lnSpc>
+              <a:spcAft>
+                <a:spcPts val="400"/>
+              </a:spcAft>
+            </a:pPr>
+            <a:r>
+              <a:rPr sz="2200" b="0" i="0">
+                <a:solidFill>
+                  <a:srgbClr val="000000"/>
+                </a:solidFill>
+                <a:latin typeface="Times New Roman"/>
+              </a:rPr>
+              <a:t>Findings echo earlier evidence of distress and reduced quality of life in MRKH</a:t>
+            </a:r>
+            <a:r>
+              <a:rPr sz="2200" b="0" i="0" baseline="30000">
+                <a:solidFill>
+                  <a:srgbClr val="000000"/>
+                </a:solidFill>
+                <a:latin typeface="Times New Roman"/>
+              </a:rPr>
+              <a:t>3,5</a:t>
+            </a:r>
+            <a:r>
+              <a:rPr sz="2200" b="0" i="0">
+                <a:solidFill>
+                  <a:srgbClr val="000000"/>
+                </a:solidFill>
+                <a:latin typeface="Times New Roman"/>
+              </a:rPr>
+              <a:t> and extend prior reviews by mapping coping and health-system gaps. Structured support can help (group cognitive-behavioral therapy improved psychological outcomes in an earlier trial</a:t>
+            </a:r>
+            <a:r>
+              <a:rPr sz="2200" b="0" i="0" baseline="30000">
+                <a:solidFill>
+                  <a:srgbClr val="000000"/>
+                </a:solidFill>
+                <a:latin typeface="Times New Roman"/>
+              </a:rPr>
+              <a:t>24</a:t>
+            </a:r>
+            <a:r>
+              <a:rPr sz="2200" b="0" i="0">
+                <a:solidFill>
+                  <a:srgbClr val="000000"/>
+                </a:solidFill>
+                <a:latin typeface="Times New Roman"/>
+              </a:rPr>
+              <a:t>), yet few recent studies tested interventions. Psychosexual concerns dominate the recent literature, whereas depression and anxiety were measured in fewer than half of studies. Evidence is concentrated in Europe (14) and Asia (14); 1 study came from Africa and none from South America, where expectations about fertility and marriage may shape experiences differently.</a:t>
+            </a:r>
+          </a:p>
+          <a:p>
+            <a:pPr algn="just">
+              <a:lnSpc>
+                <a:spcPct val="100000"/>
+              </a:lnSpc>
+              <a:spcAft>
+                <a:spcPts val="400"/>
+              </a:spcAft>
+            </a:pPr>
+            <a:r>
+              <a:rPr sz="2200" b="1" i="0">
+                <a:solidFill>
+                  <a:srgbClr val="000000"/>
+                </a:solidFill>
+                <a:latin typeface="Times New Roman"/>
+              </a:rPr>
+              <a:t>Limitations:</a:t>
+            </a:r>
+            <a:r>
+              <a:rPr sz="2200" b="0" i="0">
+                <a:solidFill>
+                  <a:srgbClr val="000000"/>
+                </a:solidFill>
+                <a:latin typeface="Times New Roman"/>
+              </a:rPr>
+              <a:t> AI-assisted screening and charting (full text checked for 30 of 35 studies); English-language studies from 2019–2026 only; heterogeneous designs and measures; some reports may share samples; counts show how often outcomes were studied, not their prevalence.</a:t>
+            </a:r>
+          </a:p>
+        </p:txBody>
+      </p:sp>
       <p:graphicFrame>
         <p:nvGraphicFramePr>
           <p:cNvPr id="10" name="Table 9">
@@ -7999,7 +8386,7 @@
         </p:nvGraphicFramePr>
         <p:xfrm>
           <a:off x="660762" y="21538124"/>
-          <a:ext cx="9565778" cy="10820128"/>
+          <a:ext cx="9564624" cy="10588752"/>
         </p:xfrm>
         <a:graphic>
           <a:graphicData uri="http://schemas.openxmlformats.org/drawingml/2006/table">
@@ -8008,14 +8395,14 @@
                 <a:tableStyleId>{5C22544A-7EE6-4342-B048-85BDC9FD1C3A}</a:tableStyleId>
               </a:tblPr>
               <a:tblGrid>
-                <a:gridCol w="5177897">
+                <a:gridCol w="2331720">
                   <a:extLst>
                     <a:ext uri="{9D8B030D-6E8A-4147-A177-3AD203B41FA5}">
                       <a16:colId xmlns:a16="http://schemas.microsoft.com/office/drawing/2014/main" val="2846790296"/>
                     </a:ext>
                   </a:extLst>
                 </a:gridCol>
-                <a:gridCol w="4387881">
+                <a:gridCol w="7232904">
                   <a:extLst>
                     <a:ext uri="{9D8B030D-6E8A-4147-A177-3AD203B41FA5}">
                       <a16:colId xmlns:a16="http://schemas.microsoft.com/office/drawing/2014/main" val="1015726853"/>
@@ -8023,14 +8410,15 @@
                   </a:extLst>
                 </a:gridCol>
               </a:tblGrid>
-              <a:tr h="606898">
+              <a:tr h="603504">
                 <a:tc>
                   <a:txBody>
-                    <a:bodyPr/>
+                    <a:bodyPr wrap="square"/>
                     <a:lstStyle/>
                     <a:p>
+                      <a:pPr algn="l"/>
                       <a:r>
-                        <a:rPr sz="3000" b="0" i="0">
+                        <a:rPr sz="2800" b="0" i="0">
                           <a:solidFill>
                             <a:srgbClr val="FFFFFF"/>
                           </a:solidFill>
@@ -8044,11 +8432,12 @@
                 </a:tc>
                 <a:tc>
                   <a:txBody>
-                    <a:bodyPr/>
+                    <a:bodyPr wrap="square"/>
                     <a:lstStyle/>
                     <a:p>
+                      <a:pPr algn="l"/>
                       <a:r>
-                        <a:rPr sz="3000" b="0" i="0">
+                        <a:rPr sz="2800" b="0" i="0">
                           <a:solidFill>
                             <a:srgbClr val="FFFFFF"/>
                           </a:solidFill>
@@ -8066,14 +8455,15 @@
                   </a:ext>
                 </a:extLst>
               </a:tr>
-              <a:tr h="2259675">
+              <a:tr h="2395728">
                 <a:tc>
                   <a:txBody>
-                    <a:bodyPr/>
+                    <a:bodyPr wrap="square"/>
                     <a:lstStyle/>
                     <a:p>
+                      <a:pPr algn="l"/>
                       <a:r>
-                        <a:rPr sz="2300" b="1" i="0">
+                        <a:rPr sz="2400" b="1" i="0">
                           <a:solidFill>
                             <a:srgbClr val="000000"/>
                           </a:solidFill>
@@ -8087,44 +8477,54 @@
                 </a:tc>
                 <a:tc>
                   <a:txBody>
-                    <a:bodyPr/>
+                    <a:bodyPr wrap="square"/>
                     <a:lstStyle/>
                     <a:p>
+                      <a:pPr algn="l"/>
                       <a:r>
-                        <a:rPr sz="2300" b="0" i="0">
+                        <a:rPr sz="2400" b="0" i="0">
                           <a:solidFill>
                             <a:srgbClr val="000000"/>
                           </a:solidFill>
                           <a:latin typeface="Times New Roman"/>
                         </a:rPr>
-                        <a:t>Scoping review following Arksey &amp; O'Malley's framework;</a:t>
+                        <a:t>Scoping review using Arksey &amp; O'Malley's five-stage framework</a:t>
                       </a:r>
                       <a:r>
-                        <a:rPr sz="2300" b="0" i="0" baseline="30000">
+                        <a:rPr sz="2400" b="0" i="0" baseline="30000">
                           <a:solidFill>
                             <a:srgbClr val="000000"/>
                           </a:solidFill>
                           <a:latin typeface="Times New Roman"/>
                         </a:rPr>
-                        <a:t>3</a:t>
+                        <a:t>8</a:t>
                       </a:r>
                       <a:r>
-                        <a:rPr sz="2300" b="0" i="0">
+                        <a:rPr sz="2400" b="0" i="0">
                           <a:solidFill>
                             <a:srgbClr val="000000"/>
                           </a:solidFill>
                           <a:latin typeface="Times New Roman"/>
                         </a:rPr>
-                        <a:t> reported per PRISMA-ScR</a:t>
+                        <a:t> and PRISMA-ScR reporting guidance.</a:t>
                       </a:r>
                       <a:r>
-                        <a:rPr sz="2300" b="0" i="0" baseline="30000">
+                        <a:rPr sz="2400" b="0" i="0" baseline="30000">
                           <a:solidFill>
                             <a:srgbClr val="000000"/>
                           </a:solidFill>
                           <a:latin typeface="Times New Roman"/>
                         </a:rPr>
-                        <a:t>4</a:t>
+                        <a:t>9</a:t>
+                      </a:r>
+                      <a:r>
+                        <a:rPr sz="2400" b="0" i="0">
+                          <a:solidFill>
+                            <a:srgbClr val="000000"/>
+                          </a:solidFill>
+                          <a:latin typeface="Times New Roman"/>
+                        </a:rPr>
+                        <a:t> Framed by population (individuals with MRKH), concept (mental health, coping, care gaps), and context (any setting). No quality appraisal, consistent with scoping methodology.</a:t>
                       </a:r>
                       <a:endParaRPr lang="en-US" sz="2400" dirty="0">
                         <a:latin typeface="Times New Roman" panose="02020603050405020304" pitchFamily="18" charset="0"/>
@@ -8140,14 +8540,15 @@
                   </a:ext>
                 </a:extLst>
               </a:tr>
-              <a:tr h="1629041">
+              <a:tr h="2011680">
                 <a:tc>
                   <a:txBody>
-                    <a:bodyPr/>
+                    <a:bodyPr wrap="square"/>
                     <a:lstStyle/>
                     <a:p>
+                      <a:pPr algn="l"/>
                       <a:r>
-                        <a:rPr sz="2300" b="1" i="0">
+                        <a:rPr sz="2400" b="1" i="0">
                           <a:solidFill>
                             <a:srgbClr val="000000"/>
                           </a:solidFill>
@@ -8161,17 +8562,18 @@
                 </a:tc>
                 <a:tc>
                   <a:txBody>
-                    <a:bodyPr/>
+                    <a:bodyPr wrap="square"/>
                     <a:lstStyle/>
                     <a:p>
+                      <a:pPr algn="l"/>
                       <a:r>
-                        <a:rPr sz="2300" b="0" i="0">
+                        <a:rPr sz="2400" b="0" i="0">
                           <a:solidFill>
                             <a:srgbClr val="000000"/>
                           </a:solidFill>
                           <a:latin typeface="Times New Roman"/>
                         </a:rPr>
-                        <a:t>PubMed; Scopus; EBSCOhost (MEDLINE, CINAHL, APA PsycInfo, Women's Studies International). Jan 2019–Mar 2026; run Mar 29, 2026</a:t>
+                        <a:t>PubMed; Scopus; EBSCOhost (MEDLINE, CINAHL, APA PsycInfo, Women's Studies International). January 2019–March 2026; exported March 29, 2026. Terms combined MRKH and Müllerian agenesis with mental health, psychosocial, and coping concepts.</a:t>
                       </a:r>
                       <a:endParaRPr lang="en-US" sz="2400" dirty="0">
                         <a:latin typeface="Times New Roman" panose="02020603050405020304" pitchFamily="18" charset="0"/>
@@ -8187,14 +8589,15 @@
                   </a:ext>
                 </a:extLst>
               </a:tr>
-              <a:tr h="2395649">
+              <a:tr h="2743200">
                 <a:tc>
                   <a:txBody>
-                    <a:bodyPr/>
+                    <a:bodyPr wrap="square"/>
                     <a:lstStyle/>
                     <a:p>
+                      <a:pPr algn="l"/>
                       <a:r>
-                        <a:rPr sz="2300" b="1" i="0">
+                        <a:rPr sz="2400" b="1" i="0">
                           <a:solidFill>
                             <a:srgbClr val="000000"/>
                           </a:solidFill>
@@ -8208,17 +8611,45 @@
                 </a:tc>
                 <a:tc>
                   <a:txBody>
-                    <a:bodyPr/>
+                    <a:bodyPr wrap="square"/>
                     <a:lstStyle/>
                     <a:p>
+                      <a:pPr algn="l"/>
                       <a:r>
-                        <a:rPr sz="2300" b="0" i="0">
+                        <a:rPr sz="2400" b="1" i="0">
                           <a:solidFill>
                             <a:srgbClr val="000000"/>
                           </a:solidFill>
                           <a:latin typeface="Times New Roman"/>
                         </a:rPr>
-                        <a:t>English-language primary quantitative, qualitative, or mixed-methods studies reporting psychological outcomes or coping in MRKH; surgical/fertility-only studies excluded</a:t>
+                        <a:t>Included:</a:t>
+                      </a:r>
+                      <a:r>
+                        <a:rPr sz="2400" b="0" i="0">
+                          <a:solidFill>
+                            <a:srgbClr val="000000"/>
+                          </a:solidFill>
+                          <a:latin typeface="Times New Roman"/>
+                        </a:rPr>
+                        <a:t> English-language primary quantitative, qualitative, or mixed-methods studies reporting psychological outcomes or coping in MRKH; mixed samples only if MRKH results were reported separately or ≥80% had MRKH. </a:t>
+                      </a:r>
+                      <a:r>
+                        <a:rPr sz="2400" b="1" i="0">
+                          <a:solidFill>
+                            <a:srgbClr val="000000"/>
+                          </a:solidFill>
+                          <a:latin typeface="Times New Roman"/>
+                        </a:rPr>
+                        <a:t>Excluded:</a:t>
+                      </a:r>
+                      <a:r>
+                        <a:rPr sz="2400" b="0" i="0">
+                          <a:solidFill>
+                            <a:srgbClr val="000000"/>
+                          </a:solidFill>
+                          <a:latin typeface="Times New Roman"/>
+                        </a:rPr>
+                        <a:t> reviews, case reports, and studies of surgical, anatomical, or fertility outcomes only.</a:t>
                       </a:r>
                       <a:endParaRPr lang="en-US" sz="2400" dirty="0">
                         <a:latin typeface="Times New Roman" panose="02020603050405020304" pitchFamily="18" charset="0"/>
@@ -8234,14 +8665,15 @@
                   </a:ext>
                 </a:extLst>
               </a:tr>
-              <a:tr h="3928865">
+              <a:tr h="2834640">
                 <a:tc>
                   <a:txBody>
-                    <a:bodyPr/>
+                    <a:bodyPr wrap="square"/>
                     <a:lstStyle/>
                     <a:p>
+                      <a:pPr algn="l"/>
                       <a:r>
-                        <a:rPr sz="2300" b="1" i="0">
+                        <a:rPr sz="2400" b="1" i="0">
                           <a:solidFill>
                             <a:srgbClr val="000000"/>
                           </a:solidFill>
@@ -8255,17 +8687,18 @@
                 </a:tc>
                 <a:tc>
                   <a:txBody>
-                    <a:bodyPr/>
+                    <a:bodyPr wrap="square"/>
                     <a:lstStyle/>
                     <a:p>
+                      <a:pPr algn="l"/>
                       <a:r>
-                        <a:rPr sz="2300" b="0" i="0">
+                        <a:rPr sz="2400" b="0" i="0">
                           <a:solidFill>
                             <a:srgbClr val="000000"/>
                           </a:solidFill>
                           <a:latin typeface="Times New Roman"/>
                         </a:rPr>
-                        <a:t>516 records; 324 screened; 42 assessed; 35 included. AI-assisted screening with full-text charting (30 of 35 studies); frequency counts and thematic grouping</a:t>
+                        <a:t>516 records; 192 duplicates removed; 324 titles and abstracts screened; 42 assessed; 35 included (Figure 2). AI-assisted screening and charting, checked against full text for 30 of 35 studies. Charted design, country, sample, outcomes, coping, and healthcare gaps; synthesized with frequency counts and thematic grouping into 6 domains (Figure 1).</a:t>
                       </a:r>
                       <a:endParaRPr lang="en-US" sz="2400" dirty="0">
                         <a:latin typeface="Times New Roman" panose="02020603050405020304" pitchFamily="18" charset="0"/>
@@ -8285,111 +8718,6 @@
           </a:graphicData>
         </a:graphic>
       </p:graphicFrame>
-      <p:sp>
-        <p:nvSpPr>
-          <p:cNvPr id="14" name="TextBox 13">
-            <a:extLst>
-              <a:ext uri="{FF2B5EF4-FFF2-40B4-BE49-F238E27FC236}">
-                <a16:creationId xmlns:a16="http://schemas.microsoft.com/office/drawing/2014/main" id="{3FE59D55-EEB9-45ED-66FD-9D2D7B715548}"/>
-              </a:ext>
-            </a:extLst>
-          </p:cNvPr>
-          <p:cNvSpPr txBox="1"/>
-          <p:nvPr/>
-        </p:nvSpPr>
-        <p:spPr>
-          <a:xfrm>
-            <a:off x="34223508" y="13863056"/>
-            <a:ext cx="8839431" cy="4124206"/>
-          </a:xfrm>
-          <a:prstGeom prst="rect">
-            <a:avLst/>
-          </a:prstGeom>
-          <a:noFill/>
-        </p:spPr>
-        <p:txBody>
-          <a:bodyPr wrap="square">
-            <a:noAutofit/>
-          </a:bodyPr>
-          <a:lstStyle/>
-          <a:p>
-            <a:pPr algn="just">
-              <a:lnSpc>
-                <a:spcPct val="100000"/>
-              </a:lnSpc>
-              <a:spcAft>
-                <a:spcPts val="300"/>
-              </a:spcAft>
-            </a:pPr>
-            <a:r>
-              <a:rPr sz="2300" b="1" i="0">
-                <a:solidFill>
-                  <a:srgbClr val="000000"/>
-                </a:solidFill>
-                <a:latin typeface="Times New Roman"/>
-              </a:rPr>
-              <a:t>Limitations</a:t>
-            </a:r>
-          </a:p>
-          <a:p>
-            <a:pPr algn="l">
-              <a:lnSpc>
-                <a:spcPct val="100000"/>
-              </a:lnSpc>
-              <a:spcAft>
-                <a:spcPts val="300"/>
-              </a:spcAft>
-            </a:pPr>
-            <a:r>
-              <a:rPr sz="2300" b="0" i="0">
-                <a:solidFill>
-                  <a:srgbClr val="000000"/>
-                </a:solidFill>
-                <a:latin typeface="Times New Roman"/>
-              </a:rPr>
-              <a:t>• AI-assisted screening; 5 of 35 studies charted from abstracts only (full text unavailable)</a:t>
-            </a:r>
-          </a:p>
-          <a:p>
-            <a:pPr algn="l">
-              <a:lnSpc>
-                <a:spcPct val="100000"/>
-              </a:lnSpc>
-              <a:spcAft>
-                <a:spcPts val="300"/>
-              </a:spcAft>
-            </a:pPr>
-            <a:r>
-              <a:rPr sz="2300" b="0" i="0">
-                <a:solidFill>
-                  <a:srgbClr val="000000"/>
-                </a:solidFill>
-                <a:latin typeface="Times New Roman"/>
-              </a:rPr>
-              <a:t>• Review limited to 2019–2026; heterogeneous designs and measures</a:t>
-            </a:r>
-          </a:p>
-          <a:p>
-            <a:pPr algn="l">
-              <a:lnSpc>
-                <a:spcPct val="100000"/>
-              </a:lnSpc>
-              <a:spcAft>
-                <a:spcPts val="300"/>
-              </a:spcAft>
-            </a:pPr>
-            <a:r>
-              <a:rPr sz="2300" b="0" i="0">
-                <a:solidFill>
-                  <a:srgbClr val="000000"/>
-                </a:solidFill>
-                <a:latin typeface="Times New Roman"/>
-              </a:rPr>
-              <a:t>• Few studies from Africa or Oceania; none from South America</a:t>
-            </a:r>
-          </a:p>
-        </p:txBody>
-      </p:sp>
       <p:cxnSp>
         <p:nvCxnSpPr>
           <p:cNvPr id="6" name="Straight Connector 5">
@@ -8428,14 +8756,14 @@
       </p:cxnSp>
       <p:sp>
         <p:nvSpPr>
-          <p:cNvPr id="328" name="TextBox 327"/>
-          <p:cNvSpPr txBox="1"/>
+          <p:cNvPr id="328" name="QR code spot"/>
+          <p:cNvSpPr/>
           <p:nvPr/>
         </p:nvSpPr>
         <p:spPr>
           <a:xfrm>
-            <a:off x="34088832" y="27706320"/>
-            <a:ext cx="9144000" cy="4846320"/>
+            <a:off x="36210240" y="27624024"/>
+            <a:ext cx="5056632" cy="5056632"/>
           </a:xfrm>
           <a:prstGeom prst="rect">
             <a:avLst/>
@@ -8443,323 +8771,51 @@
           <a:solidFill>
             <a:srgbClr val="FFFFFF"/>
           </a:solidFill>
+          <a:ln w="19050">
+            <a:solidFill>
+              <a:srgbClr val="BFBFBF"/>
+            </a:solidFill>
+          </a:ln>
         </p:spPr>
-        <p:txBody>
-          <a:bodyPr wrap="square" lIns="109728" rIns="109728">
-            <a:noAutofit/>
-          </a:bodyPr>
+        <p:style>
+          <a:lnRef idx="1">
+            <a:schemeClr val="accent1"/>
+          </a:lnRef>
+          <a:fillRef idx="3">
+            <a:schemeClr val="accent1"/>
+          </a:fillRef>
+          <a:effectRef idx="2">
+            <a:schemeClr val="accent1"/>
+          </a:effectRef>
+          <a:fontRef idx="minor">
+            <a:schemeClr val="lt1"/>
+          </a:fontRef>
+        </p:style>
+        <p:txBody>
+          <a:bodyPr rtlCol="0" anchor="ctr" wrap="square"/>
           <a:lstStyle/>
           <a:p>
-            <a:pPr>
-              <a:spcAft>
-                <a:spcPts val="200"/>
-              </a:spcAft>
-            </a:pPr>
+            <a:pPr algn="ctr"/>
+            <a:r>
+              <a:rPr sz="2800" b="0" i="0">
+                <a:solidFill>
+                  <a:srgbClr val="595959"/>
+                </a:solidFill>
+                <a:latin typeface="Times New Roman"/>
+              </a:rPr>
+              <a:t>Paste QR code here</a:t>
+            </a:r>
+          </a:p>
+          <a:p>
+            <a:pPr algn="ctr"/>
             <a:r>
               <a:rPr sz="1800" b="0" i="0">
                 <a:solidFill>
-                  <a:srgbClr val="000000"/>
-                </a:solidFill>
-                <a:latin typeface="Times New Roman"/>
-              </a:rPr>
-              <a:t>1. ACOG Committee Opinion No. 728. </a:t>
-            </a:r>
-            <a:r>
-              <a:rPr sz="1800" b="0" i="1">
-                <a:solidFill>
-                  <a:srgbClr val="000000"/>
-                </a:solidFill>
-                <a:latin typeface="Times New Roman"/>
-              </a:rPr>
-              <a:t>Obstet Gynecol</a:t>
-            </a:r>
-            <a:r>
-              <a:rPr sz="1800" b="0" i="0">
-                <a:solidFill>
-                  <a:srgbClr val="000000"/>
-                </a:solidFill>
-                <a:latin typeface="Times New Roman"/>
-              </a:rPr>
-              <a:t>. 2018;131(1):e35-e42.</a:t>
-            </a:r>
-          </a:p>
-          <a:p>
-            <a:pPr>
-              <a:spcAft>
-                <a:spcPts val="200"/>
-              </a:spcAft>
-            </a:pPr>
-            <a:r>
-              <a:rPr sz="1800" b="0" i="0">
-                <a:solidFill>
-                  <a:srgbClr val="000000"/>
-                </a:solidFill>
-                <a:latin typeface="Times New Roman"/>
-              </a:rPr>
-              <a:t>2. Herlin M, et al. </a:t>
-            </a:r>
-            <a:r>
-              <a:rPr sz="1800" b="0" i="1">
-                <a:solidFill>
-                  <a:srgbClr val="000000"/>
-                </a:solidFill>
-                <a:latin typeface="Times New Roman"/>
-              </a:rPr>
-              <a:t>Hum Reprod</a:t>
-            </a:r>
-            <a:r>
-              <a:rPr sz="1800" b="0" i="0">
-                <a:solidFill>
-                  <a:srgbClr val="000000"/>
-                </a:solidFill>
-                <a:latin typeface="Times New Roman"/>
-              </a:rPr>
-              <a:t>. 2016;31(10):2384-2390.</a:t>
-            </a:r>
-          </a:p>
-          <a:p>
-            <a:pPr>
-              <a:spcAft>
-                <a:spcPts val="200"/>
-              </a:spcAft>
-            </a:pPr>
-            <a:r>
-              <a:rPr sz="1800" b="0" i="0">
-                <a:solidFill>
-                  <a:srgbClr val="000000"/>
-                </a:solidFill>
-                <a:latin typeface="Times New Roman"/>
-              </a:rPr>
-              <a:t>3. Arksey H, O'Malley L. </a:t>
-            </a:r>
-            <a:r>
-              <a:rPr sz="1800" b="0" i="1">
-                <a:solidFill>
-                  <a:srgbClr val="000000"/>
-                </a:solidFill>
-                <a:latin typeface="Times New Roman"/>
-              </a:rPr>
-              <a:t>Int J Soc Res Methodol</a:t>
-            </a:r>
-            <a:r>
-              <a:rPr sz="1800" b="0" i="0">
-                <a:solidFill>
-                  <a:srgbClr val="000000"/>
-                </a:solidFill>
-                <a:latin typeface="Times New Roman"/>
-              </a:rPr>
-              <a:t>. 2005;8(1):19-32.</a:t>
-            </a:r>
-          </a:p>
-          <a:p>
-            <a:pPr>
-              <a:spcAft>
-                <a:spcPts val="200"/>
-              </a:spcAft>
-            </a:pPr>
-            <a:r>
-              <a:rPr sz="1800" b="0" i="0">
-                <a:solidFill>
-                  <a:srgbClr val="000000"/>
-                </a:solidFill>
-                <a:latin typeface="Times New Roman"/>
-              </a:rPr>
-              <a:t>4. Tricco AC, et al. </a:t>
-            </a:r>
-            <a:r>
-              <a:rPr sz="1800" b="0" i="1">
-                <a:solidFill>
-                  <a:srgbClr val="000000"/>
-                </a:solidFill>
-                <a:latin typeface="Times New Roman"/>
-              </a:rPr>
-              <a:t>Ann Intern Med</a:t>
-            </a:r>
-            <a:r>
-              <a:rPr sz="1800" b="0" i="0">
-                <a:solidFill>
-                  <a:srgbClr val="000000"/>
-                </a:solidFill>
-                <a:latin typeface="Times New Roman"/>
-              </a:rPr>
-              <a:t>. 2018;169(7):467-473.</a:t>
-            </a:r>
-          </a:p>
-          <a:p>
-            <a:pPr>
-              <a:spcAft>
-                <a:spcPts val="200"/>
-              </a:spcAft>
-            </a:pPr>
-            <a:r>
-              <a:rPr sz="1800" b="0" i="0">
-                <a:solidFill>
-                  <a:srgbClr val="000000"/>
-                </a:solidFill>
-                <a:latin typeface="Times New Roman"/>
-              </a:rPr>
-              <a:t>5. Heller-Boersma JG, et al. </a:t>
-            </a:r>
-            <a:r>
-              <a:rPr sz="1800" b="0" i="1">
-                <a:solidFill>
-                  <a:srgbClr val="000000"/>
-                </a:solidFill>
-                <a:latin typeface="Times New Roman"/>
-              </a:rPr>
-              <a:t>Psychosomatics</a:t>
-            </a:r>
-            <a:r>
-              <a:rPr sz="1800" b="0" i="0">
-                <a:solidFill>
-                  <a:srgbClr val="000000"/>
-                </a:solidFill>
-                <a:latin typeface="Times New Roman"/>
-              </a:rPr>
-              <a:t>. 2009;50(3):277-281.</a:t>
-            </a:r>
-          </a:p>
-          <a:p>
-            <a:pPr>
-              <a:spcAft>
-                <a:spcPts val="200"/>
-              </a:spcAft>
-            </a:pPr>
-            <a:r>
-              <a:rPr sz="1800" b="0" i="0">
-                <a:solidFill>
-                  <a:srgbClr val="000000"/>
-                </a:solidFill>
-                <a:latin typeface="Times New Roman"/>
-              </a:rPr>
-              <a:t>6. Laggari V, et al. </a:t>
-            </a:r>
-            <a:r>
-              <a:rPr sz="1800" b="0" i="1">
-                <a:solidFill>
-                  <a:srgbClr val="000000"/>
-                </a:solidFill>
-                <a:latin typeface="Times New Roman"/>
-              </a:rPr>
-              <a:t>J Psychosom Obstet Gynaecol</a:t>
-            </a:r>
-            <a:r>
-              <a:rPr sz="1800" b="0" i="0">
-                <a:solidFill>
-                  <a:srgbClr val="000000"/>
-                </a:solidFill>
-                <a:latin typeface="Times New Roman"/>
-              </a:rPr>
-              <a:t>. 2009;30(2):83-88.</a:t>
-            </a:r>
-          </a:p>
-          <a:p>
-            <a:pPr>
-              <a:spcAft>
-                <a:spcPts val="200"/>
-              </a:spcAft>
-            </a:pPr>
-            <a:r>
-              <a:rPr sz="1800" b="0" i="0">
-                <a:solidFill>
-                  <a:srgbClr val="000000"/>
-                </a:solidFill>
-                <a:latin typeface="Times New Roman"/>
-              </a:rPr>
-              <a:t>7. Liao LM, et al. </a:t>
-            </a:r>
-            <a:r>
-              <a:rPr sz="1800" b="0" i="1">
-                <a:solidFill>
-                  <a:srgbClr val="000000"/>
-                </a:solidFill>
-                <a:latin typeface="Times New Roman"/>
-              </a:rPr>
-              <a:t>Am J Obstet Gynecol</a:t>
-            </a:r>
-            <a:r>
-              <a:rPr sz="1800" b="0" i="0">
-                <a:solidFill>
-                  <a:srgbClr val="000000"/>
-                </a:solidFill>
-                <a:latin typeface="Times New Roman"/>
-              </a:rPr>
-              <a:t>. 2011;205(2):117.e1-117.e6.</a:t>
-            </a:r>
-          </a:p>
-          <a:p>
-            <a:pPr>
-              <a:spcAft>
-                <a:spcPts val="200"/>
-              </a:spcAft>
-            </a:pPr>
-            <a:r>
-              <a:rPr sz="1800" b="0" i="0">
-                <a:solidFill>
-                  <a:srgbClr val="000000"/>
-                </a:solidFill>
-                <a:latin typeface="Times New Roman"/>
-              </a:rPr>
-              <a:t>8. Facchin F, et al. </a:t>
-            </a:r>
-            <a:r>
-              <a:rPr sz="1800" b="0" i="1">
-                <a:solidFill>
-                  <a:srgbClr val="000000"/>
-                </a:solidFill>
-                <a:latin typeface="Times New Roman"/>
-              </a:rPr>
-              <a:t>J Health Psychol</a:t>
-            </a:r>
-            <a:r>
-              <a:rPr sz="1800" b="0" i="0">
-                <a:solidFill>
-                  <a:srgbClr val="000000"/>
-                </a:solidFill>
-                <a:latin typeface="Times New Roman"/>
-              </a:rPr>
-              <a:t>. 2021;26(1):26-39.</a:t>
-            </a:r>
-          </a:p>
-          <a:p>
-            <a:pPr>
-              <a:spcAft>
-                <a:spcPts val="200"/>
-              </a:spcAft>
-            </a:pPr>
-            <a:r>
-              <a:rPr sz="1800" b="0" i="0">
-                <a:solidFill>
-                  <a:srgbClr val="000000"/>
-                </a:solidFill>
-                <a:latin typeface="Times New Roman"/>
-              </a:rPr>
-              <a:t>Full list of the 35 included studies available on request.</a:t>
-            </a:r>
-          </a:p>
-          <a:p>
-            <a:pPr>
-              <a:spcAft>
-                <a:spcPts val="200"/>
-              </a:spcAft>
-            </a:pPr>
-            <a:r>
-              <a:rPr sz="1800" b="1" i="0">
-                <a:solidFill>
-                  <a:srgbClr val="000000"/>
-                </a:solidFill>
-                <a:latin typeface="Times New Roman"/>
-              </a:rPr>
-              <a:t>Acknowledgements:</a:t>
-            </a:r>
-            <a:r>
-              <a:rPr sz="1800" b="0" i="0">
-                <a:solidFill>
-                  <a:srgbClr val="000000"/>
-                </a:solidFill>
-                <a:latin typeface="Times New Roman"/>
-              </a:rPr>
-              <a:t> Mentorship by Dr. Paul Okojie and Dr. Robyn Anderson. No external funding.</a:t>
+                  <a:srgbClr val="595959"/>
+                </a:solidFill>
+                <a:latin typeface="Times New Roman"/>
+              </a:rPr>
+              <a:t>(5.53 × 5.53 in; links to the full reference list)</a:t>
             </a:r>
           </a:p>
         </p:txBody>
@@ -8780,8 +8836,8 @@
         </p:blipFill>
         <p:spPr>
           <a:xfrm>
-            <a:off x="11426868" y="4572000"/>
-            <a:ext cx="21494663" cy="9052560"/>
+            <a:off x="11915383" y="4480560"/>
+            <a:ext cx="20517632" cy="8641080"/>
           </a:xfrm>
           <a:prstGeom prst="rect">
             <a:avLst/>
@@ -8796,8 +8852,8 @@
         </p:nvSpPr>
         <p:spPr>
           <a:xfrm>
-            <a:off x="11347704" y="13716000"/>
-            <a:ext cx="21762720" cy="640080"/>
+            <a:off x="11347704" y="13167360"/>
+            <a:ext cx="21762720" cy="1051560"/>
           </a:xfrm>
           <a:prstGeom prst="rect">
             <a:avLst/>
@@ -8811,13 +8867,22 @@
           <a:lstStyle/>
           <a:p>
             <a:r>
-              <a:rPr sz="3000" b="0" i="0">
+              <a:rPr sz="2600" b="1" i="0">
                 <a:solidFill>
                   <a:srgbClr val="000000"/>
                 </a:solidFill>
                 <a:latin typeface="Times New Roman"/>
               </a:rPr>
-              <a:t>Figure 1. Frequency of Outcome Domains Across Included Studies (N = 35); studies could report more than one domain</a:t>
+              <a:t>Figure 1.</a:t>
+            </a:r>
+            <a:r>
+              <a:rPr sz="2600" b="0" i="0">
+                <a:solidFill>
+                  <a:srgbClr val="000000"/>
+                </a:solidFill>
+                <a:latin typeface="Times New Roman"/>
+              </a:rPr>
+              <a:t> Psychosexual and relational challenges were the most frequently reported outcome (24 of 35 studies); depression and anxiety were the least often assessed of the four outcome domains (14 of 35). Studies could report more than one domain.</a:t>
             </a:r>
           </a:p>
         </p:txBody>
@@ -8838,8 +8903,8 @@
         </p:blipFill>
         <p:spPr>
           <a:xfrm>
-            <a:off x="12063423" y="14630400"/>
-            <a:ext cx="8462368" cy="7589520"/>
+            <a:off x="12343803" y="14401800"/>
+            <a:ext cx="7901608" cy="7086600"/>
           </a:xfrm>
           <a:prstGeom prst="rect">
             <a:avLst/>
@@ -8854,8 +8919,8 @@
         </p:nvSpPr>
         <p:spPr>
           <a:xfrm>
-            <a:off x="11173968" y="22311360"/>
-            <a:ext cx="10241280" cy="1097280"/>
+            <a:off x="11173968" y="21579840"/>
+            <a:ext cx="10241280" cy="1463040"/>
           </a:xfrm>
           <a:prstGeom prst="rect">
             <a:avLst/>
@@ -8869,13 +8934,22 @@
           <a:lstStyle/>
           <a:p>
             <a:r>
-              <a:rPr sz="3000" b="0" i="0">
+              <a:rPr sz="2400" b="1" i="0">
                 <a:solidFill>
                   <a:srgbClr val="000000"/>
                 </a:solidFill>
                 <a:latin typeface="Times New Roman"/>
               </a:rPr>
-              <a:t>Figure 2. PRISMA-ScR Flow Diagram of Study Selection</a:t>
+              <a:t>Figure 2.</a:t>
+            </a:r>
+            <a:r>
+              <a:rPr sz="2400" b="0" i="0">
+                <a:solidFill>
+                  <a:srgbClr val="000000"/>
+                </a:solidFill>
+                <a:latin typeface="Times New Roman"/>
+              </a:rPr>
+              <a:t> PRISMA-ScR flow diagram: 516 records identified, 324 screened, 42 assessed for eligibility, and 35 included.</a:t>
             </a:r>
           </a:p>
         </p:txBody>
@@ -8896,7 +8970,7 @@
         </p:blipFill>
         <p:spPr>
           <a:xfrm>
-            <a:off x="22082760" y="15728251"/>
+            <a:off x="22082760" y="15225331"/>
             <a:ext cx="10881360" cy="5576697"/>
           </a:xfrm>
           <a:prstGeom prst="rect">
@@ -8912,8 +8986,8 @@
         </p:nvSpPr>
         <p:spPr>
           <a:xfrm>
-            <a:off x="22082760" y="22311360"/>
-            <a:ext cx="10881360" cy="1097280"/>
+            <a:off x="22082760" y="21579840"/>
+            <a:ext cx="10881360" cy="1463040"/>
           </a:xfrm>
           <a:prstGeom prst="rect">
             <a:avLst/>
@@ -8927,13 +9001,22 @@
           <a:lstStyle/>
           <a:p>
             <a:r>
-              <a:rPr sz="3000" b="0" i="0">
+              <a:rPr sz="2400" b="1" i="0">
                 <a:solidFill>
                   <a:srgbClr val="000000"/>
                 </a:solidFill>
                 <a:latin typeface="Times New Roman"/>
               </a:rPr>
-              <a:t>Figure 3. Geographic Distribution of Included Studies (N = 35)</a:t>
+              <a:t>Figure 3.</a:t>
+            </a:r>
+            <a:r>
+              <a:rPr sz="2400" b="0" i="0">
+                <a:solidFill>
+                  <a:srgbClr val="000000"/>
+                </a:solidFill>
+                <a:latin typeface="Times New Roman"/>
+              </a:rPr>
+              <a:t> Europe and Asia contributed 14 studies each, Africa and Oceania 1 each, and South America none (2 multinational studies not mapped).</a:t>
             </a:r>
           </a:p>
         </p:txBody>
@@ -8954,7 +9037,7 @@
         </p:blipFill>
         <p:spPr>
           <a:xfrm>
-            <a:off x="11173968" y="24328711"/>
+            <a:off x="11173968" y="23734351"/>
             <a:ext cx="10241280" cy="6206576"/>
           </a:xfrm>
           <a:prstGeom prst="rect">
@@ -8970,8 +9053,8 @@
         </p:nvSpPr>
         <p:spPr>
           <a:xfrm>
-            <a:off x="11173968" y="31181040"/>
-            <a:ext cx="10241280" cy="1097280"/>
+            <a:off x="11173968" y="30495240"/>
+            <a:ext cx="10241280" cy="1463040"/>
           </a:xfrm>
           <a:prstGeom prst="rect">
             <a:avLst/>
@@ -8985,13 +9068,22 @@
           <a:lstStyle/>
           <a:p>
             <a:r>
-              <a:rPr sz="3000" b="0" i="0">
+              <a:rPr sz="2400" b="1" i="0">
                 <a:solidFill>
                   <a:srgbClr val="000000"/>
                 </a:solidFill>
                 <a:latin typeface="Times New Roman"/>
               </a:rPr>
-              <a:t>Figure 4. Study Design Distribution (N = 35)</a:t>
+              <a:t>Figure 4.</a:t>
+            </a:r>
+            <a:r>
+              <a:rPr sz="2400" b="0" i="0">
+                <a:solidFill>
+                  <a:srgbClr val="000000"/>
+                </a:solidFill>
+                <a:latin typeface="Times New Roman"/>
+              </a:rPr>
+              <a:t> Study designs: 18 quantitative (51%), 14 qualitative (40%), 2 mixed-methods, and 1 not reported.</a:t>
             </a:r>
           </a:p>
         </p:txBody>
@@ -9012,7 +9104,7 @@
         </p:blipFill>
         <p:spPr>
           <a:xfrm>
-            <a:off x="22082760" y="25093683"/>
+            <a:off x="22082760" y="24499323"/>
             <a:ext cx="10881360" cy="4676633"/>
           </a:xfrm>
           <a:prstGeom prst="rect">
@@ -9028,8 +9120,8 @@
         </p:nvSpPr>
         <p:spPr>
           <a:xfrm>
-            <a:off x="22082760" y="31181040"/>
-            <a:ext cx="10881360" cy="1097280"/>
+            <a:off x="22082760" y="30495240"/>
+            <a:ext cx="10881360" cy="1463040"/>
           </a:xfrm>
           <a:prstGeom prst="rect">
             <a:avLst/>
@@ -9043,13 +9135,22 @@
           <a:lstStyle/>
           <a:p>
             <a:r>
-              <a:rPr sz="3000" b="0" i="0">
+              <a:rPr sz="2400" b="1" i="0">
                 <a:solidFill>
                   <a:srgbClr val="000000"/>
                 </a:solidFill>
                 <a:latin typeface="Times New Roman"/>
               </a:rPr>
-              <a:t>Figure 5. Coping Mechanisms Documented (15 studies)</a:t>
+              <a:t>Figure 5.</a:t>
+            </a:r>
+            <a:r>
+              <a:rPr sz="2400" b="0" i="0">
+                <a:solidFill>
+                  <a:srgbClr val="000000"/>
+                </a:solidFill>
+                <a:latin typeface="Times New Roman"/>
+              </a:rPr>
+              <a:t> Coping mechanisms in 15 studies: peer, family, and social support was most common (7), followed by avoidance and concealment (6).</a:t>
             </a:r>
           </a:p>
         </p:txBody>

</xml_diff>

<commit_message>
Poster: PRISMA flow diagram as Figure 1; figures ordered selection, design, outcomes, coping, geography
Co-Authored-By: Claude Opus 5.5 <noreply@anthropic.com>
Claude-Session: https://claude.ai/code/session_01N468nYR7vy45HpujgUezn5
</commit_message>
<xml_diff>
--- a/poster/MRKH_APHA2026_Poster.pptx
+++ b/poster/MRKH_APHA2026_Poster.pptx
@@ -8698,7 +8698,7 @@
                           </a:solidFill>
                           <a:latin typeface="Times New Roman"/>
                         </a:rPr>
-                        <a:t>516 records; 192 duplicates removed; 324 titles and abstracts screened; 42 assessed; 35 included (Figure 2). AI-assisted screening and charting, checked against full text for 30 of 35 studies. Charted design, country, sample, outcomes, coping, and healthcare gaps; synthesized with frequency counts and thematic grouping into 6 domains (Figure 1).</a:t>
+                        <a:t>516 records; 192 duplicates removed; 324 titles and abstracts screened; 42 assessed; 35 included (Figure 1). AI-assisted screening and charting, checked against full text for 30 of 35 studies. Charted design, country, sample, outcomes, coping, and healthcare gaps; synthesized with frequency counts and thematic grouping into 6 domains (Figure 3).</a:t>
                       </a:r>
                       <a:endParaRPr lang="en-US" sz="2400" dirty="0">
                         <a:latin typeface="Times New Roman" panose="02020603050405020304" pitchFamily="18" charset="0"/>
@@ -8822,7 +8822,7 @@
       </p:sp>
       <p:pic>
         <p:nvPicPr>
-          <p:cNvPr id="329" name="Picture 328" descr="fig1_outcomes_bar.png"/>
+          <p:cNvPr id="329" name="Picture 328" descr="prisma_flow.png"/>
           <p:cNvPicPr>
             <a:picLocks noChangeAspect="1"/>
           </p:cNvPicPr>
@@ -8836,8 +8836,8 @@
         </p:blipFill>
         <p:spPr>
           <a:xfrm>
-            <a:off x="11915383" y="4480560"/>
-            <a:ext cx="20517632" cy="8641080"/>
+            <a:off x="12114402" y="4572000"/>
+            <a:ext cx="8360411" cy="7498079"/>
           </a:xfrm>
           <a:prstGeom prst="rect">
             <a:avLst/>
@@ -8852,8 +8852,8 @@
         </p:nvSpPr>
         <p:spPr>
           <a:xfrm>
-            <a:off x="11347704" y="13167360"/>
-            <a:ext cx="21762720" cy="1051560"/>
+            <a:off x="11173968" y="12161520"/>
+            <a:ext cx="10241280" cy="1097280"/>
           </a:xfrm>
           <a:prstGeom prst="rect">
             <a:avLst/>
@@ -8867,7 +8867,7 @@
           <a:lstStyle/>
           <a:p>
             <a:r>
-              <a:rPr sz="2600" b="1" i="0">
+              <a:rPr sz="2400" b="1" i="0">
                 <a:solidFill>
                   <a:srgbClr val="000000"/>
                 </a:solidFill>
@@ -8876,20 +8876,20 @@
               <a:t>Figure 1.</a:t>
             </a:r>
             <a:r>
-              <a:rPr sz="2600" b="0" i="0">
+              <a:rPr sz="2400" b="0" i="0">
                 <a:solidFill>
                   <a:srgbClr val="000000"/>
                 </a:solidFill>
                 <a:latin typeface="Times New Roman"/>
               </a:rPr>
-              <a:t> Psychosexual and relational challenges were the most frequently reported outcome (24 of 35 studies); depression and anxiety were the least often assessed of the four outcome domains (14 of 35). Studies could report more than one domain.</a:t>
+              <a:t> PRISMA-ScR flow diagram: 516 records identified, 324 screened, 42 assessed for eligibility, and 35 included.</a:t>
             </a:r>
           </a:p>
         </p:txBody>
       </p:sp>
       <p:pic>
         <p:nvPicPr>
-          <p:cNvPr id="331" name="Picture 330" descr="prisma_flow.png"/>
+          <p:cNvPr id="331" name="Picture 330" descr="fig2_design_donut.png"/>
           <p:cNvPicPr>
             <a:picLocks noChangeAspect="1"/>
           </p:cNvPicPr>
@@ -8903,8 +8903,8 @@
         </p:blipFill>
         <p:spPr>
           <a:xfrm>
-            <a:off x="12343803" y="14401800"/>
-            <a:ext cx="7901608" cy="7086600"/>
+            <a:off x="22082760" y="5023796"/>
+            <a:ext cx="10881360" cy="6594487"/>
           </a:xfrm>
           <a:prstGeom prst="rect">
             <a:avLst/>
@@ -8919,8 +8919,8 @@
         </p:nvSpPr>
         <p:spPr>
           <a:xfrm>
-            <a:off x="11173968" y="21579840"/>
-            <a:ext cx="10241280" cy="1463040"/>
+            <a:off x="22082760" y="12161520"/>
+            <a:ext cx="10881360" cy="1097280"/>
           </a:xfrm>
           <a:prstGeom prst="rect">
             <a:avLst/>
@@ -8949,14 +8949,14 @@
                 </a:solidFill>
                 <a:latin typeface="Times New Roman"/>
               </a:rPr>
-              <a:t> PRISMA-ScR flow diagram: 516 records identified, 324 screened, 42 assessed for eligibility, and 35 included.</a:t>
+              <a:t> Study designs: 18 quantitative (51%), 14 qualitative (40%), 2 mixed-methods, and 1 not reported.</a:t>
             </a:r>
           </a:p>
         </p:txBody>
       </p:sp>
       <p:pic>
         <p:nvPicPr>
-          <p:cNvPr id="333" name="Picture 332" descr="fig3_geographic_map.png"/>
+          <p:cNvPr id="333" name="Picture 332" descr="fig1_outcomes_bar.png"/>
           <p:cNvPicPr>
             <a:picLocks noChangeAspect="1"/>
           </p:cNvPicPr>
@@ -8970,8 +8970,8 @@
         </p:blipFill>
         <p:spPr>
           <a:xfrm>
-            <a:off x="22082760" y="15225331"/>
-            <a:ext cx="10881360" cy="5576697"/>
+            <a:off x="12892413" y="13487400"/>
+            <a:ext cx="18563572" cy="7818120"/>
           </a:xfrm>
           <a:prstGeom prst="rect">
             <a:avLst/>
@@ -8986,8 +8986,8 @@
         </p:nvSpPr>
         <p:spPr>
           <a:xfrm>
-            <a:off x="22082760" y="21579840"/>
-            <a:ext cx="10881360" cy="1463040"/>
+            <a:off x="11347704" y="21351240"/>
+            <a:ext cx="21762720" cy="1097280"/>
           </a:xfrm>
           <a:prstGeom prst="rect">
             <a:avLst/>
@@ -9016,14 +9016,14 @@
                 </a:solidFill>
                 <a:latin typeface="Times New Roman"/>
               </a:rPr>
-              <a:t> Europe and Asia contributed 14 studies each, Africa and Oceania 1 each, and South America none (2 multinational studies not mapped).</a:t>
+              <a:t> Psychosexual and relational challenges were the most frequently reported outcome (24 of 35 studies); depression and anxiety were the least often assessed of the four outcome domains (14 of 35). Studies could report more than one domain.</a:t>
             </a:r>
           </a:p>
         </p:txBody>
       </p:sp>
       <p:pic>
         <p:nvPicPr>
-          <p:cNvPr id="335" name="Picture 334" descr="fig2_design_donut.png"/>
+          <p:cNvPr id="335" name="Picture 334" descr="fig5_coping_bar.png"/>
           <p:cNvPicPr>
             <a:picLocks noChangeAspect="1"/>
           </p:cNvPicPr>
@@ -9037,8 +9037,8 @@
         </p:blipFill>
         <p:spPr>
           <a:xfrm>
-            <a:off x="11173968" y="23734351"/>
-            <a:ext cx="10241280" cy="6206576"/>
+            <a:off x="11173968" y="24408271"/>
+            <a:ext cx="10241280" cy="4401537"/>
           </a:xfrm>
           <a:prstGeom prst="rect">
             <a:avLst/>
@@ -9083,14 +9083,14 @@
                 </a:solidFill>
                 <a:latin typeface="Times New Roman"/>
               </a:rPr>
-              <a:t> Study designs: 18 quantitative (51%), 14 qualitative (40%), 2 mixed-methods, and 1 not reported.</a:t>
+              <a:t> Coping mechanisms in 15 studies: peer, family, and social support was most common (7), followed by avoidance and concealment (6).</a:t>
             </a:r>
           </a:p>
         </p:txBody>
       </p:sp>
       <p:pic>
         <p:nvPicPr>
-          <p:cNvPr id="337" name="Picture 336" descr="fig5_coping_bar.png"/>
+          <p:cNvPr id="337" name="Picture 336" descr="fig3_geographic_map.png"/>
           <p:cNvPicPr>
             <a:picLocks noChangeAspect="1"/>
           </p:cNvPicPr>
@@ -9104,8 +9104,8 @@
         </p:blipFill>
         <p:spPr>
           <a:xfrm>
-            <a:off x="22082760" y="24499323"/>
-            <a:ext cx="10881360" cy="4676633"/>
+            <a:off x="22082760" y="23820691"/>
+            <a:ext cx="10881360" cy="5576697"/>
           </a:xfrm>
           <a:prstGeom prst="rect">
             <a:avLst/>
@@ -9150,7 +9150,7 @@
                 </a:solidFill>
                 <a:latin typeface="Times New Roman"/>
               </a:rPr>
-              <a:t> Coping mechanisms in 15 studies: peer, family, and social support was most common (7), followed by avoidance and concealment (6).</a:t>
+              <a:t> Europe and Asia contributed 14 studies each, Africa and Oceania 1 each, and South America none (2 multinational studies not mapped).</a:t>
             </a:r>
           </a:p>
         </p:txBody>

</xml_diff>

<commit_message>
Poster: fuller conclusion tied to the findings
Co-Authored-By: Claude Opus 5.5 <noreply@anthropic.com>
Claude-Session: https://claude.ai/code/session_01N468nYR7vy45HpujgUezn5
</commit_message>
<xml_diff>
--- a/poster/MRKH_APHA2026_Poster.pptx
+++ b/poster/MRKH_APHA2026_Poster.pptx
@@ -7575,7 +7575,7 @@
                 </a:solidFill>
                 <a:latin typeface="Times New Roman"/>
               </a:rPr>
-              <a:t>MRKH carries a substantial psychosocial burden that remains under-integrated into care. Mental health–inclusive, multidisciplinary care is needed to close this gap.</a:t>
+              <a:t>MRKH affects far more than reproductive anatomy. Psychosexual difficulties, emotional distress, and low self-esteem were widely reported, yet depression and anxiety were measured in fewer than half of studies, and coping relied mostly on peers or concealment rather than structured care. Embedding mental health screening, psychosexual counseling, and peer support in multidisciplinary MRKH care, and extending research to underrepresented regions, should be public health priorities.</a:t>
             </a:r>
           </a:p>
           <a:p>
@@ -7594,7 +7594,7 @@
                 </a:solidFill>
                 <a:latin typeface="Times New Roman"/>
               </a:rPr>
-              <a:t>Acknowledgements: mentorship by Dr. Paul Okojie and Dr. Robyn Anderson; no external funding.</a:t>
+              <a:t>Mentored by Dr. Paul Okojie and Dr. Robyn Anderson; no external funding.</a:t>
             </a:r>
           </a:p>
         </p:txBody>

</xml_diff>

<commit_message>
Poster: remove acknowledgement line
Co-Authored-By: Claude Opus 5.5 <noreply@anthropic.com>
Claude-Session: https://claude.ai/code/session_01N468nYR7vy45HpujgUezn5
</commit_message>
<xml_diff>
--- a/poster/MRKH_APHA2026_Poster.pptx
+++ b/poster/MRKH_APHA2026_Poster.pptx
@@ -7578,25 +7578,6 @@
               <a:t>MRKH affects far more than reproductive anatomy. Psychosexual difficulties, emotional distress, and low self-esteem were widely reported, yet depression and anxiety were measured in fewer than half of studies, and coping relied mostly on peers or concealment rather than structured care. Embedding mental health screening, psychosexual counseling, and peer support in multidisciplinary MRKH care, and extending research to underrepresented regions, should be public health priorities.</a:t>
             </a:r>
           </a:p>
-          <a:p>
-            <a:pPr algn="just">
-              <a:lnSpc>
-                <a:spcPct val="100000"/>
-              </a:lnSpc>
-              <a:spcAft>
-                <a:spcPts val="300"/>
-              </a:spcAft>
-            </a:pPr>
-            <a:r>
-              <a:rPr sz="2200" b="0" i="1">
-                <a:solidFill>
-                  <a:srgbClr val="000000"/>
-                </a:solidFill>
-                <a:latin typeface="Times New Roman"/>
-              </a:rPr>
-              <a:t>Mentored by Dr. Paul Okojie and Dr. Robyn Anderson; no external funding.</a:t>
-            </a:r>
-          </a:p>
         </p:txBody>
       </p:sp>
       <p:sp>

</xml_diff>

<commit_message>
Poster: Results, Discussion, Conclusion, and Limitations together; Public Health Implications and Future Work together (as in the Liberty sample)
Co-Authored-By: Claude Opus 5.5 <noreply@anthropic.com>
Claude-Session: https://claude.ai/code/session_01N468nYR7vy45HpujgUezn5
</commit_message>
<xml_diff>
--- a/poster/MRKH_APHA2026_Poster.pptx
+++ b/poster/MRKH_APHA2026_Poster.pptx
@@ -7321,8 +7321,8 @@
         </p:nvSpPr>
         <p:spPr>
           <a:xfrm>
-            <a:off x="34006536" y="19156680"/>
-            <a:ext cx="9253728" cy="7406640"/>
+            <a:off x="34006536" y="22338792"/>
+            <a:ext cx="9253728" cy="4270248"/>
           </a:xfrm>
           <a:prstGeom prst="rect">
             <a:avLst/>
@@ -7540,44 +7540,6 @@
               <a:t>• Studies in Africa, South America, and other low-resource settings</a:t>
             </a:r>
           </a:p>
-          <a:p>
-            <a:pPr algn="just">
-              <a:lnSpc>
-                <a:spcPct val="100000"/>
-              </a:lnSpc>
-              <a:spcAft>
-                <a:spcPts val="300"/>
-              </a:spcAft>
-            </a:pPr>
-            <a:r>
-              <a:rPr sz="2200" b="1" i="0">
-                <a:solidFill>
-                  <a:srgbClr val="000000"/>
-                </a:solidFill>
-                <a:latin typeface="Times New Roman"/>
-              </a:rPr>
-              <a:t>Conclusion</a:t>
-            </a:r>
-          </a:p>
-          <a:p>
-            <a:pPr algn="just">
-              <a:lnSpc>
-                <a:spcPct val="100000"/>
-              </a:lnSpc>
-              <a:spcAft>
-                <a:spcPts val="300"/>
-              </a:spcAft>
-            </a:pPr>
-            <a:r>
-              <a:rPr sz="2200" b="0" i="0">
-                <a:solidFill>
-                  <a:srgbClr val="000000"/>
-                </a:solidFill>
-                <a:latin typeface="Times New Roman"/>
-              </a:rPr>
-              <a:t>MRKH affects far more than reproductive anatomy. Psychosexual difficulties, emotional distress, and low self-esteem were widely reported, yet depression and anxiety were measured in fewer than half of studies, and coping relied mostly on peers or concealment rather than structured care. Mental health screening, psychosexual counseling, and peer support should become standard in multidisciplinary MRKH care, not an afterthought, and research must reach underrepresented regions.</a:t>
-            </a:r>
-          </a:p>
         </p:txBody>
       </p:sp>
       <p:sp>
@@ -7594,8 +7556,8 @@
         </p:nvSpPr>
         <p:spPr>
           <a:xfrm>
-            <a:off x="34006536" y="18288000"/>
-            <a:ext cx="9253728" cy="868680"/>
+            <a:off x="34006536" y="20848320"/>
+            <a:ext cx="9253728" cy="1490472"/>
           </a:xfrm>
           <a:prstGeom prst="rect">
             <a:avLst/>
@@ -7621,7 +7583,7 @@
                 <a:latin typeface="Times New Roman"/>
                 <a:cs typeface="Garamond"/>
               </a:rPr>
-              <a:t>Implications and Conclusion</a:t>
+              <a:t>Public Health Implications and Future Work</a:t>
             </a:r>
             <a:endParaRPr lang="en-US" sz="6000" dirty="0">
               <a:latin typeface="Garamond"/>
@@ -7694,8 +7656,8 @@
         </p:nvSpPr>
         <p:spPr>
           <a:xfrm>
-            <a:off x="34006536" y="5093208"/>
-            <a:ext cx="9253728" cy="13103352"/>
+            <a:off x="34006536" y="5861304"/>
+            <a:ext cx="9253728" cy="14895576"/>
           </a:xfrm>
           <a:prstGeom prst="rect">
             <a:avLst/>
@@ -7794,7 +7756,7 @@
         <p:spPr>
           <a:xfrm>
             <a:off x="34006536" y="4224528"/>
-            <a:ext cx="9253728" cy="868680"/>
+            <a:ext cx="9253728" cy="1636776"/>
           </a:xfrm>
           <a:prstGeom prst="rect">
             <a:avLst/>
@@ -7820,7 +7782,7 @@
                 <a:latin typeface="Times New Roman"/>
                 <a:cs typeface="Times New Roman"/>
               </a:rPr>
-              <a:t>Results and Discussion</a:t>
+              <a:t>Results, Discussion, Conclusion, and Limitations</a:t>
             </a:r>
             <a:endParaRPr lang="en-US" sz="6000" dirty="0">
               <a:latin typeface="Times New Roman"/>
@@ -7843,8 +7805,8 @@
         </p:nvSpPr>
         <p:spPr>
           <a:xfrm>
-            <a:off x="34116263" y="5138928"/>
-            <a:ext cx="9034272" cy="13011912"/>
+            <a:off x="34116263" y="5907024"/>
+            <a:ext cx="9034272" cy="14804136"/>
           </a:xfrm>
           <a:prstGeom prst="rect">
             <a:avLst/>
@@ -7871,7 +7833,364 @@
                 </a:solidFill>
                 <a:latin typeface="Times New Roman"/>
               </a:rPr>
-              <a:t>Key Findings</a:t>
+              <a:t>Key Findings:</a:t>
+            </a:r>
+            <a:r>
+              <a:rPr sz="2200" b="0" i="0">
+                <a:solidFill>
+                  <a:srgbClr val="000000"/>
+                </a:solidFill>
+                <a:latin typeface="Times New Roman"/>
+              </a:rPr>
+              <a:t> 35 studies from 2019–2026 were included (18 quantitative, 14 qualitative, 2 mixed-methods), with samples of 5 to 616 participants (Figures 1–5).</a:t>
+            </a:r>
+          </a:p>
+          <a:p>
+            <a:pPr algn="l" marL="274320" indent="-274320">
+              <a:lnSpc>
+                <a:spcPct val="100000"/>
+              </a:lnSpc>
+              <a:spcAft>
+                <a:spcPts val="400"/>
+              </a:spcAft>
+            </a:pPr>
+            <a:r>
+              <a:rPr sz="2200" b="0" i="0">
+                <a:solidFill>
+                  <a:srgbClr val="000000"/>
+                </a:solidFill>
+                <a:latin typeface="Times New Roman"/>
+              </a:rPr>
+              <a:t>• </a:t>
+            </a:r>
+            <a:r>
+              <a:rPr sz="2200" b="1" i="0">
+                <a:solidFill>
+                  <a:srgbClr val="000000"/>
+                </a:solidFill>
+                <a:latin typeface="Times New Roman"/>
+              </a:rPr>
+              <a:t>Psychosexual and relational (69%):</a:t>
+            </a:r>
+            <a:r>
+              <a:rPr sz="2200" b="0" i="0">
+                <a:solidFill>
+                  <a:srgbClr val="000000"/>
+                </a:solidFill>
+                <a:latin typeface="Times New Roman"/>
+              </a:rPr>
+              <a:t> lower sexual esteem and more negative genital self-image than controls, even after neovagina creation.</a:t>
+            </a:r>
+            <a:r>
+              <a:rPr sz="2200" b="0" i="0" baseline="30000">
+                <a:solidFill>
+                  <a:srgbClr val="000000"/>
+                </a:solidFill>
+                <a:latin typeface="Times New Roman"/>
+              </a:rPr>
+              <a:t>10,11</a:t>
+            </a:r>
+          </a:p>
+          <a:p>
+            <a:pPr algn="l" marL="274320" indent="-274320">
+              <a:lnSpc>
+                <a:spcPct val="100000"/>
+              </a:lnSpc>
+              <a:spcAft>
+                <a:spcPts val="400"/>
+              </a:spcAft>
+            </a:pPr>
+            <a:r>
+              <a:rPr sz="2200" b="0" i="0">
+                <a:solidFill>
+                  <a:srgbClr val="000000"/>
+                </a:solidFill>
+                <a:latin typeface="Times New Roman"/>
+              </a:rPr>
+              <a:t>• </a:t>
+            </a:r>
+            <a:r>
+              <a:rPr sz="2200" b="1" i="0">
+                <a:solidFill>
+                  <a:srgbClr val="000000"/>
+                </a:solidFill>
+                <a:latin typeface="Times New Roman"/>
+              </a:rPr>
+              <a:t>Psychological distress (57%):</a:t>
+            </a:r>
+            <a:r>
+              <a:rPr sz="2200" b="0" i="0">
+                <a:solidFill>
+                  <a:srgbClr val="000000"/>
+                </a:solidFill>
+                <a:latin typeface="Times New Roman"/>
+              </a:rPr>
+              <a:t> shock, grief, shame, and secrecy at diagnosis; the diagnostic process itself was described as upsetting and potentially traumatizing.</a:t>
+            </a:r>
+            <a:r>
+              <a:rPr sz="2200" b="0" i="0" baseline="30000">
+                <a:solidFill>
+                  <a:srgbClr val="000000"/>
+                </a:solidFill>
+                <a:latin typeface="Times New Roman"/>
+              </a:rPr>
+              <a:t>12,13</a:t>
+            </a:r>
+          </a:p>
+          <a:p>
+            <a:pPr algn="l" marL="274320" indent="-274320">
+              <a:lnSpc>
+                <a:spcPct val="100000"/>
+              </a:lnSpc>
+              <a:spcAft>
+                <a:spcPts val="400"/>
+              </a:spcAft>
+            </a:pPr>
+            <a:r>
+              <a:rPr sz="2200" b="0" i="0">
+                <a:solidFill>
+                  <a:srgbClr val="000000"/>
+                </a:solidFill>
+                <a:latin typeface="Times New Roman"/>
+              </a:rPr>
+              <a:t>• </a:t>
+            </a:r>
+            <a:r>
+              <a:rPr sz="2200" b="1" i="0">
+                <a:solidFill>
+                  <a:srgbClr val="000000"/>
+                </a:solidFill>
+                <a:latin typeface="Times New Roman"/>
+              </a:rPr>
+              <a:t>QoL, body image, and self-esteem (54%):</a:t>
+            </a:r>
+            <a:r>
+              <a:rPr sz="2200" b="0" i="0">
+                <a:solidFill>
+                  <a:srgbClr val="000000"/>
+                </a:solidFill>
+                <a:latin typeface="Times New Roman"/>
+              </a:rPr>
+              <a:t> impaired mental health–related quality of life,</a:t>
+            </a:r>
+            <a:r>
+              <a:rPr sz="2200" b="0" i="0" baseline="30000">
+                <a:solidFill>
+                  <a:srgbClr val="000000"/>
+                </a:solidFill>
+                <a:latin typeface="Times New Roman"/>
+              </a:rPr>
+              <a:t>14</a:t>
+            </a:r>
+            <a:r>
+              <a:rPr sz="2200" b="0" i="0">
+                <a:solidFill>
+                  <a:srgbClr val="000000"/>
+                </a:solidFill>
+                <a:latin typeface="Times New Roman"/>
+              </a:rPr>
+              <a:t> and higher distress with lower self-esteem than population norms.</a:t>
+            </a:r>
+            <a:r>
+              <a:rPr sz="2200" b="0" i="0" baseline="30000">
+                <a:solidFill>
+                  <a:srgbClr val="000000"/>
+                </a:solidFill>
+                <a:latin typeface="Times New Roman"/>
+              </a:rPr>
+              <a:t>15</a:t>
+            </a:r>
+          </a:p>
+          <a:p>
+            <a:pPr algn="l" marL="274320" indent="-274320">
+              <a:lnSpc>
+                <a:spcPct val="100000"/>
+              </a:lnSpc>
+              <a:spcAft>
+                <a:spcPts val="400"/>
+              </a:spcAft>
+            </a:pPr>
+            <a:r>
+              <a:rPr sz="2200" b="0" i="0">
+                <a:solidFill>
+                  <a:srgbClr val="000000"/>
+                </a:solidFill>
+                <a:latin typeface="Times New Roman"/>
+              </a:rPr>
+              <a:t>• </a:t>
+            </a:r>
+            <a:r>
+              <a:rPr sz="2200" b="1" i="0">
+                <a:solidFill>
+                  <a:srgbClr val="000000"/>
+                </a:solidFill>
+                <a:latin typeface="Times New Roman"/>
+              </a:rPr>
+              <a:t>Depression and anxiety (40%):</a:t>
+            </a:r>
+            <a:r>
+              <a:rPr sz="2200" b="0" i="0">
+                <a:solidFill>
+                  <a:srgbClr val="000000"/>
+                </a:solidFill>
+                <a:latin typeface="Times New Roman"/>
+              </a:rPr>
+              <a:t> depressive symptoms in 75.2% of 141 Chinese patients;</a:t>
+            </a:r>
+            <a:r>
+              <a:rPr sz="2200" b="0" i="0" baseline="30000">
+                <a:solidFill>
+                  <a:srgbClr val="000000"/>
+                </a:solidFill>
+                <a:latin typeface="Times New Roman"/>
+              </a:rPr>
+              <a:t>16</a:t>
+            </a:r>
+            <a:r>
+              <a:rPr sz="2200" b="0" i="0">
+                <a:solidFill>
+                  <a:srgbClr val="000000"/>
+                </a:solidFill>
+                <a:latin typeface="Times New Roman"/>
+              </a:rPr>
+              <a:t> anxiety in 37.7% and depression in 32.5% of 77 Malaysian women.</a:t>
+            </a:r>
+            <a:r>
+              <a:rPr sz="2200" b="0" i="0" baseline="30000">
+                <a:solidFill>
+                  <a:srgbClr val="000000"/>
+                </a:solidFill>
+                <a:latin typeface="Times New Roman"/>
+              </a:rPr>
+              <a:t>17</a:t>
+            </a:r>
+            <a:r>
+              <a:rPr sz="2200" b="0" i="0">
+                <a:solidFill>
+                  <a:srgbClr val="000000"/>
+                </a:solidFill>
+                <a:latin typeface="Times New Roman"/>
+              </a:rPr>
+              <a:t> Findings were mixed: uterus transplant candidates in France showed few symptoms.</a:t>
+            </a:r>
+            <a:r>
+              <a:rPr sz="2200" b="0" i="0" baseline="30000">
+                <a:solidFill>
+                  <a:srgbClr val="000000"/>
+                </a:solidFill>
+                <a:latin typeface="Times New Roman"/>
+              </a:rPr>
+              <a:t>18</a:t>
+            </a:r>
+          </a:p>
+          <a:p>
+            <a:pPr algn="l" marL="274320" indent="-274320">
+              <a:lnSpc>
+                <a:spcPct val="100000"/>
+              </a:lnSpc>
+              <a:spcAft>
+                <a:spcPts val="400"/>
+              </a:spcAft>
+            </a:pPr>
+            <a:r>
+              <a:rPr sz="2200" b="0" i="0">
+                <a:solidFill>
+                  <a:srgbClr val="000000"/>
+                </a:solidFill>
+                <a:latin typeface="Times New Roman"/>
+              </a:rPr>
+              <a:t>• </a:t>
+            </a:r>
+            <a:r>
+              <a:rPr sz="2200" b="1" i="0">
+                <a:solidFill>
+                  <a:srgbClr val="000000"/>
+                </a:solidFill>
+                <a:latin typeface="Times New Roman"/>
+              </a:rPr>
+              <a:t>Coping (43%):</a:t>
+            </a:r>
+            <a:r>
+              <a:rPr sz="2200" b="0" i="0">
+                <a:solidFill>
+                  <a:srgbClr val="000000"/>
+                </a:solidFill>
+                <a:latin typeface="Times New Roman"/>
+              </a:rPr>
+              <a:t> peer and online support most common; avoidance and concealment also frequent, and one study traced a shift from avoidance to empowerment.</a:t>
+            </a:r>
+            <a:r>
+              <a:rPr sz="2200" b="0" i="0" baseline="30000">
+                <a:solidFill>
+                  <a:srgbClr val="000000"/>
+                </a:solidFill>
+                <a:latin typeface="Times New Roman"/>
+              </a:rPr>
+              <a:t>19</a:t>
+            </a:r>
+            <a:r>
+              <a:rPr sz="2200" b="0" i="0">
+                <a:solidFill>
+                  <a:srgbClr val="000000"/>
+                </a:solidFill>
+                <a:latin typeface="Times New Roman"/>
+              </a:rPr>
+              <a:t> Only 2 intervention studies were found, both reporting benefit.</a:t>
+            </a:r>
+            <a:r>
+              <a:rPr sz="2200" b="0" i="0" baseline="30000">
+                <a:solidFill>
+                  <a:srgbClr val="000000"/>
+                </a:solidFill>
+                <a:latin typeface="Times New Roman"/>
+              </a:rPr>
+              <a:t>20,21</a:t>
+            </a:r>
+          </a:p>
+          <a:p>
+            <a:pPr algn="l" marL="274320" indent="-274320">
+              <a:lnSpc>
+                <a:spcPct val="100000"/>
+              </a:lnSpc>
+              <a:spcAft>
+                <a:spcPts val="400"/>
+              </a:spcAft>
+            </a:pPr>
+            <a:r>
+              <a:rPr sz="2200" b="0" i="0">
+                <a:solidFill>
+                  <a:srgbClr val="000000"/>
+                </a:solidFill>
+                <a:latin typeface="Times New Roman"/>
+              </a:rPr>
+              <a:t>• </a:t>
+            </a:r>
+            <a:r>
+              <a:rPr sz="2200" b="1" i="0">
+                <a:solidFill>
+                  <a:srgbClr val="000000"/>
+                </a:solidFill>
+                <a:latin typeface="Times New Roman"/>
+              </a:rPr>
+              <a:t>Healthcare gaps (29%):</a:t>
+            </a:r>
+            <a:r>
+              <a:rPr sz="2200" b="0" i="0">
+                <a:solidFill>
+                  <a:srgbClr val="000000"/>
+                </a:solidFill>
+                <a:latin typeface="Times New Roman"/>
+              </a:rPr>
+              <a:t> delayed diagnosis, providers unfamiliar with MRKH, and patients forced to self-advocate.</a:t>
+            </a:r>
+            <a:r>
+              <a:rPr sz="2200" b="0" i="0" baseline="30000">
+                <a:solidFill>
+                  <a:srgbClr val="000000"/>
+                </a:solidFill>
+                <a:latin typeface="Times New Roman"/>
+              </a:rPr>
+              <a:t>22,23</a:t>
             </a:r>
           </a:p>
           <a:p>
@@ -7884,361 +8203,13 @@
               </a:spcAft>
             </a:pPr>
             <a:r>
-              <a:rPr sz="2200" b="0" i="0">
+              <a:rPr sz="2200" b="1" i="0">
                 <a:solidFill>
                   <a:srgbClr val="000000"/>
                 </a:solidFill>
                 <a:latin typeface="Times New Roman"/>
               </a:rPr>
-              <a:t>35 studies from 2019–2026 were included (18 quantitative, 14 qualitative, 2 mixed-methods), with samples of 5 to 616 participants (Figures 1–5).</a:t>
-            </a:r>
-          </a:p>
-          <a:p>
-            <a:pPr algn="l" marL="274320" indent="-274320">
-              <a:lnSpc>
-                <a:spcPct val="100000"/>
-              </a:lnSpc>
-              <a:spcAft>
-                <a:spcPts val="400"/>
-              </a:spcAft>
-            </a:pPr>
-            <a:r>
-              <a:rPr sz="2200" b="0" i="0">
-                <a:solidFill>
-                  <a:srgbClr val="000000"/>
-                </a:solidFill>
-                <a:latin typeface="Times New Roman"/>
-              </a:rPr>
-              <a:t>• </a:t>
-            </a:r>
-            <a:r>
-              <a:rPr sz="2200" b="1" i="0">
-                <a:solidFill>
-                  <a:srgbClr val="000000"/>
-                </a:solidFill>
-                <a:latin typeface="Times New Roman"/>
-              </a:rPr>
-              <a:t>Psychosexual and relational (69%):</a:t>
-            </a:r>
-            <a:r>
-              <a:rPr sz="2200" b="0" i="0">
-                <a:solidFill>
-                  <a:srgbClr val="000000"/>
-                </a:solidFill>
-                <a:latin typeface="Times New Roman"/>
-              </a:rPr>
-              <a:t> lower sexual esteem and more negative genital self-image than controls, even after neovagina creation.</a:t>
-            </a:r>
-            <a:r>
-              <a:rPr sz="2200" b="0" i="0" baseline="30000">
-                <a:solidFill>
-                  <a:srgbClr val="000000"/>
-                </a:solidFill>
-                <a:latin typeface="Times New Roman"/>
-              </a:rPr>
-              <a:t>10,11</a:t>
-            </a:r>
-          </a:p>
-          <a:p>
-            <a:pPr algn="l" marL="274320" indent="-274320">
-              <a:lnSpc>
-                <a:spcPct val="100000"/>
-              </a:lnSpc>
-              <a:spcAft>
-                <a:spcPts val="400"/>
-              </a:spcAft>
-            </a:pPr>
-            <a:r>
-              <a:rPr sz="2200" b="0" i="0">
-                <a:solidFill>
-                  <a:srgbClr val="000000"/>
-                </a:solidFill>
-                <a:latin typeface="Times New Roman"/>
-              </a:rPr>
-              <a:t>• </a:t>
-            </a:r>
-            <a:r>
-              <a:rPr sz="2200" b="1" i="0">
-                <a:solidFill>
-                  <a:srgbClr val="000000"/>
-                </a:solidFill>
-                <a:latin typeface="Times New Roman"/>
-              </a:rPr>
-              <a:t>Psychological distress (57%):</a:t>
-            </a:r>
-            <a:r>
-              <a:rPr sz="2200" b="0" i="0">
-                <a:solidFill>
-                  <a:srgbClr val="000000"/>
-                </a:solidFill>
-                <a:latin typeface="Times New Roman"/>
-              </a:rPr>
-              <a:t> shock, grief, shame, and secrecy at diagnosis; the diagnostic process itself was described as upsetting and potentially traumatizing.</a:t>
-            </a:r>
-            <a:r>
-              <a:rPr sz="2200" b="0" i="0" baseline="30000">
-                <a:solidFill>
-                  <a:srgbClr val="000000"/>
-                </a:solidFill>
-                <a:latin typeface="Times New Roman"/>
-              </a:rPr>
-              <a:t>12,13</a:t>
-            </a:r>
-          </a:p>
-          <a:p>
-            <a:pPr algn="l" marL="274320" indent="-274320">
-              <a:lnSpc>
-                <a:spcPct val="100000"/>
-              </a:lnSpc>
-              <a:spcAft>
-                <a:spcPts val="400"/>
-              </a:spcAft>
-            </a:pPr>
-            <a:r>
-              <a:rPr sz="2200" b="0" i="0">
-                <a:solidFill>
-                  <a:srgbClr val="000000"/>
-                </a:solidFill>
-                <a:latin typeface="Times New Roman"/>
-              </a:rPr>
-              <a:t>• </a:t>
-            </a:r>
-            <a:r>
-              <a:rPr sz="2200" b="1" i="0">
-                <a:solidFill>
-                  <a:srgbClr val="000000"/>
-                </a:solidFill>
-                <a:latin typeface="Times New Roman"/>
-              </a:rPr>
-              <a:t>QoL, body image, and self-esteem (54%):</a:t>
-            </a:r>
-            <a:r>
-              <a:rPr sz="2200" b="0" i="0">
-                <a:solidFill>
-                  <a:srgbClr val="000000"/>
-                </a:solidFill>
-                <a:latin typeface="Times New Roman"/>
-              </a:rPr>
-              <a:t> impaired mental health–related quality of life,</a:t>
-            </a:r>
-            <a:r>
-              <a:rPr sz="2200" b="0" i="0" baseline="30000">
-                <a:solidFill>
-                  <a:srgbClr val="000000"/>
-                </a:solidFill>
-                <a:latin typeface="Times New Roman"/>
-              </a:rPr>
-              <a:t>14</a:t>
-            </a:r>
-            <a:r>
-              <a:rPr sz="2200" b="0" i="0">
-                <a:solidFill>
-                  <a:srgbClr val="000000"/>
-                </a:solidFill>
-                <a:latin typeface="Times New Roman"/>
-              </a:rPr>
-              <a:t> and higher distress with lower self-esteem than population norms.</a:t>
-            </a:r>
-            <a:r>
-              <a:rPr sz="2200" b="0" i="0" baseline="30000">
-                <a:solidFill>
-                  <a:srgbClr val="000000"/>
-                </a:solidFill>
-                <a:latin typeface="Times New Roman"/>
-              </a:rPr>
-              <a:t>15</a:t>
-            </a:r>
-          </a:p>
-          <a:p>
-            <a:pPr algn="l" marL="274320" indent="-274320">
-              <a:lnSpc>
-                <a:spcPct val="100000"/>
-              </a:lnSpc>
-              <a:spcAft>
-                <a:spcPts val="400"/>
-              </a:spcAft>
-            </a:pPr>
-            <a:r>
-              <a:rPr sz="2200" b="0" i="0">
-                <a:solidFill>
-                  <a:srgbClr val="000000"/>
-                </a:solidFill>
-                <a:latin typeface="Times New Roman"/>
-              </a:rPr>
-              <a:t>• </a:t>
-            </a:r>
-            <a:r>
-              <a:rPr sz="2200" b="1" i="0">
-                <a:solidFill>
-                  <a:srgbClr val="000000"/>
-                </a:solidFill>
-                <a:latin typeface="Times New Roman"/>
-              </a:rPr>
-              <a:t>Depression and anxiety (40%):</a:t>
-            </a:r>
-            <a:r>
-              <a:rPr sz="2200" b="0" i="0">
-                <a:solidFill>
-                  <a:srgbClr val="000000"/>
-                </a:solidFill>
-                <a:latin typeface="Times New Roman"/>
-              </a:rPr>
-              <a:t> depressive symptoms in 75.2% of 141 Chinese patients;</a:t>
-            </a:r>
-            <a:r>
-              <a:rPr sz="2200" b="0" i="0" baseline="30000">
-                <a:solidFill>
-                  <a:srgbClr val="000000"/>
-                </a:solidFill>
-                <a:latin typeface="Times New Roman"/>
-              </a:rPr>
-              <a:t>16</a:t>
-            </a:r>
-            <a:r>
-              <a:rPr sz="2200" b="0" i="0">
-                <a:solidFill>
-                  <a:srgbClr val="000000"/>
-                </a:solidFill>
-                <a:latin typeface="Times New Roman"/>
-              </a:rPr>
-              <a:t> anxiety in 37.7% and depression in 32.5% of 77 Malaysian women.</a:t>
-            </a:r>
-            <a:r>
-              <a:rPr sz="2200" b="0" i="0" baseline="30000">
-                <a:solidFill>
-                  <a:srgbClr val="000000"/>
-                </a:solidFill>
-                <a:latin typeface="Times New Roman"/>
-              </a:rPr>
-              <a:t>17</a:t>
-            </a:r>
-            <a:r>
-              <a:rPr sz="2200" b="0" i="0">
-                <a:solidFill>
-                  <a:srgbClr val="000000"/>
-                </a:solidFill>
-                <a:latin typeface="Times New Roman"/>
-              </a:rPr>
-              <a:t> Findings were mixed: uterus transplant candidates in France showed few symptoms.</a:t>
-            </a:r>
-            <a:r>
-              <a:rPr sz="2200" b="0" i="0" baseline="30000">
-                <a:solidFill>
-                  <a:srgbClr val="000000"/>
-                </a:solidFill>
-                <a:latin typeface="Times New Roman"/>
-              </a:rPr>
-              <a:t>18</a:t>
-            </a:r>
-          </a:p>
-          <a:p>
-            <a:pPr algn="l" marL="274320" indent="-274320">
-              <a:lnSpc>
-                <a:spcPct val="100000"/>
-              </a:lnSpc>
-              <a:spcAft>
-                <a:spcPts val="400"/>
-              </a:spcAft>
-            </a:pPr>
-            <a:r>
-              <a:rPr sz="2200" b="0" i="0">
-                <a:solidFill>
-                  <a:srgbClr val="000000"/>
-                </a:solidFill>
-                <a:latin typeface="Times New Roman"/>
-              </a:rPr>
-              <a:t>• </a:t>
-            </a:r>
-            <a:r>
-              <a:rPr sz="2200" b="1" i="0">
-                <a:solidFill>
-                  <a:srgbClr val="000000"/>
-                </a:solidFill>
-                <a:latin typeface="Times New Roman"/>
-              </a:rPr>
-              <a:t>Coping (43%):</a:t>
-            </a:r>
-            <a:r>
-              <a:rPr sz="2200" b="0" i="0">
-                <a:solidFill>
-                  <a:srgbClr val="000000"/>
-                </a:solidFill>
-                <a:latin typeface="Times New Roman"/>
-              </a:rPr>
-              <a:t> peer and online support most common; avoidance and concealment also frequent, and one study traced a shift from avoidance to empowerment.</a:t>
-            </a:r>
-            <a:r>
-              <a:rPr sz="2200" b="0" i="0" baseline="30000">
-                <a:solidFill>
-                  <a:srgbClr val="000000"/>
-                </a:solidFill>
-                <a:latin typeface="Times New Roman"/>
-              </a:rPr>
-              <a:t>19</a:t>
-            </a:r>
-            <a:r>
-              <a:rPr sz="2200" b="0" i="0">
-                <a:solidFill>
-                  <a:srgbClr val="000000"/>
-                </a:solidFill>
-                <a:latin typeface="Times New Roman"/>
-              </a:rPr>
-              <a:t> Only 2 intervention studies were found, both reporting benefit.</a:t>
-            </a:r>
-            <a:r>
-              <a:rPr sz="2200" b="0" i="0" baseline="30000">
-                <a:solidFill>
-                  <a:srgbClr val="000000"/>
-                </a:solidFill>
-                <a:latin typeface="Times New Roman"/>
-              </a:rPr>
-              <a:t>20,21</a:t>
-            </a:r>
-          </a:p>
-          <a:p>
-            <a:pPr algn="l" marL="274320" indent="-274320">
-              <a:lnSpc>
-                <a:spcPct val="100000"/>
-              </a:lnSpc>
-              <a:spcAft>
-                <a:spcPts val="400"/>
-              </a:spcAft>
-            </a:pPr>
-            <a:r>
-              <a:rPr sz="2200" b="0" i="0">
-                <a:solidFill>
-                  <a:srgbClr val="000000"/>
-                </a:solidFill>
-                <a:latin typeface="Times New Roman"/>
-              </a:rPr>
-              <a:t>• </a:t>
-            </a:r>
-            <a:r>
-              <a:rPr sz="2200" b="1" i="0">
-                <a:solidFill>
-                  <a:srgbClr val="000000"/>
-                </a:solidFill>
-                <a:latin typeface="Times New Roman"/>
-              </a:rPr>
-              <a:t>Healthcare gaps (29%):</a:t>
-            </a:r>
-            <a:r>
-              <a:rPr sz="2200" b="0" i="0">
-                <a:solidFill>
-                  <a:srgbClr val="000000"/>
-                </a:solidFill>
-                <a:latin typeface="Times New Roman"/>
-              </a:rPr>
-              <a:t> delayed diagnosis, providers unfamiliar with MRKH, and patients forced to self-advocate.</a:t>
-            </a:r>
-            <a:r>
-              <a:rPr sz="2200" b="0" i="0" baseline="30000">
-                <a:solidFill>
-                  <a:srgbClr val="000000"/>
-                </a:solidFill>
-                <a:latin typeface="Times New Roman"/>
-              </a:rPr>
-              <a:t>22,23</a:t>
+              <a:t>Discussion</a:t>
             </a:r>
           </a:p>
           <a:p>
@@ -8251,13 +8222,31 @@
               </a:spcAft>
             </a:pPr>
             <a:r>
-              <a:rPr sz="2200" b="1" i="0">
+              <a:rPr sz="2200" b="0" i="0">
                 <a:solidFill>
                   <a:srgbClr val="000000"/>
                 </a:solidFill>
                 <a:latin typeface="Times New Roman"/>
               </a:rPr>
-              <a:t>Discussion</a:t>
+              <a:t>Findings echo earlier evidence of distress and reduced quality of life in MRKH</a:t>
+            </a:r>
+            <a:r>
+              <a:rPr sz="2200" b="0" i="0" baseline="30000">
+                <a:solidFill>
+                  <a:srgbClr val="000000"/>
+                </a:solidFill>
+                <a:latin typeface="Times New Roman"/>
+              </a:rPr>
+              <a:t>3,5</a:t>
+            </a:r>
+            <a:r>
+              <a:rPr sz="2200" b="0" i="0">
+                <a:solidFill>
+                  <a:srgbClr val="000000"/>
+                </a:solidFill>
+                <a:latin typeface="Times New Roman"/>
+              </a:rPr>
+              <a:t> and extend prior reviews by mapping coping and health-system gaps. Psychosexual concerns dominate the recent literature, whereas depression and anxiety were measured in fewer than half of studies. Evidence is concentrated in Europe (14) and Asia (14); 1 study came from Africa and none from South America, where expectations about fertility and marriage may shape experiences differently.</a:t>
             </a:r>
           </a:p>
           <a:p>
@@ -8270,49 +8259,32 @@
               </a:spcAft>
             </a:pPr>
             <a:r>
+              <a:rPr sz="2200" b="1" i="0">
+                <a:solidFill>
+                  <a:srgbClr val="000000"/>
+                </a:solidFill>
+                <a:latin typeface="Times New Roman"/>
+              </a:rPr>
+              <a:t>Conclusion</a:t>
+            </a:r>
+          </a:p>
+          <a:p>
+            <a:pPr algn="just">
+              <a:lnSpc>
+                <a:spcPct val="100000"/>
+              </a:lnSpc>
+              <a:spcAft>
+                <a:spcPts val="400"/>
+              </a:spcAft>
+            </a:pPr>
+            <a:r>
               <a:rPr sz="2200" b="0" i="0">
                 <a:solidFill>
                   <a:srgbClr val="000000"/>
                 </a:solidFill>
                 <a:latin typeface="Times New Roman"/>
               </a:rPr>
-              <a:t>Findings echo earlier evidence of distress and reduced quality of life in MRKH</a:t>
-            </a:r>
-            <a:r>
-              <a:rPr sz="2200" b="0" i="0" baseline="30000">
-                <a:solidFill>
-                  <a:srgbClr val="000000"/>
-                </a:solidFill>
-                <a:latin typeface="Times New Roman"/>
-              </a:rPr>
-              <a:t>3,5</a:t>
-            </a:r>
-            <a:r>
-              <a:rPr sz="2200" b="0" i="0">
-                <a:solidFill>
-                  <a:srgbClr val="000000"/>
-                </a:solidFill>
-                <a:latin typeface="Times New Roman"/>
-              </a:rPr>
-              <a:t> and extend prior reviews by mapping coping and health-system gaps. Structured support can help (group cognitive-behavioral therapy improved psychological outcomes in an earlier trial</a:t>
-            </a:r>
-            <a:r>
-              <a:rPr sz="2200" b="0" i="0" baseline="30000">
-                <a:solidFill>
-                  <a:srgbClr val="000000"/>
-                </a:solidFill>
-                <a:latin typeface="Times New Roman"/>
-              </a:rPr>
-              <a:t>24</a:t>
-            </a:r>
-            <a:r>
-              <a:rPr sz="2200" b="0" i="0">
-                <a:solidFill>
-                  <a:srgbClr val="000000"/>
-                </a:solidFill>
-                <a:latin typeface="Times New Roman"/>
-              </a:rPr>
-              <a:t>), yet few recent studies tested interventions. Psychosexual concerns dominate the recent literature, whereas depression and anxiety were measured in fewer than half of studies. Evidence is concentrated in Europe (14) and Asia (14); 1 study came from Africa and none from South America, where expectations about fertility and marriage may shape experiences differently.</a:t>
+              <a:t>MRKH affects far more than reproductive anatomy. Psychosexual difficulties, emotional distress, and low self-esteem were widely reported, yet depression and anxiety were measured in fewer than half of studies, and coping relied mostly on peers or concealment rather than structured care. Mental health screening, psychosexual counseling, and peer support should become standard in multidisciplinary MRKH care, not an afterthought, and research must reach underrepresented regions.</a:t>
             </a:r>
           </a:p>
           <a:p>

</xml_diff>

<commit_message>
Poster: drop non-essential in-text citations
Co-Authored-By: Claude Opus 5.5 <noreply@anthropic.com>
Claude-Session: https://claude.ai/code/session_01N468nYR7vy45HpujgUezn5
</commit_message>
<xml_diff>
--- a/poster/MRKH_APHA2026_Poster.pptx
+++ b/poster/MRKH_APHA2026_Poster.pptx
@@ -7011,25 +7011,7 @@
                 </a:solidFill>
                 <a:latin typeface="Times New Roman"/>
               </a:rPr>
-              <a:t> It is usually diagnosed in adolescence during evaluation of primary amenorrhea,</a:t>
-            </a:r>
-            <a:r>
-              <a:rPr sz="2200" b="0" i="0" baseline="30000">
-                <a:solidFill>
-                  <a:srgbClr val="000000"/>
-                </a:solidFill>
-                <a:latin typeface="Times New Roman"/>
-              </a:rPr>
-              <a:t>1</a:t>
-            </a:r>
-            <a:r>
-              <a:rPr sz="2200" b="0" i="0">
-                <a:solidFill>
-                  <a:srgbClr val="000000"/>
-                </a:solidFill>
-                <a:latin typeface="Times New Roman"/>
-              </a:rPr>
-              <a:t> a sensitive period for identity, sexuality, and relationships. Earlier studies linked MRKH with psychological distress, anxiety, and reduced quality of life,</a:t>
+              <a:t> It is usually diagnosed in adolescence during evaluation of primary amenorrhea, a sensitive period for identity, sexuality, and relationships. Earlier studies linked MRKH with psychological distress, anxiety, and reduced quality of life,</a:t>
             </a:r>
             <a:r>
               <a:rPr sz="2200" b="0" i="0" baseline="30000">
@@ -7378,15 +7360,6 @@
               </a:rPr>
               <a:t>• Integrate psychosocial screening and support into MRKH diagnostic pathways</a:t>
             </a:r>
-            <a:r>
-              <a:rPr sz="2200" b="0" i="0" baseline="30000">
-                <a:solidFill>
-                  <a:srgbClr val="000000"/>
-                </a:solidFill>
-                <a:latin typeface="Times New Roman"/>
-              </a:rPr>
-              <a:t>1</a:t>
-            </a:r>
           </a:p>
           <a:p>
             <a:pPr algn="l" marL="274320" indent="-274320">
@@ -7934,7 +7907,7 @@
                 </a:solidFill>
                 <a:latin typeface="Times New Roman"/>
               </a:rPr>
-              <a:t>12,13</a:t>
+              <a:t>12</a:t>
             </a:r>
           </a:p>
           <a:p>
@@ -7980,7 +7953,7 @@
                 </a:solidFill>
                 <a:latin typeface="Times New Roman"/>
               </a:rPr>
-              <a:t>14</a:t>
+              <a:t>13</a:t>
             </a:r>
             <a:r>
               <a:rPr sz="2200" b="0" i="0">
@@ -7998,7 +7971,7 @@
                 </a:solidFill>
                 <a:latin typeface="Times New Roman"/>
               </a:rPr>
-              <a:t>15</a:t>
+              <a:t>14</a:t>
             </a:r>
           </a:p>
           <a:p>
@@ -8044,7 +8017,7 @@
                 </a:solidFill>
                 <a:latin typeface="Times New Roman"/>
               </a:rPr>
-              <a:t>16</a:t>
+              <a:t>15</a:t>
             </a:r>
             <a:r>
               <a:rPr sz="2200" b="0" i="0">
@@ -8062,7 +8035,7 @@
                 </a:solidFill>
                 <a:latin typeface="Times New Roman"/>
               </a:rPr>
-              <a:t>17</a:t>
+              <a:t>16</a:t>
             </a:r>
             <a:r>
               <a:rPr sz="2200" b="0" i="0">
@@ -8080,7 +8053,7 @@
                 </a:solidFill>
                 <a:latin typeface="Times New Roman"/>
               </a:rPr>
-              <a:t>18</a:t>
+              <a:t>17</a:t>
             </a:r>
           </a:p>
           <a:p>
@@ -8126,7 +8099,7 @@
                 </a:solidFill>
                 <a:latin typeface="Times New Roman"/>
               </a:rPr>
-              <a:t>19</a:t>
+              <a:t>18</a:t>
             </a:r>
             <a:r>
               <a:rPr sz="2200" b="0" i="0">
@@ -8144,7 +8117,7 @@
                 </a:solidFill>
                 <a:latin typeface="Times New Roman"/>
               </a:rPr>
-              <a:t>20,21</a:t>
+              <a:t>19,20</a:t>
             </a:r>
           </a:p>
           <a:p>
@@ -8182,15 +8155,6 @@
                 <a:latin typeface="Times New Roman"/>
               </a:rPr>
               <a:t> delayed diagnosis, providers unfamiliar with MRKH, and patients forced to self-advocate.</a:t>
-            </a:r>
-            <a:r>
-              <a:rPr sz="2200" b="0" i="0" baseline="30000">
-                <a:solidFill>
-                  <a:srgbClr val="000000"/>
-                </a:solidFill>
-                <a:latin typeface="Times New Roman"/>
-              </a:rPr>
-              <a:t>22,23</a:t>
             </a:r>
           </a:p>
           <a:p>

</xml_diff>

<commit_message>
Abstract (poster and manuscript) aligned with poster results and conclusion
Co-Authored-By: Claude Opus 5.5 <noreply@anthropic.com>
Claude-Session: https://claude.ai/code/session_01N468nYR7vy45HpujgUezn5
</commit_message>
<xml_diff>
--- a/poster/MRKH_APHA2026_Poster.pptx
+++ b/poster/MRKH_APHA2026_Poster.pptx
@@ -6841,7 +6841,7 @@
                 </a:solidFill>
                 <a:latin typeface="Times New Roman"/>
               </a:rPr>
-              <a:t> Of 516 records, 35 studies were included. Psychosexual and relational challenges were most frequent (n = 24), followed by psychological distress (n = 20), reduced QoL, body image, and self-esteem (n = 19), and depression and anxiety (n = 14). Coping was documented in 15 studies, mostly peer support; healthcare gaps in 10.</a:t>
+              <a:t> Of 516 records, 35 studies were included. Psychosexual and relational challenges were most frequent (n = 24), followed by psychological distress (n = 20), reduced QoL, body image, and self-esteem (n = 19), and depression and anxiety (n = 14). Coping was documented in 15 studies, most often peer support (7) and avoidance or concealment (6); healthcare gaps in 10.</a:t>
             </a:r>
           </a:p>
           <a:p>
@@ -6869,7 +6869,7 @@
                 </a:solidFill>
                 <a:latin typeface="Times New Roman"/>
               </a:rPr>
-              <a:t> MRKH-related psychosocial burden is substantial yet under-integrated into care. Psychosocial screening, psychosexual counseling, and peer support belong in MRKH care pathways.</a:t>
+              <a:t> MRKH affects far more than reproductive anatomy. Mental health screening, psychosexual counseling, and peer support should become standard in multidisciplinary MRKH care, and research must reach underrepresented regions.</a:t>
             </a:r>
           </a:p>
         </p:txBody>

</xml_diff>

<commit_message>
Poster: Results written as a results section; study counts instead of percentages; moderate-to-severe depression figure; intervention point moved to Discussion
Co-Authored-By: Claude Opus 5.5 <noreply@anthropic.com>
Claude-Session: https://claude.ai/code/session_01N468nYR7vy45HpujgUezn5
</commit_message>
<xml_diff>
--- a/poster/MRKH_APHA2026_Poster.pptx
+++ b/poster/MRKH_APHA2026_Poster.pptx
@@ -7806,355 +7806,7 @@
                 </a:solidFill>
                 <a:latin typeface="Times New Roman"/>
               </a:rPr>
-              <a:t>Key Findings:</a:t>
-            </a:r>
-            <a:r>
-              <a:rPr sz="2200" b="0" i="0">
-                <a:solidFill>
-                  <a:srgbClr val="000000"/>
-                </a:solidFill>
-                <a:latin typeface="Times New Roman"/>
-              </a:rPr>
-              <a:t> 35 studies from 2019–2026 were included (18 quantitative, 14 qualitative, 2 mixed-methods), with samples of 5 to 616 participants (Figures 1–5).</a:t>
-            </a:r>
-          </a:p>
-          <a:p>
-            <a:pPr algn="l" marL="274320" indent="-274320">
-              <a:lnSpc>
-                <a:spcPct val="100000"/>
-              </a:lnSpc>
-              <a:spcAft>
-                <a:spcPts val="400"/>
-              </a:spcAft>
-            </a:pPr>
-            <a:r>
-              <a:rPr sz="2200" b="0" i="0">
-                <a:solidFill>
-                  <a:srgbClr val="000000"/>
-                </a:solidFill>
-                <a:latin typeface="Times New Roman"/>
-              </a:rPr>
-              <a:t>• </a:t>
-            </a:r>
-            <a:r>
-              <a:rPr sz="2200" b="1" i="0">
-                <a:solidFill>
-                  <a:srgbClr val="000000"/>
-                </a:solidFill>
-                <a:latin typeface="Times New Roman"/>
-              </a:rPr>
-              <a:t>Psychosexual and relational (69%):</a:t>
-            </a:r>
-            <a:r>
-              <a:rPr sz="2200" b="0" i="0">
-                <a:solidFill>
-                  <a:srgbClr val="000000"/>
-                </a:solidFill>
-                <a:latin typeface="Times New Roman"/>
-              </a:rPr>
-              <a:t> lower sexual esteem and more negative genital self-image than controls, even after neovagina creation.</a:t>
-            </a:r>
-            <a:r>
-              <a:rPr sz="2200" b="0" i="0" baseline="30000">
-                <a:solidFill>
-                  <a:srgbClr val="000000"/>
-                </a:solidFill>
-                <a:latin typeface="Times New Roman"/>
-              </a:rPr>
-              <a:t>10,11</a:t>
-            </a:r>
-          </a:p>
-          <a:p>
-            <a:pPr algn="l" marL="274320" indent="-274320">
-              <a:lnSpc>
-                <a:spcPct val="100000"/>
-              </a:lnSpc>
-              <a:spcAft>
-                <a:spcPts val="400"/>
-              </a:spcAft>
-            </a:pPr>
-            <a:r>
-              <a:rPr sz="2200" b="0" i="0">
-                <a:solidFill>
-                  <a:srgbClr val="000000"/>
-                </a:solidFill>
-                <a:latin typeface="Times New Roman"/>
-              </a:rPr>
-              <a:t>• </a:t>
-            </a:r>
-            <a:r>
-              <a:rPr sz="2200" b="1" i="0">
-                <a:solidFill>
-                  <a:srgbClr val="000000"/>
-                </a:solidFill>
-                <a:latin typeface="Times New Roman"/>
-              </a:rPr>
-              <a:t>Psychological distress (57%):</a:t>
-            </a:r>
-            <a:r>
-              <a:rPr sz="2200" b="0" i="0">
-                <a:solidFill>
-                  <a:srgbClr val="000000"/>
-                </a:solidFill>
-                <a:latin typeface="Times New Roman"/>
-              </a:rPr>
-              <a:t> shock, grief, shame, and secrecy at diagnosis; the diagnostic process itself was described as upsetting and potentially traumatizing.</a:t>
-            </a:r>
-            <a:r>
-              <a:rPr sz="2200" b="0" i="0" baseline="30000">
-                <a:solidFill>
-                  <a:srgbClr val="000000"/>
-                </a:solidFill>
-                <a:latin typeface="Times New Roman"/>
-              </a:rPr>
-              <a:t>12</a:t>
-            </a:r>
-          </a:p>
-          <a:p>
-            <a:pPr algn="l" marL="274320" indent="-274320">
-              <a:lnSpc>
-                <a:spcPct val="100000"/>
-              </a:lnSpc>
-              <a:spcAft>
-                <a:spcPts val="400"/>
-              </a:spcAft>
-            </a:pPr>
-            <a:r>
-              <a:rPr sz="2200" b="0" i="0">
-                <a:solidFill>
-                  <a:srgbClr val="000000"/>
-                </a:solidFill>
-                <a:latin typeface="Times New Roman"/>
-              </a:rPr>
-              <a:t>• </a:t>
-            </a:r>
-            <a:r>
-              <a:rPr sz="2200" b="1" i="0">
-                <a:solidFill>
-                  <a:srgbClr val="000000"/>
-                </a:solidFill>
-                <a:latin typeface="Times New Roman"/>
-              </a:rPr>
-              <a:t>QoL, body image, and self-esteem (54%):</a:t>
-            </a:r>
-            <a:r>
-              <a:rPr sz="2200" b="0" i="0">
-                <a:solidFill>
-                  <a:srgbClr val="000000"/>
-                </a:solidFill>
-                <a:latin typeface="Times New Roman"/>
-              </a:rPr>
-              <a:t> impaired mental health–related quality of life,</a:t>
-            </a:r>
-            <a:r>
-              <a:rPr sz="2200" b="0" i="0" baseline="30000">
-                <a:solidFill>
-                  <a:srgbClr val="000000"/>
-                </a:solidFill>
-                <a:latin typeface="Times New Roman"/>
-              </a:rPr>
-              <a:t>13</a:t>
-            </a:r>
-            <a:r>
-              <a:rPr sz="2200" b="0" i="0">
-                <a:solidFill>
-                  <a:srgbClr val="000000"/>
-                </a:solidFill>
-                <a:latin typeface="Times New Roman"/>
-              </a:rPr>
-              <a:t> and higher distress with lower self-esteem than population norms.</a:t>
-            </a:r>
-            <a:r>
-              <a:rPr sz="2200" b="0" i="0" baseline="30000">
-                <a:solidFill>
-                  <a:srgbClr val="000000"/>
-                </a:solidFill>
-                <a:latin typeface="Times New Roman"/>
-              </a:rPr>
-              <a:t>14</a:t>
-            </a:r>
-          </a:p>
-          <a:p>
-            <a:pPr algn="l" marL="274320" indent="-274320">
-              <a:lnSpc>
-                <a:spcPct val="100000"/>
-              </a:lnSpc>
-              <a:spcAft>
-                <a:spcPts val="400"/>
-              </a:spcAft>
-            </a:pPr>
-            <a:r>
-              <a:rPr sz="2200" b="0" i="0">
-                <a:solidFill>
-                  <a:srgbClr val="000000"/>
-                </a:solidFill>
-                <a:latin typeface="Times New Roman"/>
-              </a:rPr>
-              <a:t>• </a:t>
-            </a:r>
-            <a:r>
-              <a:rPr sz="2200" b="1" i="0">
-                <a:solidFill>
-                  <a:srgbClr val="000000"/>
-                </a:solidFill>
-                <a:latin typeface="Times New Roman"/>
-              </a:rPr>
-              <a:t>Depression and anxiety (40%):</a:t>
-            </a:r>
-            <a:r>
-              <a:rPr sz="2200" b="0" i="0">
-                <a:solidFill>
-                  <a:srgbClr val="000000"/>
-                </a:solidFill>
-                <a:latin typeface="Times New Roman"/>
-              </a:rPr>
-              <a:t> depressive symptoms in 75.2% of 141 Chinese patients;</a:t>
-            </a:r>
-            <a:r>
-              <a:rPr sz="2200" b="0" i="0" baseline="30000">
-                <a:solidFill>
-                  <a:srgbClr val="000000"/>
-                </a:solidFill>
-                <a:latin typeface="Times New Roman"/>
-              </a:rPr>
-              <a:t>15</a:t>
-            </a:r>
-            <a:r>
-              <a:rPr sz="2200" b="0" i="0">
-                <a:solidFill>
-                  <a:srgbClr val="000000"/>
-                </a:solidFill>
-                <a:latin typeface="Times New Roman"/>
-              </a:rPr>
-              <a:t> anxiety in 37.7% and depression in 32.5% of 77 Malaysian women.</a:t>
-            </a:r>
-            <a:r>
-              <a:rPr sz="2200" b="0" i="0" baseline="30000">
-                <a:solidFill>
-                  <a:srgbClr val="000000"/>
-                </a:solidFill>
-                <a:latin typeface="Times New Roman"/>
-              </a:rPr>
-              <a:t>16</a:t>
-            </a:r>
-            <a:r>
-              <a:rPr sz="2200" b="0" i="0">
-                <a:solidFill>
-                  <a:srgbClr val="000000"/>
-                </a:solidFill>
-                <a:latin typeface="Times New Roman"/>
-              </a:rPr>
-              <a:t> Findings were mixed: uterus transplant candidates in France showed few symptoms.</a:t>
-            </a:r>
-            <a:r>
-              <a:rPr sz="2200" b="0" i="0" baseline="30000">
-                <a:solidFill>
-                  <a:srgbClr val="000000"/>
-                </a:solidFill>
-                <a:latin typeface="Times New Roman"/>
-              </a:rPr>
-              <a:t>17</a:t>
-            </a:r>
-          </a:p>
-          <a:p>
-            <a:pPr algn="l" marL="274320" indent="-274320">
-              <a:lnSpc>
-                <a:spcPct val="100000"/>
-              </a:lnSpc>
-              <a:spcAft>
-                <a:spcPts val="400"/>
-              </a:spcAft>
-            </a:pPr>
-            <a:r>
-              <a:rPr sz="2200" b="0" i="0">
-                <a:solidFill>
-                  <a:srgbClr val="000000"/>
-                </a:solidFill>
-                <a:latin typeface="Times New Roman"/>
-              </a:rPr>
-              <a:t>• </a:t>
-            </a:r>
-            <a:r>
-              <a:rPr sz="2200" b="1" i="0">
-                <a:solidFill>
-                  <a:srgbClr val="000000"/>
-                </a:solidFill>
-                <a:latin typeface="Times New Roman"/>
-              </a:rPr>
-              <a:t>Coping (43%):</a:t>
-            </a:r>
-            <a:r>
-              <a:rPr sz="2200" b="0" i="0">
-                <a:solidFill>
-                  <a:srgbClr val="000000"/>
-                </a:solidFill>
-                <a:latin typeface="Times New Roman"/>
-              </a:rPr>
-              <a:t> peer and online support most common; avoidance and concealment also frequent, and one study traced a shift from avoidance to empowerment.</a:t>
-            </a:r>
-            <a:r>
-              <a:rPr sz="2200" b="0" i="0" baseline="30000">
-                <a:solidFill>
-                  <a:srgbClr val="000000"/>
-                </a:solidFill>
-                <a:latin typeface="Times New Roman"/>
-              </a:rPr>
-              <a:t>18</a:t>
-            </a:r>
-            <a:r>
-              <a:rPr sz="2200" b="0" i="0">
-                <a:solidFill>
-                  <a:srgbClr val="000000"/>
-                </a:solidFill>
-                <a:latin typeface="Times New Roman"/>
-              </a:rPr>
-              <a:t> Only 2 intervention studies were found, both reporting benefit.</a:t>
-            </a:r>
-            <a:r>
-              <a:rPr sz="2200" b="0" i="0" baseline="30000">
-                <a:solidFill>
-                  <a:srgbClr val="000000"/>
-                </a:solidFill>
-                <a:latin typeface="Times New Roman"/>
-              </a:rPr>
-              <a:t>19,20</a:t>
-            </a:r>
-          </a:p>
-          <a:p>
-            <a:pPr algn="l" marL="274320" indent="-274320">
-              <a:lnSpc>
-                <a:spcPct val="100000"/>
-              </a:lnSpc>
-              <a:spcAft>
-                <a:spcPts val="400"/>
-              </a:spcAft>
-            </a:pPr>
-            <a:r>
-              <a:rPr sz="2200" b="0" i="0">
-                <a:solidFill>
-                  <a:srgbClr val="000000"/>
-                </a:solidFill>
-                <a:latin typeface="Times New Roman"/>
-              </a:rPr>
-              <a:t>• </a:t>
-            </a:r>
-            <a:r>
-              <a:rPr sz="2200" b="1" i="0">
-                <a:solidFill>
-                  <a:srgbClr val="000000"/>
-                </a:solidFill>
-                <a:latin typeface="Times New Roman"/>
-              </a:rPr>
-              <a:t>Healthcare gaps (29%):</a:t>
-            </a:r>
-            <a:r>
-              <a:rPr sz="2200" b="0" i="0">
-                <a:solidFill>
-                  <a:srgbClr val="000000"/>
-                </a:solidFill>
-                <a:latin typeface="Times New Roman"/>
-              </a:rPr>
-              <a:t> delayed diagnosis, providers unfamiliar with MRKH, and patients forced to self-advocate.</a:t>
+              <a:t>Results</a:t>
             </a:r>
           </a:p>
           <a:p>
@@ -8167,13 +7819,13 @@
               </a:spcAft>
             </a:pPr>
             <a:r>
-              <a:rPr sz="2200" b="1" i="0">
+              <a:rPr sz="2200" b="0" i="0">
                 <a:solidFill>
                   <a:srgbClr val="000000"/>
                 </a:solidFill>
                 <a:latin typeface="Times New Roman"/>
               </a:rPr>
-              <a:t>Discussion</a:t>
+              <a:t>Of 516 records, 35 studies (2019–2026; 5 to 616 participants) met inclusion criteria: 18 quantitative, 14 qualitative, and 2 mixed-methods (Figures 1–2).</a:t>
             </a:r>
           </a:p>
           <a:p>
@@ -8192,7 +7844,7 @@
                 </a:solidFill>
                 <a:latin typeface="Times New Roman"/>
               </a:rPr>
-              <a:t>Findings echo earlier evidence of distress and reduced quality of life in MRKH</a:t>
+              <a:t>Psychosexual and relational challenges were the most frequently reported outcome (24 of 35 studies), including lower sexual esteem and more negative genital self-image than controls.</a:t>
             </a:r>
             <a:r>
               <a:rPr sz="2200" b="0" i="0" baseline="30000">
@@ -8201,7 +7853,7 @@
                 </a:solidFill>
                 <a:latin typeface="Times New Roman"/>
               </a:rPr>
-              <a:t>3,5</a:t>
+              <a:t>10,11</a:t>
             </a:r>
             <a:r>
               <a:rPr sz="2200" b="0" i="0">
@@ -8210,7 +7862,88 @@
                 </a:solidFill>
                 <a:latin typeface="Times New Roman"/>
               </a:rPr>
-              <a:t> and extend prior reviews by mapping coping and health-system gaps. Psychosexual concerns dominate the recent literature, whereas depression and anxiety were measured in fewer than half of studies. Evidence is concentrated in Europe (14) and Asia (14); 1 study came from Africa and none from South America, where expectations about fertility and marriage may shape experiences differently.</a:t>
+              <a:t> Psychological distress was reported in 20 studies, with shock, shame, and secrecy at diagnosis and a diagnostic process described as potentially traumatizing.</a:t>
+            </a:r>
+            <a:r>
+              <a:rPr sz="2200" b="0" i="0" baseline="30000">
+                <a:solidFill>
+                  <a:srgbClr val="000000"/>
+                </a:solidFill>
+                <a:latin typeface="Times New Roman"/>
+              </a:rPr>
+              <a:t>12</a:t>
+            </a:r>
+            <a:r>
+              <a:rPr sz="2200" b="0" i="0">
+                <a:solidFill>
+                  <a:srgbClr val="000000"/>
+                </a:solidFill>
+                <a:latin typeface="Times New Roman"/>
+              </a:rPr>
+              <a:t> Quality of life, body image, and self-esteem were reported in 19, including lower self-esteem than population norms.</a:t>
+            </a:r>
+            <a:r>
+              <a:rPr sz="2200" b="0" i="0" baseline="30000">
+                <a:solidFill>
+                  <a:srgbClr val="000000"/>
+                </a:solidFill>
+                <a:latin typeface="Times New Roman"/>
+              </a:rPr>
+              <a:t>13</a:t>
+            </a:r>
+            <a:r>
+              <a:rPr sz="2200" b="0" i="0">
+                <a:solidFill>
+                  <a:srgbClr val="000000"/>
+                </a:solidFill>
+                <a:latin typeface="Times New Roman"/>
+              </a:rPr>
+              <a:t> Depression and anxiety were assessed least often (14 studies), with mixed results: moderate-to-severe depressive symptoms in 34.0% of 141 Chinese patients</a:t>
+            </a:r>
+            <a:r>
+              <a:rPr sz="2200" b="0" i="0" baseline="30000">
+                <a:solidFill>
+                  <a:srgbClr val="000000"/>
+                </a:solidFill>
+                <a:latin typeface="Times New Roman"/>
+              </a:rPr>
+              <a:t>14</a:t>
+            </a:r>
+            <a:r>
+              <a:rPr sz="2200" b="0" i="0">
+                <a:solidFill>
+                  <a:srgbClr val="000000"/>
+                </a:solidFill>
+                <a:latin typeface="Times New Roman"/>
+              </a:rPr>
+              <a:t> and anxiety in 37.7% of 77 Malaysian women,</a:t>
+            </a:r>
+            <a:r>
+              <a:rPr sz="2200" b="0" i="0" baseline="30000">
+                <a:solidFill>
+                  <a:srgbClr val="000000"/>
+                </a:solidFill>
+                <a:latin typeface="Times New Roman"/>
+              </a:rPr>
+              <a:t>15</a:t>
+            </a:r>
+            <a:r>
+              <a:rPr sz="2200" b="0" i="0">
+                <a:solidFill>
+                  <a:srgbClr val="000000"/>
+                </a:solidFill>
+                <a:latin typeface="Times New Roman"/>
+              </a:rPr>
+              <a:t> but few symptoms among French uterus transplant candidates.</a:t>
+            </a:r>
+            <a:r>
+              <a:rPr sz="2200" b="0" i="0" baseline="30000">
+                <a:solidFill>
+                  <a:srgbClr val="000000"/>
+                </a:solidFill>
+                <a:latin typeface="Times New Roman"/>
+              </a:rPr>
+              <a:t>16</a:t>
             </a:r>
           </a:p>
           <a:p>
@@ -8223,13 +7956,13 @@
               </a:spcAft>
             </a:pPr>
             <a:r>
-              <a:rPr sz="2200" b="1" i="0">
+              <a:rPr sz="2200" b="0" i="0">
                 <a:solidFill>
                   <a:srgbClr val="000000"/>
                 </a:solidFill>
                 <a:latin typeface="Times New Roman"/>
               </a:rPr>
-              <a:t>Conclusion</a:t>
+              <a:t>Coping was documented in 15 studies, most often peer and online support (7) and avoidance or concealment (6) (Figure 4). Healthcare system gaps, reported in 10 studies, included delayed diagnosis, providers unfamiliar with MRKH, and patients having to advocate for themselves (Figure 3).</a:t>
             </a:r>
           </a:p>
           <a:p>
@@ -8242,13 +7975,13 @@
               </a:spcAft>
             </a:pPr>
             <a:r>
-              <a:rPr sz="2200" b="0" i="0">
+              <a:rPr sz="2200" b="1" i="0">
                 <a:solidFill>
                   <a:srgbClr val="000000"/>
                 </a:solidFill>
                 <a:latin typeface="Times New Roman"/>
               </a:rPr>
-              <a:t>MRKH affects far more than reproductive anatomy. Psychosexual difficulties, emotional distress, and low self-esteem were widely reported, yet depression and anxiety were measured in fewer than half of studies, and coping relied mostly on peers or concealment rather than structured care. Mental health screening, psychosexual counseling, and peer support should become standard in multidisciplinary MRKH care, not an afterthought, and research must reach underrepresented regions.</a:t>
+              <a:t>Discussion</a:t>
             </a:r>
           </a:p>
           <a:p>
@@ -8261,22 +7994,125 @@
               </a:spcAft>
             </a:pPr>
             <a:r>
-              <a:rPr sz="2200" b="1" i="0">
+              <a:rPr sz="2200" b="0" i="0">
                 <a:solidFill>
                   <a:srgbClr val="000000"/>
                 </a:solidFill>
                 <a:latin typeface="Times New Roman"/>
               </a:rPr>
-              <a:t>Limitations:</a:t>
-            </a:r>
-            <a:r>
-              <a:rPr sz="2200" b="0" i="0">
+              <a:t>Findings echo earlier evidence of distress and reduced quality of life in MRKH</a:t>
+            </a:r>
+            <a:r>
+              <a:rPr sz="2200" b="0" i="0" baseline="30000">
                 <a:solidFill>
                   <a:srgbClr val="000000"/>
                 </a:solidFill>
                 <a:latin typeface="Times New Roman"/>
               </a:rPr>
-              <a:t> English-language database literature from 2019–2026 only, without grey literature; many small, single-center samples; heterogeneous designs and measures; possible overlapping samples; 5 studies assessed from abstracts only; no quality appraisal, and counts show how often outcomes were studied, not their prevalence.</a:t>
+              <a:t>3,5</a:t>
+            </a:r>
+            <a:r>
+              <a:rPr sz="2200" b="0" i="0">
+                <a:solidFill>
+                  <a:srgbClr val="000000"/>
+                </a:solidFill>
+                <a:latin typeface="Times New Roman"/>
+              </a:rPr>
+              <a:t> and extend prior reviews by mapping coping and health-system gaps. Psychosexual concerns dominate the recent literature, whereas depression and anxiety were measured in fewer than half of studies. Only 2 studies tested psychosocial interventions, and both reported benefit.</a:t>
+            </a:r>
+            <a:r>
+              <a:rPr sz="2200" b="0" i="0" baseline="30000">
+                <a:solidFill>
+                  <a:srgbClr val="000000"/>
+                </a:solidFill>
+                <a:latin typeface="Times New Roman"/>
+              </a:rPr>
+              <a:t>17,18</a:t>
+            </a:r>
+            <a:r>
+              <a:rPr sz="2200" b="0" i="0">
+                <a:solidFill>
+                  <a:srgbClr val="000000"/>
+                </a:solidFill>
+                <a:latin typeface="Times New Roman"/>
+              </a:rPr>
+              <a:t> Evidence is concentrated in Europe (14) and Asia (14); 1 study came from Africa and none from South America, where expectations about fertility and marriage may shape experiences differently.</a:t>
+            </a:r>
+          </a:p>
+          <a:p>
+            <a:pPr algn="just">
+              <a:lnSpc>
+                <a:spcPct val="100000"/>
+              </a:lnSpc>
+              <a:spcAft>
+                <a:spcPts val="400"/>
+              </a:spcAft>
+            </a:pPr>
+            <a:r>
+              <a:rPr sz="2200" b="1" i="0">
+                <a:solidFill>
+                  <a:srgbClr val="000000"/>
+                </a:solidFill>
+                <a:latin typeface="Times New Roman"/>
+              </a:rPr>
+              <a:t>Conclusion</a:t>
+            </a:r>
+          </a:p>
+          <a:p>
+            <a:pPr algn="just">
+              <a:lnSpc>
+                <a:spcPct val="100000"/>
+              </a:lnSpc>
+              <a:spcAft>
+                <a:spcPts val="400"/>
+              </a:spcAft>
+            </a:pPr>
+            <a:r>
+              <a:rPr sz="2200" b="0" i="0">
+                <a:solidFill>
+                  <a:srgbClr val="000000"/>
+                </a:solidFill>
+                <a:latin typeface="Times New Roman"/>
+              </a:rPr>
+              <a:t>MRKH affects far more than reproductive anatomy. Psychosexual difficulties, emotional distress, and low self-esteem were widely reported, yet depression and anxiety were measured in fewer than half of studies, and coping relied mostly on peers or concealment rather than structured care. Mental health screening, psychosexual counseling, and peer support should become standard in multidisciplinary MRKH care, not an afterthought, and research must reach underrepresented regions.</a:t>
+            </a:r>
+          </a:p>
+          <a:p>
+            <a:pPr algn="just">
+              <a:lnSpc>
+                <a:spcPct val="100000"/>
+              </a:lnSpc>
+              <a:spcAft>
+                <a:spcPts val="400"/>
+              </a:spcAft>
+            </a:pPr>
+            <a:r>
+              <a:rPr sz="2200" b="1" i="0">
+                <a:solidFill>
+                  <a:srgbClr val="000000"/>
+                </a:solidFill>
+                <a:latin typeface="Times New Roman"/>
+              </a:rPr>
+              <a:t>Limitations</a:t>
+            </a:r>
+          </a:p>
+          <a:p>
+            <a:pPr algn="just">
+              <a:lnSpc>
+                <a:spcPct val="100000"/>
+              </a:lnSpc>
+              <a:spcAft>
+                <a:spcPts val="400"/>
+              </a:spcAft>
+            </a:pPr>
+            <a:r>
+              <a:rPr sz="2200" b="0" i="0">
+                <a:solidFill>
+                  <a:srgbClr val="000000"/>
+                </a:solidFill>
+                <a:latin typeface="Times New Roman"/>
+              </a:rPr>
+              <a:t>English-language database literature from 2019–2026 only, without grey literature; many small, single-center samples; heterogeneous designs and measures; possible overlapping samples; 5 studies assessed from abstracts only; no quality appraisal, and counts show how often outcomes were studied, not their prevalence.</a:t>
             </a:r>
           </a:p>
         </p:txBody>

</xml_diff>

<commit_message>
Poster: limitations as bullet points
Co-Authored-By: Claude Opus 5.5 <noreply@anthropic.com>
Claude-Session: https://claude.ai/code/session_01N468nYR7vy45HpujgUezn5
</commit_message>
<xml_diff>
--- a/poster/MRKH_APHA2026_Poster.pptx
+++ b/poster/MRKH_APHA2026_Poster.pptx
@@ -8097,7 +8097,7 @@
             </a:r>
           </a:p>
           <a:p>
-            <a:pPr algn="just">
+            <a:pPr algn="l" marL="274320" indent="-274320">
               <a:lnSpc>
                 <a:spcPct val="100000"/>
               </a:lnSpc>
@@ -8112,7 +8112,64 @@
                 </a:solidFill>
                 <a:latin typeface="Times New Roman"/>
               </a:rPr>
-              <a:t>English-language database literature from 2019–2026 only, without grey literature; many small, single-center samples; heterogeneous designs and measures; possible overlapping samples; 5 studies assessed from abstracts only; no quality appraisal, and counts show how often outcomes were studied, not their prevalence.</a:t>
+              <a:t>• English-language database literature from 2019–2026 only; no grey literature</a:t>
+            </a:r>
+          </a:p>
+          <a:p>
+            <a:pPr algn="l" marL="274320" indent="-274320">
+              <a:lnSpc>
+                <a:spcPct val="100000"/>
+              </a:lnSpc>
+              <a:spcAft>
+                <a:spcPts val="400"/>
+              </a:spcAft>
+            </a:pPr>
+            <a:r>
+              <a:rPr sz="2200" b="0" i="0">
+                <a:solidFill>
+                  <a:srgbClr val="000000"/>
+                </a:solidFill>
+                <a:latin typeface="Times New Roman"/>
+              </a:rPr>
+              <a:t>• Many small, single-center samples; heterogeneous designs and measures</a:t>
+            </a:r>
+          </a:p>
+          <a:p>
+            <a:pPr algn="l" marL="274320" indent="-274320">
+              <a:lnSpc>
+                <a:spcPct val="100000"/>
+              </a:lnSpc>
+              <a:spcAft>
+                <a:spcPts val="400"/>
+              </a:spcAft>
+            </a:pPr>
+            <a:r>
+              <a:rPr sz="2200" b="0" i="0">
+                <a:solidFill>
+                  <a:srgbClr val="000000"/>
+                </a:solidFill>
+                <a:latin typeface="Times New Roman"/>
+              </a:rPr>
+              <a:t>• Possible overlapping samples; 5 studies assessed from abstracts only</a:t>
+            </a:r>
+          </a:p>
+          <a:p>
+            <a:pPr algn="l" marL="274320" indent="-274320">
+              <a:lnSpc>
+                <a:spcPct val="100000"/>
+              </a:lnSpc>
+              <a:spcAft>
+                <a:spcPts val="400"/>
+              </a:spcAft>
+            </a:pPr>
+            <a:r>
+              <a:rPr sz="2200" b="0" i="0">
+                <a:solidFill>
+                  <a:srgbClr val="000000"/>
+                </a:solidFill>
+                <a:latin typeface="Times New Roman"/>
+              </a:rPr>
+              <a:t>• No quality appraisal; counts show how often outcomes were studied, not prevalence</a:t>
             </a:r>
           </a:p>
         </p:txBody>

</xml_diff>

<commit_message>
AMA: citation before semicolon on poster; accent-insensitive alphabetical order in full reference list
Co-Authored-By: Claude Opus 5.5 <noreply@anthropic.com>
Claude-Session: https://claude.ai/code/session_01N468nYR7vy45HpujgUezn5
</commit_message>
<xml_diff>
--- a/poster/MRKH_APHA2026_Poster.pptx
+++ b/poster/MRKH_APHA2026_Poster.pptx
@@ -7047,7 +7047,7 @@
                 </a:solidFill>
                 <a:latin typeface="Times New Roman"/>
               </a:rPr>
-              <a:t> Prior reviews focused on psychological and sexual outcomes;</a:t>
+              <a:t> Prior reviews focused on psychological and sexual outcomes</a:t>
             </a:r>
             <a:r>
               <a:rPr sz="2200" b="0" i="0" baseline="30000">
@@ -7065,7 +7065,7 @@
                 </a:solidFill>
                 <a:latin typeface="Times New Roman"/>
               </a:rPr>
-              <a:t> coping and healthcare system gaps have not been mapped across the growing recent literature. Mapping this evidence can guide psychosocial care, provider training, and research priorities.</a:t>
+              <a:t>; coping and healthcare system gaps have not been mapped across the growing recent literature. Mapping this evidence can guide psychosocial care, provider training, and research priorities.</a:t>
             </a:r>
           </a:p>
           <a:p>

</xml_diff>

<commit_message>
Generated poster: figure 3 and 5 references in Results; trimmed Discussion and last limitation to fit
Co-Authored-By: Claude Opus 5.5 <noreply@anthropic.com>
Claude-Session: https://claude.ai/code/session_01N468nYR7vy45HpujgUezn5
</commit_message>
<xml_diff>
--- a/poster/MRKH_APHA2026_Poster.pptx
+++ b/poster/MRKH_APHA2026_Poster.pptx
@@ -7825,7 +7825,7 @@
                 </a:solidFill>
                 <a:latin typeface="Times New Roman"/>
               </a:rPr>
-              <a:t>Of 516 records, 35 studies (2019–2026; 5 to 616 participants) met inclusion criteria: 18 quantitative, 14 qualitative, 2 mixed-methods, and 1 not reported (Figures 1–2).</a:t>
+              <a:t>Of 516 records, 35 studies (2019–2026; 5 to 616 participants) met inclusion criteria: 18 quantitative, 14 qualitative, 2 mixed-methods, and 1 not reported (Figures 1–2). Studies came from Europe (14), Asia (14), North America (3), Africa (1), and Oceania (1); 2 were multinational and none came from South America (Figure 5).</a:t>
             </a:r>
           </a:p>
           <a:p>
@@ -7844,7 +7844,7 @@
                 </a:solidFill>
                 <a:latin typeface="Times New Roman"/>
               </a:rPr>
-              <a:t>Psychosexual and relational challenges were the most frequently reported outcome (24 of 35 studies), including lower sexual esteem and more negative genital self-image than controls.</a:t>
+              <a:t>Psychosexual and relational challenges were the most frequently reported outcome (24 of 35 studies; Figure 3), including lower sexual esteem and more negative genital self-image than controls.</a:t>
             </a:r>
             <a:r>
               <a:rPr sz="2200" b="0" i="0" baseline="30000">
@@ -7962,7 +7962,7 @@
                 </a:solidFill>
                 <a:latin typeface="Times New Roman"/>
               </a:rPr>
-              <a:t>Coping was documented in 15 studies, most often peer and online support (7) and avoidance or concealment (6) (Figure 4). Healthcare system gaps, reported in 10 studies, included delayed diagnosis, providers unfamiliar with MRKH, and patients having to advocate for themselves (Figure 3).</a:t>
+              <a:t>Coping was documented in 15 studies (Figure 4), most often peer and online support (7) and avoidance or concealment (6). Healthcare system gaps, reported in 10 studies, included delayed diagnosis, providers unfamiliar with MRKH, and patients having to advocate for themselves.</a:t>
             </a:r>
           </a:p>
           <a:p>
@@ -8018,7 +8018,7 @@
                 </a:solidFill>
                 <a:latin typeface="Times New Roman"/>
               </a:rPr>
-              <a:t> and extend prior reviews by mapping coping and health-system gaps. Psychosexual concerns dominate the recent literature, whereas depression and anxiety were measured in fewer than half of studies. Only 2 studies tested psychosocial interventions, and both reported benefit.</a:t>
+              <a:t> and extend prior reviews by mapping coping and health-system gaps. Psychosexual concerns dominate the recent literature, whereas depression and anxiety were measured in fewer than half of studies. Only 2 studies tested interventions, both reporting benefit.</a:t>
             </a:r>
             <a:r>
               <a:rPr sz="2200" b="0" i="0" baseline="30000">
@@ -8036,7 +8036,7 @@
                 </a:solidFill>
                 <a:latin typeface="Times New Roman"/>
               </a:rPr>
-              <a:t> Evidence is concentrated in Europe (14) and Asia (14); 1 study came from Africa and none from South America, where expectations about fertility and marriage may shape experiences differently.</a:t>
+              <a:t> Evidence is concentrated in Europe and Asia, with little from Africa and none from South America, where expectations about fertility and marriage may shape experiences differently.</a:t>
             </a:r>
           </a:p>
           <a:p>
@@ -8169,7 +8169,7 @@
                 </a:solidFill>
                 <a:latin typeface="Times New Roman"/>
               </a:rPr>
-              <a:t>• No quality appraisal; counts show how often outcomes were studied, not prevalence</a:t>
+              <a:t>• No quality appraisal; counts reflect how often outcomes were studied</a:t>
             </a:r>
           </a:p>
         </p:txBody>

</xml_diff>